<commit_message>
feat: add all requirements in pptx
</commit_message>
<xml_diff>
--- a/NetworkScience_Presentation.pptx
+++ b/NetworkScience_Presentation.pptx
@@ -12,8 +12,15 @@
     <p:sldId id="260" r:id="rId6"/>
     <p:sldId id="261" r:id="rId7"/>
     <p:sldId id="262" r:id="rId8"/>
+    <p:sldId id="263" r:id="rId9"/>
+    <p:sldId id="264" r:id="rId10"/>
+    <p:sldId id="265" r:id="rId11"/>
+    <p:sldId id="266" r:id="rId12"/>
+    <p:sldId id="267" r:id="rId13"/>
+    <p:sldId id="268" r:id="rId14"/>
+    <p:sldId id="269" r:id="rId15"/>
   </p:sldIdLst>
-  <p:sldSz cx="9144000" cy="6858000" type="screen4x3"/>
+  <p:sldSz cx="12192000" cy="6858000"/>
   <p:notesSz cx="6858000" cy="9144000"/>
   <p:defaultTextStyle>
     <a:defPPr>
@@ -113,12 +120,12 @@
   <p:extLst>
     <p:ext uri="{EFAFB233-063F-42B5-8137-9DF3F51BA10A}">
       <p15:sldGuideLst xmlns:p15="http://schemas.microsoft.com/office/powerpoint/2012/main">
-        <p15:guide id="1" orient="horz" pos="2160">
+        <p15:guide id="1" orient="horz" pos="2160" userDrawn="1">
           <p15:clr>
             <a:srgbClr val="A4A3A4"/>
           </p15:clr>
         </p15:guide>
-        <p15:guide id="2" pos="2880">
+        <p15:guide id="2" pos="3840" userDrawn="1">
           <p15:clr>
             <a:srgbClr val="A4A3A4"/>
           </p15:clr>
@@ -158,8 +165,8 @@
         </p:nvSpPr>
         <p:spPr>
           <a:xfrm>
-            <a:off x="685800" y="2130425"/>
-            <a:ext cx="7772400" cy="1470025"/>
+            <a:off x="914400" y="2130426"/>
+            <a:ext cx="10363200" cy="1470025"/>
           </a:xfrm>
         </p:spPr>
         <p:txBody>
@@ -185,8 +192,8 @@
         </p:nvSpPr>
         <p:spPr>
           <a:xfrm>
-            <a:off x="1371600" y="3886200"/>
-            <a:ext cx="6400800" cy="1752600"/>
+            <a:off x="1828800" y="3886200"/>
+            <a:ext cx="8534400" cy="1752600"/>
           </a:xfrm>
         </p:spPr>
         <p:txBody>
@@ -308,9 +315,9 @@
           <a:p>
             <a:fld id="{5BCAD085-E8A6-8845-BD4E-CB4CCA059FC4}" type="datetimeFigureOut">
               <a:rPr lang="en-US" smtClean="0"/>
-              <a:t>4/4/26</a:t>
+              <a:t>04/09/2026</a:t>
             </a:fld>
-            <a:endParaRPr lang="en-US"/>
+            <a:endParaRPr lang="en-US" dirty="0"/>
           </a:p>
         </p:txBody>
       </p:sp>
@@ -329,7 +336,7 @@
           <a:bodyPr/>
           <a:lstStyle/>
           <a:p>
-            <a:endParaRPr lang="en-US"/>
+            <a:endParaRPr lang="en-US" dirty="0"/>
           </a:p>
         </p:txBody>
       </p:sp>
@@ -352,7 +359,7 @@
               <a:rPr lang="en-US" smtClean="0"/>
               <a:t>‹#›</a:t>
             </a:fld>
-            <a:endParaRPr lang="en-US"/>
+            <a:endParaRPr lang="en-US" dirty="0"/>
           </a:p>
         </p:txBody>
       </p:sp>
@@ -476,9 +483,9 @@
           <a:p>
             <a:fld id="{5BCAD085-E8A6-8845-BD4E-CB4CCA059FC4}" type="datetimeFigureOut">
               <a:rPr lang="en-US" smtClean="0"/>
-              <a:t>4/4/26</a:t>
+              <a:t>04/09/2026</a:t>
             </a:fld>
-            <a:endParaRPr lang="en-US"/>
+            <a:endParaRPr lang="en-US" dirty="0"/>
           </a:p>
         </p:txBody>
       </p:sp>
@@ -497,7 +504,7 @@
           <a:bodyPr/>
           <a:lstStyle/>
           <a:p>
-            <a:endParaRPr lang="en-US"/>
+            <a:endParaRPr lang="en-US" dirty="0"/>
           </a:p>
         </p:txBody>
       </p:sp>
@@ -520,7 +527,7 @@
               <a:rPr lang="en-US" smtClean="0"/>
               <a:t>‹#›</a:t>
             </a:fld>
-            <a:endParaRPr lang="en-US"/>
+            <a:endParaRPr lang="en-US" dirty="0"/>
           </a:p>
         </p:txBody>
       </p:sp>
@@ -566,8 +573,8 @@
         </p:nvSpPr>
         <p:spPr>
           <a:xfrm>
-            <a:off x="6629400" y="274638"/>
-            <a:ext cx="2057400" cy="5851525"/>
+            <a:off x="8839200" y="274639"/>
+            <a:ext cx="2743200" cy="5851525"/>
           </a:xfrm>
         </p:spPr>
         <p:txBody>
@@ -593,8 +600,8 @@
         </p:nvSpPr>
         <p:spPr>
           <a:xfrm>
-            <a:off x="457200" y="274638"/>
-            <a:ext cx="6019800" cy="5851525"/>
+            <a:off x="609600" y="274639"/>
+            <a:ext cx="8026400" cy="5851525"/>
           </a:xfrm>
         </p:spPr>
         <p:txBody>
@@ -654,9 +661,9 @@
           <a:p>
             <a:fld id="{5BCAD085-E8A6-8845-BD4E-CB4CCA059FC4}" type="datetimeFigureOut">
               <a:rPr lang="en-US" smtClean="0"/>
-              <a:t>4/4/26</a:t>
+              <a:t>04/09/2026</a:t>
             </a:fld>
-            <a:endParaRPr lang="en-US"/>
+            <a:endParaRPr lang="en-US" dirty="0"/>
           </a:p>
         </p:txBody>
       </p:sp>
@@ -675,7 +682,7 @@
           <a:bodyPr/>
           <a:lstStyle/>
           <a:p>
-            <a:endParaRPr lang="en-US"/>
+            <a:endParaRPr lang="en-US" dirty="0"/>
           </a:p>
         </p:txBody>
       </p:sp>
@@ -698,7 +705,7 @@
               <a:rPr lang="en-US" smtClean="0"/>
               <a:t>‹#›</a:t>
             </a:fld>
-            <a:endParaRPr lang="en-US"/>
+            <a:endParaRPr lang="en-US" dirty="0"/>
           </a:p>
         </p:txBody>
       </p:sp>
@@ -822,9 +829,9 @@
           <a:p>
             <a:fld id="{5BCAD085-E8A6-8845-BD4E-CB4CCA059FC4}" type="datetimeFigureOut">
               <a:rPr lang="en-US" smtClean="0"/>
-              <a:t>4/4/26</a:t>
+              <a:t>04/09/2026</a:t>
             </a:fld>
-            <a:endParaRPr lang="en-US"/>
+            <a:endParaRPr lang="en-US" dirty="0"/>
           </a:p>
         </p:txBody>
       </p:sp>
@@ -843,7 +850,7 @@
           <a:bodyPr/>
           <a:lstStyle/>
           <a:p>
-            <a:endParaRPr lang="en-US"/>
+            <a:endParaRPr lang="en-US" dirty="0"/>
           </a:p>
         </p:txBody>
       </p:sp>
@@ -866,7 +873,7 @@
               <a:rPr lang="en-US" smtClean="0"/>
               <a:t>‹#›</a:t>
             </a:fld>
-            <a:endParaRPr lang="en-US"/>
+            <a:endParaRPr lang="en-US" dirty="0"/>
           </a:p>
         </p:txBody>
       </p:sp>
@@ -912,8 +919,8 @@
         </p:nvSpPr>
         <p:spPr>
           <a:xfrm>
-            <a:off x="722313" y="4406900"/>
-            <a:ext cx="7772400" cy="1362075"/>
+            <a:off x="963084" y="4406901"/>
+            <a:ext cx="10363200" cy="1362075"/>
           </a:xfrm>
         </p:spPr>
         <p:txBody>
@@ -943,8 +950,8 @@
         </p:nvSpPr>
         <p:spPr>
           <a:xfrm>
-            <a:off x="722313" y="2906713"/>
-            <a:ext cx="7772400" cy="1500187"/>
+            <a:off x="963084" y="2906713"/>
+            <a:ext cx="10363200" cy="1500187"/>
           </a:xfrm>
         </p:spPr>
         <p:txBody>
@@ -1067,9 +1074,9 @@
           <a:p>
             <a:fld id="{5BCAD085-E8A6-8845-BD4E-CB4CCA059FC4}" type="datetimeFigureOut">
               <a:rPr lang="en-US" smtClean="0"/>
-              <a:t>4/4/26</a:t>
+              <a:t>04/09/2026</a:t>
             </a:fld>
-            <a:endParaRPr lang="en-US"/>
+            <a:endParaRPr lang="en-US" dirty="0"/>
           </a:p>
         </p:txBody>
       </p:sp>
@@ -1088,7 +1095,7 @@
           <a:bodyPr/>
           <a:lstStyle/>
           <a:p>
-            <a:endParaRPr lang="en-US"/>
+            <a:endParaRPr lang="en-US" dirty="0"/>
           </a:p>
         </p:txBody>
       </p:sp>
@@ -1111,7 +1118,7 @@
               <a:rPr lang="en-US" smtClean="0"/>
               <a:t>‹#›</a:t>
             </a:fld>
-            <a:endParaRPr lang="en-US"/>
+            <a:endParaRPr lang="en-US" dirty="0"/>
           </a:p>
         </p:txBody>
       </p:sp>
@@ -1179,8 +1186,8 @@
         </p:nvSpPr>
         <p:spPr>
           <a:xfrm>
-            <a:off x="457200" y="1600200"/>
-            <a:ext cx="4038600" cy="4525963"/>
+            <a:off x="609600" y="1600201"/>
+            <a:ext cx="5384800" cy="4525963"/>
           </a:xfrm>
         </p:spPr>
         <p:txBody>
@@ -1263,8 +1270,8 @@
         </p:nvSpPr>
         <p:spPr>
           <a:xfrm>
-            <a:off x="4648200" y="1600200"/>
-            <a:ext cx="4038600" cy="4525963"/>
+            <a:off x="6197600" y="1600201"/>
+            <a:ext cx="5384800" cy="4525963"/>
           </a:xfrm>
         </p:spPr>
         <p:txBody>
@@ -1352,9 +1359,9 @@
           <a:p>
             <a:fld id="{5BCAD085-E8A6-8845-BD4E-CB4CCA059FC4}" type="datetimeFigureOut">
               <a:rPr lang="en-US" smtClean="0"/>
-              <a:t>4/4/26</a:t>
+              <a:t>04/09/2026</a:t>
             </a:fld>
-            <a:endParaRPr lang="en-US"/>
+            <a:endParaRPr lang="en-US" dirty="0"/>
           </a:p>
         </p:txBody>
       </p:sp>
@@ -1373,7 +1380,7 @@
           <a:bodyPr/>
           <a:lstStyle/>
           <a:p>
-            <a:endParaRPr lang="en-US"/>
+            <a:endParaRPr lang="en-US" dirty="0"/>
           </a:p>
         </p:txBody>
       </p:sp>
@@ -1396,7 +1403,7 @@
               <a:rPr lang="en-US" smtClean="0"/>
               <a:t>‹#›</a:t>
             </a:fld>
-            <a:endParaRPr lang="en-US"/>
+            <a:endParaRPr lang="en-US" dirty="0"/>
           </a:p>
         </p:txBody>
       </p:sp>
@@ -1468,8 +1475,8 @@
         </p:nvSpPr>
         <p:spPr>
           <a:xfrm>
-            <a:off x="457200" y="1535113"/>
-            <a:ext cx="4040188" cy="639762"/>
+            <a:off x="609600" y="1535113"/>
+            <a:ext cx="5386917" cy="639762"/>
           </a:xfrm>
         </p:spPr>
         <p:txBody>
@@ -1533,8 +1540,8 @@
         </p:nvSpPr>
         <p:spPr>
           <a:xfrm>
-            <a:off x="457200" y="2174875"/>
-            <a:ext cx="4040188" cy="3951288"/>
+            <a:off x="609600" y="2174875"/>
+            <a:ext cx="5386917" cy="3951288"/>
           </a:xfrm>
         </p:spPr>
         <p:txBody>
@@ -1617,8 +1624,8 @@
         </p:nvSpPr>
         <p:spPr>
           <a:xfrm>
-            <a:off x="4645025" y="1535113"/>
-            <a:ext cx="4041775" cy="639762"/>
+            <a:off x="6193368" y="1535113"/>
+            <a:ext cx="5389033" cy="639762"/>
           </a:xfrm>
         </p:spPr>
         <p:txBody>
@@ -1682,8 +1689,8 @@
         </p:nvSpPr>
         <p:spPr>
           <a:xfrm>
-            <a:off x="4645025" y="2174875"/>
-            <a:ext cx="4041775" cy="3951288"/>
+            <a:off x="6193368" y="2174875"/>
+            <a:ext cx="5389033" cy="3951288"/>
           </a:xfrm>
         </p:spPr>
         <p:txBody>
@@ -1771,9 +1778,9 @@
           <a:p>
             <a:fld id="{5BCAD085-E8A6-8845-BD4E-CB4CCA059FC4}" type="datetimeFigureOut">
               <a:rPr lang="en-US" smtClean="0"/>
-              <a:t>4/4/26</a:t>
+              <a:t>04/09/2026</a:t>
             </a:fld>
-            <a:endParaRPr lang="en-US"/>
+            <a:endParaRPr lang="en-US" dirty="0"/>
           </a:p>
         </p:txBody>
       </p:sp>
@@ -1792,7 +1799,7 @@
           <a:bodyPr/>
           <a:lstStyle/>
           <a:p>
-            <a:endParaRPr lang="en-US"/>
+            <a:endParaRPr lang="en-US" dirty="0"/>
           </a:p>
         </p:txBody>
       </p:sp>
@@ -1815,7 +1822,7 @@
               <a:rPr lang="en-US" smtClean="0"/>
               <a:t>‹#›</a:t>
             </a:fld>
-            <a:endParaRPr lang="en-US"/>
+            <a:endParaRPr lang="en-US" dirty="0"/>
           </a:p>
         </p:txBody>
       </p:sp>
@@ -1888,9 +1895,9 @@
           <a:p>
             <a:fld id="{5BCAD085-E8A6-8845-BD4E-CB4CCA059FC4}" type="datetimeFigureOut">
               <a:rPr lang="en-US" smtClean="0"/>
-              <a:t>4/4/26</a:t>
+              <a:t>04/09/2026</a:t>
             </a:fld>
-            <a:endParaRPr lang="en-US"/>
+            <a:endParaRPr lang="en-US" dirty="0"/>
           </a:p>
         </p:txBody>
       </p:sp>
@@ -1909,7 +1916,7 @@
           <a:bodyPr/>
           <a:lstStyle/>
           <a:p>
-            <a:endParaRPr lang="en-US"/>
+            <a:endParaRPr lang="en-US" dirty="0"/>
           </a:p>
         </p:txBody>
       </p:sp>
@@ -1932,7 +1939,7 @@
               <a:rPr lang="en-US" smtClean="0"/>
               <a:t>‹#›</a:t>
             </a:fld>
-            <a:endParaRPr lang="en-US"/>
+            <a:endParaRPr lang="en-US" dirty="0"/>
           </a:p>
         </p:txBody>
       </p:sp>
@@ -1983,9 +1990,9 @@
           <a:p>
             <a:fld id="{5BCAD085-E8A6-8845-BD4E-CB4CCA059FC4}" type="datetimeFigureOut">
               <a:rPr lang="en-US" smtClean="0"/>
-              <a:t>4/4/26</a:t>
+              <a:t>04/09/2026</a:t>
             </a:fld>
-            <a:endParaRPr lang="en-US"/>
+            <a:endParaRPr lang="en-US" dirty="0"/>
           </a:p>
         </p:txBody>
       </p:sp>
@@ -2004,7 +2011,7 @@
           <a:bodyPr/>
           <a:lstStyle/>
           <a:p>
-            <a:endParaRPr lang="en-US"/>
+            <a:endParaRPr lang="en-US" dirty="0"/>
           </a:p>
         </p:txBody>
       </p:sp>
@@ -2027,7 +2034,7 @@
               <a:rPr lang="en-US" smtClean="0"/>
               <a:t>‹#›</a:t>
             </a:fld>
-            <a:endParaRPr lang="en-US"/>
+            <a:endParaRPr lang="en-US" dirty="0"/>
           </a:p>
         </p:txBody>
       </p:sp>
@@ -2073,8 +2080,8 @@
         </p:nvSpPr>
         <p:spPr>
           <a:xfrm>
-            <a:off x="457200" y="273050"/>
-            <a:ext cx="3008313" cy="1162050"/>
+            <a:off x="609601" y="273050"/>
+            <a:ext cx="4011084" cy="1162050"/>
           </a:xfrm>
         </p:spPr>
         <p:txBody>
@@ -2104,8 +2111,8 @@
         </p:nvSpPr>
         <p:spPr>
           <a:xfrm>
-            <a:off x="3575050" y="273050"/>
-            <a:ext cx="5111750" cy="5853113"/>
+            <a:off x="4766733" y="273051"/>
+            <a:ext cx="6815667" cy="5853113"/>
           </a:xfrm>
         </p:spPr>
         <p:txBody>
@@ -2188,8 +2195,8 @@
         </p:nvSpPr>
         <p:spPr>
           <a:xfrm>
-            <a:off x="457200" y="1435100"/>
-            <a:ext cx="3008313" cy="4691063"/>
+            <a:off x="609601" y="1435101"/>
+            <a:ext cx="4011084" cy="4691063"/>
           </a:xfrm>
         </p:spPr>
         <p:txBody>
@@ -2258,9 +2265,9 @@
           <a:p>
             <a:fld id="{5BCAD085-E8A6-8845-BD4E-CB4CCA059FC4}" type="datetimeFigureOut">
               <a:rPr lang="en-US" smtClean="0"/>
-              <a:t>4/4/26</a:t>
+              <a:t>04/09/2026</a:t>
             </a:fld>
-            <a:endParaRPr lang="en-US"/>
+            <a:endParaRPr lang="en-US" dirty="0"/>
           </a:p>
         </p:txBody>
       </p:sp>
@@ -2279,7 +2286,7 @@
           <a:bodyPr/>
           <a:lstStyle/>
           <a:p>
-            <a:endParaRPr lang="en-US"/>
+            <a:endParaRPr lang="en-US" dirty="0"/>
           </a:p>
         </p:txBody>
       </p:sp>
@@ -2302,7 +2309,7 @@
               <a:rPr lang="en-US" smtClean="0"/>
               <a:t>‹#›</a:t>
             </a:fld>
-            <a:endParaRPr lang="en-US"/>
+            <a:endParaRPr lang="en-US" dirty="0"/>
           </a:p>
         </p:txBody>
       </p:sp>
@@ -2348,8 +2355,8 @@
         </p:nvSpPr>
         <p:spPr>
           <a:xfrm>
-            <a:off x="1792288" y="4800600"/>
-            <a:ext cx="5486400" cy="566738"/>
+            <a:off x="2389717" y="4800600"/>
+            <a:ext cx="7315200" cy="566738"/>
           </a:xfrm>
         </p:spPr>
         <p:txBody>
@@ -2379,8 +2386,8 @@
         </p:nvSpPr>
         <p:spPr>
           <a:xfrm>
-            <a:off x="1792288" y="612775"/>
-            <a:ext cx="5486400" cy="4114800"/>
+            <a:off x="2389717" y="612775"/>
+            <a:ext cx="7315200" cy="4114800"/>
           </a:xfrm>
         </p:spPr>
         <p:txBody>
@@ -2424,7 +2431,7 @@
             </a:lvl9pPr>
           </a:lstStyle>
           <a:p>
-            <a:endParaRPr lang="en-US"/>
+            <a:endParaRPr lang="en-US" dirty="0"/>
           </a:p>
         </p:txBody>
       </p:sp>
@@ -2440,8 +2447,8 @@
         </p:nvSpPr>
         <p:spPr>
           <a:xfrm>
-            <a:off x="1792288" y="5367338"/>
-            <a:ext cx="5486400" cy="804862"/>
+            <a:off x="2389717" y="5367338"/>
+            <a:ext cx="7315200" cy="804862"/>
           </a:xfrm>
         </p:spPr>
         <p:txBody>
@@ -2510,9 +2517,9 @@
           <a:p>
             <a:fld id="{5BCAD085-E8A6-8845-BD4E-CB4CCA059FC4}" type="datetimeFigureOut">
               <a:rPr lang="en-US" smtClean="0"/>
-              <a:t>4/4/26</a:t>
+              <a:t>04/09/2026</a:t>
             </a:fld>
-            <a:endParaRPr lang="en-US"/>
+            <a:endParaRPr lang="en-US" dirty="0"/>
           </a:p>
         </p:txBody>
       </p:sp>
@@ -2531,7 +2538,7 @@
           <a:bodyPr/>
           <a:lstStyle/>
           <a:p>
-            <a:endParaRPr lang="en-US"/>
+            <a:endParaRPr lang="en-US" dirty="0"/>
           </a:p>
         </p:txBody>
       </p:sp>
@@ -2554,7 +2561,7 @@
               <a:rPr lang="en-US" smtClean="0"/>
               <a:t>‹#›</a:t>
             </a:fld>
-            <a:endParaRPr lang="en-US"/>
+            <a:endParaRPr lang="en-US" dirty="0"/>
           </a:p>
         </p:txBody>
       </p:sp>
@@ -2605,8 +2612,8 @@
         </p:nvSpPr>
         <p:spPr>
           <a:xfrm>
-            <a:off x="457200" y="274638"/>
-            <a:ext cx="8229600" cy="1143000"/>
+            <a:off x="609600" y="274638"/>
+            <a:ext cx="10972800" cy="1143000"/>
           </a:xfrm>
           <a:prstGeom prst="rect">
             <a:avLst/>
@@ -2637,8 +2644,8 @@
         </p:nvSpPr>
         <p:spPr>
           <a:xfrm>
-            <a:off x="457200" y="1600200"/>
-            <a:ext cx="8229600" cy="4525963"/>
+            <a:off x="609600" y="1600201"/>
+            <a:ext cx="10972800" cy="4525963"/>
           </a:xfrm>
           <a:prstGeom prst="rect">
             <a:avLst/>
@@ -2698,8 +2705,8 @@
         </p:nvSpPr>
         <p:spPr>
           <a:xfrm>
-            <a:off x="457200" y="6356350"/>
-            <a:ext cx="2133600" cy="365125"/>
+            <a:off x="609600" y="6356351"/>
+            <a:ext cx="2844800" cy="365125"/>
           </a:xfrm>
           <a:prstGeom prst="rect">
             <a:avLst/>
@@ -2721,9 +2728,9 @@
           <a:p>
             <a:fld id="{5BCAD085-E8A6-8845-BD4E-CB4CCA059FC4}" type="datetimeFigureOut">
               <a:rPr lang="en-US" smtClean="0"/>
-              <a:t>4/4/26</a:t>
+              <a:t>04/09/2026</a:t>
             </a:fld>
-            <a:endParaRPr lang="en-US"/>
+            <a:endParaRPr lang="en-US" dirty="0"/>
           </a:p>
         </p:txBody>
       </p:sp>
@@ -2739,8 +2746,8 @@
         </p:nvSpPr>
         <p:spPr>
           <a:xfrm>
-            <a:off x="3124200" y="6356350"/>
-            <a:ext cx="2895600" cy="365125"/>
+            <a:off x="4165600" y="6356351"/>
+            <a:ext cx="3860800" cy="365125"/>
           </a:xfrm>
           <a:prstGeom prst="rect">
             <a:avLst/>
@@ -2760,7 +2767,7 @@
             </a:lvl1pPr>
           </a:lstStyle>
           <a:p>
-            <a:endParaRPr lang="en-US"/>
+            <a:endParaRPr lang="en-US" dirty="0"/>
           </a:p>
         </p:txBody>
       </p:sp>
@@ -2776,8 +2783,8 @@
         </p:nvSpPr>
         <p:spPr>
           <a:xfrm>
-            <a:off x="6553200" y="6356350"/>
-            <a:ext cx="2133600" cy="365125"/>
+            <a:off x="8737600" y="6356351"/>
+            <a:ext cx="2844800" cy="365125"/>
           </a:xfrm>
           <a:prstGeom prst="rect">
             <a:avLst/>
@@ -2801,7 +2808,7 @@
               <a:rPr lang="en-US" smtClean="0"/>
               <a:t>‹#›</a:t>
             </a:fld>
-            <a:endParaRPr lang="en-US"/>
+            <a:endParaRPr lang="en-US" dirty="0"/>
           </a:p>
         </p:txBody>
       </p:sp>
@@ -3106,39 +3113,1544 @@
             <p:ph type="ctrTitle"/>
           </p:nvPr>
         </p:nvSpPr>
+        <p:spPr>
+          <a:xfrm>
+            <a:off x="0" y="1504821"/>
+            <a:ext cx="12192000" cy="1470025"/>
+          </a:xfrm>
+        </p:spPr>
+        <p:txBody>
+          <a:bodyPr>
+            <a:noAutofit/>
+          </a:bodyPr>
+          <a:lstStyle/>
+          <a:p>
+            <a:r>
+              <a:rPr lang="en-US" sz="6000" b="1" dirty="0"/>
+              <a:t>Network Science Co-authorship Analysis</a:t>
+            </a:r>
+          </a:p>
+        </p:txBody>
+      </p:sp>
+      <p:sp>
+        <p:nvSpPr>
+          <p:cNvPr id="3" name="Subtitle 2"/>
+          <p:cNvSpPr>
+            <a:spLocks noGrp="1"/>
+          </p:cNvSpPr>
+          <p:nvPr>
+            <p:ph type="subTitle" idx="1"/>
+          </p:nvPr>
+        </p:nvSpPr>
+        <p:spPr>
+          <a:xfrm>
+            <a:off x="2803849" y="3883155"/>
+            <a:ext cx="6584302" cy="1752600"/>
+          </a:xfrm>
+        </p:spPr>
+        <p:txBody>
+          <a:bodyPr>
+            <a:normAutofit/>
+          </a:bodyPr>
+          <a:lstStyle/>
+          <a:p>
+            <a:r>
+              <a:rPr lang="en-US" sz="2200" dirty="0"/>
+              <a:t>dimacs10-netscience vs Erdos-</a:t>
+            </a:r>
+            <a:r>
+              <a:rPr lang="en-US" sz="2200" dirty="0" err="1"/>
+              <a:t>Renyi</a:t>
+            </a:r>
+            <a:r>
+              <a:rPr lang="en-US" sz="2200" dirty="0"/>
+              <a:t> and </a:t>
+            </a:r>
+            <a:r>
+              <a:rPr lang="en-US" sz="2200" dirty="0" err="1"/>
+              <a:t>Barabasi</a:t>
+            </a:r>
+            <a:r>
+              <a:rPr lang="en-US" sz="2200" dirty="0"/>
+              <a:t>-Albert</a:t>
+            </a:r>
+          </a:p>
+        </p:txBody>
+      </p:sp>
+    </p:spTree>
+  </p:cSld>
+  <p:clrMapOvr>
+    <a:masterClrMapping/>
+  </p:clrMapOvr>
+</p:sld>
+</file>
+
+<file path=ppt/slides/slide10.xml><?xml version="1.0" encoding="utf-8"?>
+<p:sld xmlns:a="http://schemas.openxmlformats.org/drawingml/2006/main" xmlns:r="http://schemas.openxmlformats.org/officeDocument/2006/relationships" xmlns:p="http://schemas.openxmlformats.org/presentationml/2006/main">
+  <p:cSld>
+    <p:spTree>
+      <p:nvGrpSpPr>
+        <p:cNvPr id="1" name=""/>
+        <p:cNvGrpSpPr/>
+        <p:nvPr/>
+      </p:nvGrpSpPr>
+      <p:grpSpPr>
+        <a:xfrm>
+          <a:off x="0" y="0"/>
+          <a:ext cx="0" cy="0"/>
+          <a:chOff x="0" y="0"/>
+          <a:chExt cx="0" cy="0"/>
+        </a:xfrm>
+      </p:grpSpPr>
+      <p:sp>
+        <p:nvSpPr>
+          <p:cNvPr id="2" name="Title 1">
+            <a:extLst>
+              <a:ext uri="{FF2B5EF4-FFF2-40B4-BE49-F238E27FC236}">
+                <a16:creationId xmlns:a16="http://schemas.microsoft.com/office/drawing/2014/main" id="{3343424C-E439-20D8-CED5-BA96DDBF373D}"/>
+              </a:ext>
+            </a:extLst>
+          </p:cNvPr>
+          <p:cNvSpPr>
+            <a:spLocks noGrp="1"/>
+          </p:cNvSpPr>
+          <p:nvPr>
+            <p:ph type="title"/>
+          </p:nvPr>
+        </p:nvSpPr>
         <p:spPr/>
         <p:txBody>
-          <a:bodyPr/>
-          <a:lstStyle/>
-          <a:p>
-            <a:r>
-              <a:t>Network Science Co-authorship Analysis</a:t>
-            </a:r>
-          </a:p>
-        </p:txBody>
-      </p:sp>
-      <p:sp>
-        <p:nvSpPr>
-          <p:cNvPr id="3" name="Subtitle 2"/>
-          <p:cNvSpPr>
-            <a:spLocks noGrp="1"/>
-          </p:cNvSpPr>
-          <p:nvPr>
-            <p:ph type="subTitle" idx="1"/>
+          <a:bodyPr>
+            <a:normAutofit/>
+          </a:bodyPr>
+          <a:lstStyle/>
+          <a:p>
+            <a:r>
+              <a:rPr lang="en-US" sz="3600" b="1" dirty="0"/>
+              <a:t>Network Visualization I</a:t>
+            </a:r>
+          </a:p>
+        </p:txBody>
+      </p:sp>
+      <p:pic>
+        <p:nvPicPr>
+          <p:cNvPr id="7" name="Picture 6">
+            <a:extLst>
+              <a:ext uri="{FF2B5EF4-FFF2-40B4-BE49-F238E27FC236}">
+                <a16:creationId xmlns:a16="http://schemas.microsoft.com/office/drawing/2014/main" id="{AC2B643A-1508-29A9-8713-91B77D52DBE5}"/>
+              </a:ext>
+            </a:extLst>
+          </p:cNvPr>
+          <p:cNvPicPr>
+            <a:picLocks noChangeAspect="1"/>
+          </p:cNvPicPr>
+          <p:nvPr/>
+        </p:nvPicPr>
+        <p:blipFill>
+          <a:blip r:embed="rId2"/>
+          <a:stretch>
+            <a:fillRect/>
+          </a:stretch>
+        </p:blipFill>
+        <p:spPr>
+          <a:xfrm>
+            <a:off x="0" y="1419704"/>
+            <a:ext cx="12192000" cy="4018592"/>
+          </a:xfrm>
+          <a:prstGeom prst="rect">
+            <a:avLst/>
+          </a:prstGeom>
+        </p:spPr>
+      </p:pic>
+    </p:spTree>
+    <p:extLst>
+      <p:ext uri="{BB962C8B-B14F-4D97-AF65-F5344CB8AC3E}">
+        <p14:creationId xmlns:p14="http://schemas.microsoft.com/office/powerpoint/2010/main" val="4222595288"/>
+      </p:ext>
+    </p:extLst>
+  </p:cSld>
+  <p:clrMapOvr>
+    <a:masterClrMapping/>
+  </p:clrMapOvr>
+</p:sld>
+</file>
+
+<file path=ppt/slides/slide11.xml><?xml version="1.0" encoding="utf-8"?>
+<p:sld xmlns:a="http://schemas.openxmlformats.org/drawingml/2006/main" xmlns:r="http://schemas.openxmlformats.org/officeDocument/2006/relationships" xmlns:p="http://schemas.openxmlformats.org/presentationml/2006/main">
+  <p:cSld>
+    <p:spTree>
+      <p:nvGrpSpPr>
+        <p:cNvPr id="1" name=""/>
+        <p:cNvGrpSpPr/>
+        <p:nvPr/>
+      </p:nvGrpSpPr>
+      <p:grpSpPr>
+        <a:xfrm>
+          <a:off x="0" y="0"/>
+          <a:ext cx="0" cy="0"/>
+          <a:chOff x="0" y="0"/>
+          <a:chExt cx="0" cy="0"/>
+        </a:xfrm>
+      </p:grpSpPr>
+      <p:sp>
+        <p:nvSpPr>
+          <p:cNvPr id="2" name="Title 1">
+            <a:extLst>
+              <a:ext uri="{FF2B5EF4-FFF2-40B4-BE49-F238E27FC236}">
+                <a16:creationId xmlns:a16="http://schemas.microsoft.com/office/drawing/2014/main" id="{AFB355C7-4408-F460-249E-C25B37074463}"/>
+              </a:ext>
+            </a:extLst>
+          </p:cNvPr>
+          <p:cNvSpPr>
+            <a:spLocks noGrp="1"/>
+          </p:cNvSpPr>
+          <p:nvPr>
+            <p:ph type="title"/>
           </p:nvPr>
         </p:nvSpPr>
         <p:spPr/>
         <p:txBody>
-          <a:bodyPr/>
-          <a:lstStyle/>
-          <a:p>
-            <a:r>
-              <a:t>dimacs10-netscience vs Erdos-Renyi and Barabasi-Albert</a:t>
+          <a:bodyPr>
+            <a:normAutofit/>
+          </a:bodyPr>
+          <a:lstStyle/>
+          <a:p>
+            <a:r>
+              <a:rPr lang="en-US" sz="3600" b="1" dirty="0"/>
+              <a:t>Network Visualization II</a:t>
+            </a:r>
+            <a:endParaRPr lang="en-US" sz="3600" dirty="0"/>
+          </a:p>
+        </p:txBody>
+      </p:sp>
+      <p:pic>
+        <p:nvPicPr>
+          <p:cNvPr id="5" name="Picture 4">
+            <a:extLst>
+              <a:ext uri="{FF2B5EF4-FFF2-40B4-BE49-F238E27FC236}">
+                <a16:creationId xmlns:a16="http://schemas.microsoft.com/office/drawing/2014/main" id="{A2CED4AF-B3E7-1710-E570-609E17295831}"/>
+              </a:ext>
+            </a:extLst>
+          </p:cNvPr>
+          <p:cNvPicPr>
+            <a:picLocks noChangeAspect="1"/>
+          </p:cNvPicPr>
+          <p:nvPr/>
+        </p:nvPicPr>
+        <p:blipFill>
+          <a:blip r:embed="rId2"/>
+          <a:stretch>
+            <a:fillRect/>
+          </a:stretch>
+        </p:blipFill>
+        <p:spPr>
+          <a:xfrm>
+            <a:off x="1368490" y="1284766"/>
+            <a:ext cx="10823510" cy="1849242"/>
+          </a:xfrm>
+          <a:prstGeom prst="rect">
+            <a:avLst/>
+          </a:prstGeom>
+        </p:spPr>
+      </p:pic>
+      <p:pic>
+        <p:nvPicPr>
+          <p:cNvPr id="7" name="Picture 6">
+            <a:extLst>
+              <a:ext uri="{FF2B5EF4-FFF2-40B4-BE49-F238E27FC236}">
+                <a16:creationId xmlns:a16="http://schemas.microsoft.com/office/drawing/2014/main" id="{643CA76A-1A60-E2CD-4E17-E8C8CA6D5B90}"/>
+              </a:ext>
+            </a:extLst>
+          </p:cNvPr>
+          <p:cNvPicPr>
+            <a:picLocks noChangeAspect="1"/>
+          </p:cNvPicPr>
+          <p:nvPr/>
+        </p:nvPicPr>
+        <p:blipFill>
+          <a:blip r:embed="rId3"/>
+          <a:stretch>
+            <a:fillRect/>
+          </a:stretch>
+        </p:blipFill>
+        <p:spPr>
+          <a:xfrm>
+            <a:off x="1368490" y="3168690"/>
+            <a:ext cx="10823510" cy="1849243"/>
+          </a:xfrm>
+          <a:prstGeom prst="rect">
+            <a:avLst/>
+          </a:prstGeom>
+        </p:spPr>
+      </p:pic>
+      <p:pic>
+        <p:nvPicPr>
+          <p:cNvPr id="9" name="Picture 8">
+            <a:extLst>
+              <a:ext uri="{FF2B5EF4-FFF2-40B4-BE49-F238E27FC236}">
+                <a16:creationId xmlns:a16="http://schemas.microsoft.com/office/drawing/2014/main" id="{4CD9B1F4-9E96-869F-2164-1E80C7220547}"/>
+              </a:ext>
+            </a:extLst>
+          </p:cNvPr>
+          <p:cNvPicPr>
+            <a:picLocks noChangeAspect="1"/>
+          </p:cNvPicPr>
+          <p:nvPr/>
+        </p:nvPicPr>
+        <p:blipFill>
+          <a:blip r:embed="rId4"/>
+          <a:stretch>
+            <a:fillRect/>
+          </a:stretch>
+        </p:blipFill>
+        <p:spPr>
+          <a:xfrm>
+            <a:off x="1368490" y="5052615"/>
+            <a:ext cx="10823510" cy="1849242"/>
+          </a:xfrm>
+          <a:prstGeom prst="rect">
+            <a:avLst/>
+          </a:prstGeom>
+        </p:spPr>
+      </p:pic>
+      <p:sp>
+        <p:nvSpPr>
+          <p:cNvPr id="10" name="TextBox 9">
+            <a:extLst>
+              <a:ext uri="{FF2B5EF4-FFF2-40B4-BE49-F238E27FC236}">
+                <a16:creationId xmlns:a16="http://schemas.microsoft.com/office/drawing/2014/main" id="{01BCED41-BEAB-E6B1-1E71-A0FB550FF771}"/>
+              </a:ext>
+            </a:extLst>
+          </p:cNvPr>
+          <p:cNvSpPr txBox="1"/>
+          <p:nvPr/>
+        </p:nvSpPr>
+        <p:spPr>
+          <a:xfrm>
+            <a:off x="110412" y="1840054"/>
+            <a:ext cx="1129004" cy="400110"/>
+          </a:xfrm>
+          <a:prstGeom prst="rect">
+            <a:avLst/>
+          </a:prstGeom>
+          <a:noFill/>
+        </p:spPr>
+        <p:txBody>
+          <a:bodyPr wrap="square" rtlCol="0">
+            <a:spAutoFit/>
+          </a:bodyPr>
+          <a:lstStyle/>
+          <a:p>
+            <a:r>
+              <a:rPr lang="en-US" sz="2000" b="1" dirty="0"/>
+              <a:t>Real</a:t>
+            </a:r>
+            <a:r>
+              <a:rPr lang="en-US" dirty="0"/>
+              <a:t> </a:t>
+            </a:r>
+          </a:p>
+        </p:txBody>
+      </p:sp>
+      <p:sp>
+        <p:nvSpPr>
+          <p:cNvPr id="11" name="TextBox 10">
+            <a:extLst>
+              <a:ext uri="{FF2B5EF4-FFF2-40B4-BE49-F238E27FC236}">
+                <a16:creationId xmlns:a16="http://schemas.microsoft.com/office/drawing/2014/main" id="{CAECA15B-BF3A-2F52-5945-31966228C156}"/>
+              </a:ext>
+            </a:extLst>
+          </p:cNvPr>
+          <p:cNvSpPr txBox="1"/>
+          <p:nvPr/>
+        </p:nvSpPr>
+        <p:spPr>
+          <a:xfrm>
+            <a:off x="110412" y="3723979"/>
+            <a:ext cx="1129004" cy="400110"/>
+          </a:xfrm>
+          <a:prstGeom prst="rect">
+            <a:avLst/>
+          </a:prstGeom>
+          <a:noFill/>
+        </p:spPr>
+        <p:txBody>
+          <a:bodyPr wrap="square" rtlCol="0">
+            <a:spAutoFit/>
+          </a:bodyPr>
+          <a:lstStyle/>
+          <a:p>
+            <a:r>
+              <a:rPr lang="en-US" sz="2000" b="1" dirty="0"/>
+              <a:t>Random</a:t>
+            </a:r>
+          </a:p>
+        </p:txBody>
+      </p:sp>
+      <p:sp>
+        <p:nvSpPr>
+          <p:cNvPr id="12" name="TextBox 11">
+            <a:extLst>
+              <a:ext uri="{FF2B5EF4-FFF2-40B4-BE49-F238E27FC236}">
+                <a16:creationId xmlns:a16="http://schemas.microsoft.com/office/drawing/2014/main" id="{A43115EB-B749-AEE5-BCFD-AA3E0B8477CA}"/>
+              </a:ext>
+            </a:extLst>
+          </p:cNvPr>
+          <p:cNvSpPr txBox="1"/>
+          <p:nvPr/>
+        </p:nvSpPr>
+        <p:spPr>
+          <a:xfrm>
+            <a:off x="45098" y="5607904"/>
+            <a:ext cx="1323392" cy="400110"/>
+          </a:xfrm>
+          <a:prstGeom prst="rect">
+            <a:avLst/>
+          </a:prstGeom>
+          <a:noFill/>
+        </p:spPr>
+        <p:txBody>
+          <a:bodyPr wrap="square" rtlCol="0">
+            <a:spAutoFit/>
+          </a:bodyPr>
+          <a:lstStyle/>
+          <a:p>
+            <a:r>
+              <a:rPr lang="en-US" sz="2000" b="1" dirty="0"/>
+              <a:t>Scale-free</a:t>
             </a:r>
           </a:p>
         </p:txBody>
       </p:sp>
     </p:spTree>
+    <p:extLst>
+      <p:ext uri="{BB962C8B-B14F-4D97-AF65-F5344CB8AC3E}">
+        <p14:creationId xmlns:p14="http://schemas.microsoft.com/office/powerpoint/2010/main" val="1628153016"/>
+      </p:ext>
+    </p:extLst>
+  </p:cSld>
+  <p:clrMapOvr>
+    <a:masterClrMapping/>
+  </p:clrMapOvr>
+</p:sld>
+</file>
+
+<file path=ppt/slides/slide12.xml><?xml version="1.0" encoding="utf-8"?>
+<p:sld xmlns:a="http://schemas.openxmlformats.org/drawingml/2006/main" xmlns:r="http://schemas.openxmlformats.org/officeDocument/2006/relationships" xmlns:p="http://schemas.openxmlformats.org/presentationml/2006/main">
+  <p:cSld>
+    <p:spTree>
+      <p:nvGrpSpPr>
+        <p:cNvPr id="1" name=""/>
+        <p:cNvGrpSpPr/>
+        <p:nvPr/>
+      </p:nvGrpSpPr>
+      <p:grpSpPr>
+        <a:xfrm>
+          <a:off x="0" y="0"/>
+          <a:ext cx="0" cy="0"/>
+          <a:chOff x="0" y="0"/>
+          <a:chExt cx="0" cy="0"/>
+        </a:xfrm>
+      </p:grpSpPr>
+      <p:sp>
+        <p:nvSpPr>
+          <p:cNvPr id="2" name="Title 1">
+            <a:extLst>
+              <a:ext uri="{FF2B5EF4-FFF2-40B4-BE49-F238E27FC236}">
+                <a16:creationId xmlns:a16="http://schemas.microsoft.com/office/drawing/2014/main" id="{7617A5D1-5D5C-3EBE-01DC-11D528B9D33D}"/>
+              </a:ext>
+            </a:extLst>
+          </p:cNvPr>
+          <p:cNvSpPr>
+            <a:spLocks noGrp="1"/>
+          </p:cNvSpPr>
+          <p:nvPr>
+            <p:ph type="title"/>
+          </p:nvPr>
+        </p:nvSpPr>
+        <p:spPr/>
+        <p:txBody>
+          <a:bodyPr>
+            <a:normAutofit/>
+          </a:bodyPr>
+          <a:lstStyle/>
+          <a:p>
+            <a:r>
+              <a:rPr lang="en-US" sz="3600" b="1" dirty="0"/>
+              <a:t>Network Visualization III</a:t>
+            </a:r>
+          </a:p>
+        </p:txBody>
+      </p:sp>
+      <p:pic>
+        <p:nvPicPr>
+          <p:cNvPr id="5" name="Picture 4">
+            <a:extLst>
+              <a:ext uri="{FF2B5EF4-FFF2-40B4-BE49-F238E27FC236}">
+                <a16:creationId xmlns:a16="http://schemas.microsoft.com/office/drawing/2014/main" id="{B6A01586-0EB0-B6FC-CAA9-C6A5F45C1AAB}"/>
+              </a:ext>
+            </a:extLst>
+          </p:cNvPr>
+          <p:cNvPicPr>
+            <a:picLocks noChangeAspect="1"/>
+          </p:cNvPicPr>
+          <p:nvPr/>
+        </p:nvPicPr>
+        <p:blipFill>
+          <a:blip r:embed="rId2"/>
+          <a:stretch>
+            <a:fillRect/>
+          </a:stretch>
+        </p:blipFill>
+        <p:spPr>
+          <a:xfrm>
+            <a:off x="0" y="1417638"/>
+            <a:ext cx="4280710" cy="2785192"/>
+          </a:xfrm>
+          <a:prstGeom prst="rect">
+            <a:avLst/>
+          </a:prstGeom>
+        </p:spPr>
+      </p:pic>
+      <p:pic>
+        <p:nvPicPr>
+          <p:cNvPr id="7" name="Picture 6">
+            <a:extLst>
+              <a:ext uri="{FF2B5EF4-FFF2-40B4-BE49-F238E27FC236}">
+                <a16:creationId xmlns:a16="http://schemas.microsoft.com/office/drawing/2014/main" id="{1236196F-4122-9A57-9944-28B5EFE9CB97}"/>
+              </a:ext>
+            </a:extLst>
+          </p:cNvPr>
+          <p:cNvPicPr>
+            <a:picLocks noChangeAspect="1"/>
+          </p:cNvPicPr>
+          <p:nvPr/>
+        </p:nvPicPr>
+        <p:blipFill>
+          <a:blip r:embed="rId3"/>
+          <a:stretch>
+            <a:fillRect/>
+          </a:stretch>
+        </p:blipFill>
+        <p:spPr>
+          <a:xfrm>
+            <a:off x="6988606" y="1417638"/>
+            <a:ext cx="4280710" cy="2785192"/>
+          </a:xfrm>
+          <a:prstGeom prst="rect">
+            <a:avLst/>
+          </a:prstGeom>
+        </p:spPr>
+      </p:pic>
+      <p:pic>
+        <p:nvPicPr>
+          <p:cNvPr id="9" name="Picture 8">
+            <a:extLst>
+              <a:ext uri="{FF2B5EF4-FFF2-40B4-BE49-F238E27FC236}">
+                <a16:creationId xmlns:a16="http://schemas.microsoft.com/office/drawing/2014/main" id="{B1C02610-EDB9-B3E8-BDEB-398C6AEDCBC4}"/>
+              </a:ext>
+            </a:extLst>
+          </p:cNvPr>
+          <p:cNvPicPr>
+            <a:picLocks noChangeAspect="1"/>
+          </p:cNvPicPr>
+          <p:nvPr/>
+        </p:nvPicPr>
+        <p:blipFill>
+          <a:blip r:embed="rId4"/>
+          <a:stretch>
+            <a:fillRect/>
+          </a:stretch>
+        </p:blipFill>
+        <p:spPr>
+          <a:xfrm>
+            <a:off x="3333069" y="3429001"/>
+            <a:ext cx="4848106" cy="3154362"/>
+          </a:xfrm>
+          <a:prstGeom prst="rect">
+            <a:avLst/>
+          </a:prstGeom>
+        </p:spPr>
+      </p:pic>
+    </p:spTree>
+    <p:extLst>
+      <p:ext uri="{BB962C8B-B14F-4D97-AF65-F5344CB8AC3E}">
+        <p14:creationId xmlns:p14="http://schemas.microsoft.com/office/powerpoint/2010/main" val="3432858617"/>
+      </p:ext>
+    </p:extLst>
+  </p:cSld>
+  <p:clrMapOvr>
+    <a:masterClrMapping/>
+  </p:clrMapOvr>
+</p:sld>
+</file>
+
+<file path=ppt/slides/slide13.xml><?xml version="1.0" encoding="utf-8"?>
+<p:sld xmlns:a="http://schemas.openxmlformats.org/drawingml/2006/main" xmlns:r="http://schemas.openxmlformats.org/officeDocument/2006/relationships" xmlns:p="http://schemas.openxmlformats.org/presentationml/2006/main">
+  <p:cSld>
+    <p:spTree>
+      <p:nvGrpSpPr>
+        <p:cNvPr id="1" name=""/>
+        <p:cNvGrpSpPr/>
+        <p:nvPr/>
+      </p:nvGrpSpPr>
+      <p:grpSpPr>
+        <a:xfrm>
+          <a:off x="0" y="0"/>
+          <a:ext cx="0" cy="0"/>
+          <a:chOff x="0" y="0"/>
+          <a:chExt cx="0" cy="0"/>
+        </a:xfrm>
+      </p:grpSpPr>
+      <p:sp>
+        <p:nvSpPr>
+          <p:cNvPr id="2" name="Title 1">
+            <a:extLst>
+              <a:ext uri="{FF2B5EF4-FFF2-40B4-BE49-F238E27FC236}">
+                <a16:creationId xmlns:a16="http://schemas.microsoft.com/office/drawing/2014/main" id="{79EE23CE-3967-3E06-F685-FAD97CD86183}"/>
+              </a:ext>
+            </a:extLst>
+          </p:cNvPr>
+          <p:cNvSpPr>
+            <a:spLocks noGrp="1"/>
+          </p:cNvSpPr>
+          <p:nvPr>
+            <p:ph type="title"/>
+          </p:nvPr>
+        </p:nvSpPr>
+        <p:spPr/>
+        <p:txBody>
+          <a:bodyPr>
+            <a:normAutofit/>
+          </a:bodyPr>
+          <a:lstStyle/>
+          <a:p>
+            <a:r>
+              <a:rPr lang="en-US" sz="3600" b="1" dirty="0"/>
+              <a:t>Important Nodes</a:t>
+            </a:r>
+          </a:p>
+        </p:txBody>
+      </p:sp>
+      <p:sp>
+        <p:nvSpPr>
+          <p:cNvPr id="3" name="Content Placeholder 2">
+            <a:extLst>
+              <a:ext uri="{FF2B5EF4-FFF2-40B4-BE49-F238E27FC236}">
+                <a16:creationId xmlns:a16="http://schemas.microsoft.com/office/drawing/2014/main" id="{49E7C214-9017-0F08-EA44-DF5A2B478FC4}"/>
+              </a:ext>
+            </a:extLst>
+          </p:cNvPr>
+          <p:cNvSpPr>
+            <a:spLocks noGrp="1"/>
+          </p:cNvSpPr>
+          <p:nvPr>
+            <p:ph idx="1"/>
+          </p:nvPr>
+        </p:nvSpPr>
+        <p:spPr>
+          <a:xfrm>
+            <a:off x="609600" y="1417638"/>
+            <a:ext cx="3831771" cy="5165724"/>
+          </a:xfrm>
+        </p:spPr>
+        <p:txBody>
+          <a:bodyPr>
+            <a:normAutofit fontScale="47500" lnSpcReduction="20000"/>
+          </a:bodyPr>
+          <a:lstStyle/>
+          <a:p>
+            <a:pPr marL="0" indent="0">
+              <a:buNone/>
+            </a:pPr>
+            <a:r>
+              <a:rPr lang="en-US" sz="5100" b="1" dirty="0"/>
+              <a:t>Highly Central Nodes in Real Graph</a:t>
+            </a:r>
+          </a:p>
+          <a:p>
+            <a:pPr marL="0" indent="0">
+              <a:buNone/>
+            </a:pPr>
+            <a:endParaRPr lang="en-US" dirty="0"/>
+          </a:p>
+          <a:p>
+            <a:pPr marL="0" indent="0">
+              <a:buNone/>
+            </a:pPr>
+            <a:r>
+              <a:rPr lang="en-US" sz="4200" dirty="0"/>
+              <a:t>Top 5 by Degree: </a:t>
+            </a:r>
+          </a:p>
+          <a:p>
+            <a:pPr marL="0" indent="0">
+              <a:buNone/>
+            </a:pPr>
+            <a:r>
+              <a:rPr lang="en-US" sz="4200" dirty="0"/>
+              <a:t>Node 44: 34 edges </a:t>
+            </a:r>
+          </a:p>
+          <a:p>
+            <a:pPr marL="0" indent="0">
+              <a:buNone/>
+            </a:pPr>
+            <a:r>
+              <a:rPr lang="en-US" sz="4200" dirty="0"/>
+              <a:t>Node 45: 27 edges </a:t>
+            </a:r>
+          </a:p>
+          <a:p>
+            <a:pPr marL="0" indent="0">
+              <a:buNone/>
+            </a:pPr>
+            <a:r>
+              <a:rPr lang="en-US" sz="4200" dirty="0"/>
+              <a:t>Node 107: 27 edges </a:t>
+            </a:r>
+          </a:p>
+          <a:p>
+            <a:pPr marL="0" indent="0">
+              <a:buNone/>
+            </a:pPr>
+            <a:r>
+              <a:rPr lang="en-US" sz="4200" dirty="0"/>
+              <a:t>Node 46: 21 edges </a:t>
+            </a:r>
+          </a:p>
+          <a:p>
+            <a:pPr marL="0" indent="0">
+              <a:buNone/>
+            </a:pPr>
+            <a:r>
+              <a:rPr lang="en-US" sz="4200" dirty="0"/>
+              <a:t>Node 532: 20 edges </a:t>
+            </a:r>
+          </a:p>
+          <a:p>
+            <a:pPr marL="0" indent="0">
+              <a:buNone/>
+            </a:pPr>
+            <a:endParaRPr lang="en-US" sz="4200" dirty="0"/>
+          </a:p>
+          <a:p>
+            <a:pPr marL="0" indent="0">
+              <a:buNone/>
+            </a:pPr>
+            <a:r>
+              <a:rPr lang="en-US" sz="4200" dirty="0"/>
+              <a:t>Top 5 by Betweenness Centrality: </a:t>
+            </a:r>
+          </a:p>
+          <a:p>
+            <a:pPr marL="0" indent="0">
+              <a:buNone/>
+            </a:pPr>
+            <a:r>
+              <a:rPr lang="en-US" sz="4200" dirty="0"/>
+              <a:t>Node 107: 0.021924 </a:t>
+            </a:r>
+          </a:p>
+          <a:p>
+            <a:pPr marL="0" indent="0">
+              <a:buNone/>
+            </a:pPr>
+            <a:r>
+              <a:rPr lang="en-US" sz="4200" dirty="0"/>
+              <a:t>Node 185: 0.017579 </a:t>
+            </a:r>
+          </a:p>
+          <a:p>
+            <a:pPr marL="0" indent="0">
+              <a:buNone/>
+            </a:pPr>
+            <a:r>
+              <a:rPr lang="en-US" sz="4200" dirty="0"/>
+              <a:t>Node 329: 0.017510 </a:t>
+            </a:r>
+          </a:p>
+          <a:p>
+            <a:pPr marL="0" indent="0">
+              <a:buNone/>
+            </a:pPr>
+            <a:r>
+              <a:rPr lang="en-US" sz="4200" dirty="0"/>
+              <a:t>Node 121: 0.017130 </a:t>
+            </a:r>
+          </a:p>
+          <a:p>
+            <a:pPr marL="0" indent="0">
+              <a:buNone/>
+            </a:pPr>
+            <a:r>
+              <a:rPr lang="en-US" sz="4200" dirty="0"/>
+              <a:t>Node 205: 0.013582 </a:t>
+            </a:r>
+          </a:p>
+          <a:p>
+            <a:pPr marL="0" indent="0">
+              <a:buNone/>
+            </a:pPr>
+            <a:endParaRPr lang="en-US" dirty="0"/>
+          </a:p>
+          <a:p>
+            <a:pPr marL="0" indent="0">
+              <a:buNone/>
+            </a:pPr>
+            <a:endParaRPr lang="en-US" dirty="0"/>
+          </a:p>
+        </p:txBody>
+      </p:sp>
+      <p:sp>
+        <p:nvSpPr>
+          <p:cNvPr id="4" name="TextBox 3">
+            <a:extLst>
+              <a:ext uri="{FF2B5EF4-FFF2-40B4-BE49-F238E27FC236}">
+                <a16:creationId xmlns:a16="http://schemas.microsoft.com/office/drawing/2014/main" id="{6C074C14-C96B-825E-1B75-AD00B68CA4FC}"/>
+              </a:ext>
+            </a:extLst>
+          </p:cNvPr>
+          <p:cNvSpPr txBox="1"/>
+          <p:nvPr/>
+        </p:nvSpPr>
+        <p:spPr>
+          <a:xfrm>
+            <a:off x="4441371" y="1305670"/>
+            <a:ext cx="3676262" cy="5109091"/>
+          </a:xfrm>
+          <a:prstGeom prst="rect">
+            <a:avLst/>
+          </a:prstGeom>
+          <a:noFill/>
+        </p:spPr>
+        <p:txBody>
+          <a:bodyPr wrap="square" rtlCol="0">
+            <a:spAutoFit/>
+          </a:bodyPr>
+          <a:lstStyle/>
+          <a:p>
+            <a:r>
+              <a:rPr lang="en-US" sz="2400" b="1" dirty="0"/>
+              <a:t>Highly Central Nodes in Random Graph</a:t>
+            </a:r>
+          </a:p>
+          <a:p>
+            <a:endParaRPr lang="en-US" dirty="0"/>
+          </a:p>
+          <a:p>
+            <a:r>
+              <a:rPr lang="en-US" sz="2000" dirty="0"/>
+              <a:t>Top 5 by Degree: </a:t>
+            </a:r>
+          </a:p>
+          <a:p>
+            <a:r>
+              <a:rPr lang="en-US" sz="2000" dirty="0"/>
+              <a:t>Node 670: 12 edges </a:t>
+            </a:r>
+          </a:p>
+          <a:p>
+            <a:r>
+              <a:rPr lang="en-US" sz="2000" dirty="0"/>
+              <a:t>Node 690: 12 edges </a:t>
+            </a:r>
+          </a:p>
+          <a:p>
+            <a:r>
+              <a:rPr lang="en-US" sz="2000" dirty="0"/>
+              <a:t>Node 154: 11 edges </a:t>
+            </a:r>
+          </a:p>
+          <a:p>
+            <a:r>
+              <a:rPr lang="en-US" sz="2000" dirty="0"/>
+              <a:t>Node 29: 10 edges </a:t>
+            </a:r>
+          </a:p>
+          <a:p>
+            <a:r>
+              <a:rPr lang="en-US" sz="2000" dirty="0"/>
+              <a:t>Node 261: 10 edges </a:t>
+            </a:r>
+          </a:p>
+          <a:p>
+            <a:endParaRPr lang="en-US" sz="2000" dirty="0"/>
+          </a:p>
+          <a:p>
+            <a:r>
+              <a:rPr lang="en-US" sz="2000" dirty="0"/>
+              <a:t>Top 5 by Betweenness Centrality: </a:t>
+            </a:r>
+          </a:p>
+          <a:p>
+            <a:r>
+              <a:rPr lang="en-US" sz="2000" dirty="0"/>
+              <a:t>Node 1063: 0.022408 </a:t>
+            </a:r>
+          </a:p>
+          <a:p>
+            <a:r>
+              <a:rPr lang="en-US" sz="2000" dirty="0"/>
+              <a:t>Node 1426: 0.022274 </a:t>
+            </a:r>
+          </a:p>
+          <a:p>
+            <a:r>
+              <a:rPr lang="en-US" sz="2000" dirty="0"/>
+              <a:t>Node 670: 0.021199 </a:t>
+            </a:r>
+          </a:p>
+          <a:p>
+            <a:r>
+              <a:rPr lang="en-US" sz="2000" dirty="0"/>
+              <a:t>Node 29: 0.020611 </a:t>
+            </a:r>
+          </a:p>
+          <a:p>
+            <a:r>
+              <a:rPr lang="en-US" sz="2000" dirty="0"/>
+              <a:t>Node 154: 0.020269 </a:t>
+            </a:r>
+          </a:p>
+        </p:txBody>
+      </p:sp>
+      <p:sp>
+        <p:nvSpPr>
+          <p:cNvPr id="5" name="TextBox 4">
+            <a:extLst>
+              <a:ext uri="{FF2B5EF4-FFF2-40B4-BE49-F238E27FC236}">
+                <a16:creationId xmlns:a16="http://schemas.microsoft.com/office/drawing/2014/main" id="{B5A0743E-3302-1D62-F94B-0DA145953297}"/>
+              </a:ext>
+            </a:extLst>
+          </p:cNvPr>
+          <p:cNvSpPr txBox="1"/>
+          <p:nvPr/>
+        </p:nvSpPr>
+        <p:spPr>
+          <a:xfrm>
+            <a:off x="8223379" y="1286905"/>
+            <a:ext cx="3676262" cy="5109091"/>
+          </a:xfrm>
+          <a:prstGeom prst="rect">
+            <a:avLst/>
+          </a:prstGeom>
+          <a:noFill/>
+        </p:spPr>
+        <p:txBody>
+          <a:bodyPr wrap="square" rtlCol="0">
+            <a:spAutoFit/>
+          </a:bodyPr>
+          <a:lstStyle/>
+          <a:p>
+            <a:r>
+              <a:rPr lang="en-US" sz="2400" b="1" dirty="0"/>
+              <a:t>Highly Central Nodes in Scale-Free Graph</a:t>
+            </a:r>
+          </a:p>
+          <a:p>
+            <a:endParaRPr lang="en-US" dirty="0"/>
+          </a:p>
+          <a:p>
+            <a:r>
+              <a:rPr lang="en-US" sz="2000" dirty="0"/>
+              <a:t>Top 5 by Degree:</a:t>
+            </a:r>
+          </a:p>
+          <a:p>
+            <a:r>
+              <a:rPr lang="en-US" sz="2000" dirty="0"/>
+              <a:t>Node 0: 103 edges </a:t>
+            </a:r>
+          </a:p>
+          <a:p>
+            <a:r>
+              <a:rPr lang="en-US" sz="2000" dirty="0"/>
+              <a:t>Node 1: 89 edges </a:t>
+            </a:r>
+          </a:p>
+          <a:p>
+            <a:r>
+              <a:rPr lang="en-US" sz="2000" dirty="0"/>
+              <a:t>Node 4: 78 edges </a:t>
+            </a:r>
+          </a:p>
+          <a:p>
+            <a:r>
+              <a:rPr lang="en-US" sz="2000" dirty="0"/>
+              <a:t>Node 6: 62 edges </a:t>
+            </a:r>
+          </a:p>
+          <a:p>
+            <a:r>
+              <a:rPr lang="en-US" sz="2000" dirty="0"/>
+              <a:t>Node 16: 42 edges </a:t>
+            </a:r>
+          </a:p>
+          <a:p>
+            <a:endParaRPr lang="en-US" sz="2000" dirty="0"/>
+          </a:p>
+          <a:p>
+            <a:r>
+              <a:rPr lang="en-US" sz="2000" dirty="0"/>
+              <a:t>Top 5 by Betweenness Centrality: </a:t>
+            </a:r>
+          </a:p>
+          <a:p>
+            <a:r>
+              <a:rPr lang="en-US" sz="2000" dirty="0"/>
+              <a:t>Node 0: 0.235513 </a:t>
+            </a:r>
+          </a:p>
+          <a:p>
+            <a:r>
+              <a:rPr lang="en-US" sz="2000" dirty="0"/>
+              <a:t>Node 1: 0.214777 </a:t>
+            </a:r>
+          </a:p>
+          <a:p>
+            <a:r>
+              <a:rPr lang="en-US" sz="2000" dirty="0"/>
+              <a:t>Node 4: 0.178849</a:t>
+            </a:r>
+          </a:p>
+          <a:p>
+            <a:r>
+              <a:rPr lang="en-US" sz="2000" dirty="0"/>
+              <a:t>Node 6: 0.160739 </a:t>
+            </a:r>
+          </a:p>
+          <a:p>
+            <a:r>
+              <a:rPr lang="en-US" sz="2000" dirty="0"/>
+              <a:t>Node 16: 0.060915</a:t>
+            </a:r>
+          </a:p>
+        </p:txBody>
+      </p:sp>
+      <p:graphicFrame>
+        <p:nvGraphicFramePr>
+          <p:cNvPr id="6" name="Table 5">
+            <a:extLst>
+              <a:ext uri="{FF2B5EF4-FFF2-40B4-BE49-F238E27FC236}">
+                <a16:creationId xmlns:a16="http://schemas.microsoft.com/office/drawing/2014/main" id="{12CE1A74-3532-598C-DFE4-3C95E2F1AF02}"/>
+              </a:ext>
+            </a:extLst>
+          </p:cNvPr>
+          <p:cNvGraphicFramePr>
+            <a:graphicFrameLocks noGrp="1"/>
+          </p:cNvGraphicFramePr>
+          <p:nvPr>
+            <p:extLst>
+              <p:ext uri="{D42A27DB-BD31-4B8C-83A1-F6EECF244321}">
+                <p14:modId xmlns:p14="http://schemas.microsoft.com/office/powerpoint/2010/main" val="696217807"/>
+              </p:ext>
+            </p:extLst>
+          </p:nvPr>
+        </p:nvGraphicFramePr>
+        <p:xfrm>
+          <a:off x="1147533" y="2772084"/>
+          <a:ext cx="9683814" cy="2325345"/>
+        </p:xfrm>
+        <a:graphic>
+          <a:graphicData uri="http://schemas.openxmlformats.org/drawingml/2006/table">
+            <a:tbl>
+              <a:tblPr firstRow="1" bandRow="1">
+                <a:tableStyleId>{5C22544A-7EE6-4342-B048-85BDC9FD1C3A}</a:tableStyleId>
+              </a:tblPr>
+              <a:tblGrid>
+                <a:gridCol w="1827530">
+                  <a:extLst>
+                    <a:ext uri="{9D8B030D-6E8A-4147-A177-3AD203B41FA5}">
+                      <a16:colId xmlns:a16="http://schemas.microsoft.com/office/drawing/2014/main" val="3907867901"/>
+                    </a:ext>
+                  </a:extLst>
+                </a:gridCol>
+                <a:gridCol w="2790000">
+                  <a:extLst>
+                    <a:ext uri="{9D8B030D-6E8A-4147-A177-3AD203B41FA5}">
+                      <a16:colId xmlns:a16="http://schemas.microsoft.com/office/drawing/2014/main" val="2873117807"/>
+                    </a:ext>
+                  </a:extLst>
+                </a:gridCol>
+                <a:gridCol w="2642743">
+                  <a:extLst>
+                    <a:ext uri="{9D8B030D-6E8A-4147-A177-3AD203B41FA5}">
+                      <a16:colId xmlns:a16="http://schemas.microsoft.com/office/drawing/2014/main" val="3202549202"/>
+                    </a:ext>
+                  </a:extLst>
+                </a:gridCol>
+                <a:gridCol w="2423541">
+                  <a:extLst>
+                    <a:ext uri="{9D8B030D-6E8A-4147-A177-3AD203B41FA5}">
+                      <a16:colId xmlns:a16="http://schemas.microsoft.com/office/drawing/2014/main" val="1808895448"/>
+                    </a:ext>
+                  </a:extLst>
+                </a:gridCol>
+              </a:tblGrid>
+              <a:tr h="677973">
+                <a:tc>
+                  <a:txBody>
+                    <a:bodyPr/>
+                    <a:lstStyle/>
+                    <a:p>
+                      <a:r>
+                        <a:rPr lang="en-US" sz="2000" dirty="0"/>
+                        <a:t>Centrality Type</a:t>
+                      </a:r>
+                    </a:p>
+                  </a:txBody>
+                  <a:tcPr/>
+                </a:tc>
+                <a:tc>
+                  <a:txBody>
+                    <a:bodyPr/>
+                    <a:lstStyle/>
+                    <a:p>
+                      <a:r>
+                        <a:rPr lang="en-US" sz="2000" dirty="0"/>
+                        <a:t>Real Network</a:t>
+                      </a:r>
+                    </a:p>
+                  </a:txBody>
+                  <a:tcPr/>
+                </a:tc>
+                <a:tc>
+                  <a:txBody>
+                    <a:bodyPr/>
+                    <a:lstStyle/>
+                    <a:p>
+                      <a:r>
+                        <a:rPr lang="en-US" sz="2000" dirty="0"/>
+                        <a:t>Random Network</a:t>
+                      </a:r>
+                    </a:p>
+                  </a:txBody>
+                  <a:tcPr/>
+                </a:tc>
+                <a:tc>
+                  <a:txBody>
+                    <a:bodyPr/>
+                    <a:lstStyle/>
+                    <a:p>
+                      <a:r>
+                        <a:rPr lang="en-US" sz="2000" dirty="0"/>
+                        <a:t>Scale-free Network</a:t>
+                      </a:r>
+                    </a:p>
+                  </a:txBody>
+                  <a:tcPr/>
+                </a:tc>
+                <a:extLst>
+                  <a:ext uri="{0D108BD9-81ED-4DB2-BD59-A6C34878D82A}">
+                    <a16:rowId xmlns:a16="http://schemas.microsoft.com/office/drawing/2014/main" val="1630775892"/>
+                  </a:ext>
+                </a:extLst>
+              </a:tr>
+              <a:tr h="370840">
+                <a:tc>
+                  <a:txBody>
+                    <a:bodyPr/>
+                    <a:lstStyle/>
+                    <a:p>
+                      <a:r>
+                        <a:rPr lang="en-US" sz="2000" dirty="0"/>
+                        <a:t>Hubs(Degree)</a:t>
+                      </a:r>
+                    </a:p>
+                  </a:txBody>
+                  <a:tcPr/>
+                </a:tc>
+                <a:tc>
+                  <a:txBody>
+                    <a:bodyPr/>
+                    <a:lstStyle/>
+                    <a:p>
+                      <a:r>
+                        <a:rPr lang="en-US" sz="2000" dirty="0"/>
+                        <a:t>Node 44 (34 edges)</a:t>
+                      </a:r>
+                    </a:p>
+                  </a:txBody>
+                  <a:tcPr/>
+                </a:tc>
+                <a:tc>
+                  <a:txBody>
+                    <a:bodyPr/>
+                    <a:lstStyle/>
+                    <a:p>
+                      <a:r>
+                        <a:rPr lang="en-US" sz="2000" dirty="0"/>
+                        <a:t>Node 670 (12 edges)</a:t>
+                      </a:r>
+                    </a:p>
+                  </a:txBody>
+                  <a:tcPr/>
+                </a:tc>
+                <a:tc>
+                  <a:txBody>
+                    <a:bodyPr/>
+                    <a:lstStyle/>
+                    <a:p>
+                      <a:r>
+                        <a:rPr lang="en-US" sz="2000" dirty="0"/>
+                        <a:t>Node 0 (103 edges)</a:t>
+                      </a:r>
+                    </a:p>
+                  </a:txBody>
+                  <a:tcPr/>
+                </a:tc>
+                <a:extLst>
+                  <a:ext uri="{0D108BD9-81ED-4DB2-BD59-A6C34878D82A}">
+                    <a16:rowId xmlns:a16="http://schemas.microsoft.com/office/drawing/2014/main" val="3377972218"/>
+                  </a:ext>
+                </a:extLst>
+              </a:tr>
+              <a:tr h="370840">
+                <a:tc>
+                  <a:txBody>
+                    <a:bodyPr/>
+                    <a:lstStyle/>
+                    <a:p>
+                      <a:r>
+                        <a:rPr lang="en-US" sz="2000" dirty="0"/>
+                        <a:t>Insight</a:t>
+                      </a:r>
+                    </a:p>
+                  </a:txBody>
+                  <a:tcPr/>
+                </a:tc>
+                <a:tc>
+                  <a:txBody>
+                    <a:bodyPr/>
+                    <a:lstStyle/>
+                    <a:p>
+                      <a:r>
+                        <a:rPr lang="en-US" sz="2000" dirty="0"/>
+                        <a:t>Moderate Concentration</a:t>
+                      </a:r>
+                    </a:p>
+                  </a:txBody>
+                  <a:tcPr/>
+                </a:tc>
+                <a:tc>
+                  <a:txBody>
+                    <a:bodyPr/>
+                    <a:lstStyle/>
+                    <a:p>
+                      <a:r>
+                        <a:rPr lang="en-US" sz="2000" dirty="0"/>
+                        <a:t>Very flat</a:t>
+                      </a:r>
+                    </a:p>
+                  </a:txBody>
+                  <a:tcPr/>
+                </a:tc>
+                <a:tc>
+                  <a:txBody>
+                    <a:bodyPr/>
+                    <a:lstStyle/>
+                    <a:p>
+                      <a:r>
+                        <a:rPr lang="en-US" sz="2000" dirty="0"/>
+                        <a:t>Massive hub</a:t>
+                      </a:r>
+                    </a:p>
+                  </a:txBody>
+                  <a:tcPr/>
+                </a:tc>
+                <a:extLst>
+                  <a:ext uri="{0D108BD9-81ED-4DB2-BD59-A6C34878D82A}">
+                    <a16:rowId xmlns:a16="http://schemas.microsoft.com/office/drawing/2014/main" val="597515445"/>
+                  </a:ext>
+                </a:extLst>
+              </a:tr>
+              <a:tr h="458652">
+                <a:tc>
+                  <a:txBody>
+                    <a:bodyPr/>
+                    <a:lstStyle/>
+                    <a:p>
+                      <a:r>
+                        <a:rPr lang="en-US" sz="2000" dirty="0"/>
+                        <a:t>Betweenness</a:t>
+                      </a:r>
+                    </a:p>
+                  </a:txBody>
+                  <a:tcPr/>
+                </a:tc>
+                <a:tc>
+                  <a:txBody>
+                    <a:bodyPr/>
+                    <a:lstStyle/>
+                    <a:p>
+                      <a:r>
+                        <a:rPr lang="en-US" sz="2000" dirty="0"/>
+                        <a:t>Node 107 (0.022)</a:t>
+                      </a:r>
+                    </a:p>
+                  </a:txBody>
+                  <a:tcPr/>
+                </a:tc>
+                <a:tc>
+                  <a:txBody>
+                    <a:bodyPr/>
+                    <a:lstStyle/>
+                    <a:p>
+                      <a:r>
+                        <a:rPr lang="en-US" sz="2000" dirty="0"/>
+                        <a:t>Node 1063 (0.022)</a:t>
+                      </a:r>
+                    </a:p>
+                  </a:txBody>
+                  <a:tcPr/>
+                </a:tc>
+                <a:tc>
+                  <a:txBody>
+                    <a:bodyPr/>
+                    <a:lstStyle/>
+                    <a:p>
+                      <a:r>
+                        <a:rPr lang="en-US" sz="2000" dirty="0"/>
+                        <a:t>Node 0 (0.24)</a:t>
+                      </a:r>
+                    </a:p>
+                  </a:txBody>
+                  <a:tcPr/>
+                </a:tc>
+                <a:extLst>
+                  <a:ext uri="{0D108BD9-81ED-4DB2-BD59-A6C34878D82A}">
+                    <a16:rowId xmlns:a16="http://schemas.microsoft.com/office/drawing/2014/main" val="2362316916"/>
+                  </a:ext>
+                </a:extLst>
+              </a:tr>
+              <a:tr h="370840">
+                <a:tc>
+                  <a:txBody>
+                    <a:bodyPr/>
+                    <a:lstStyle/>
+                    <a:p>
+                      <a:r>
+                        <a:rPr lang="en-US" sz="2000" dirty="0"/>
+                        <a:t>Insight</a:t>
+                      </a:r>
+                    </a:p>
+                  </a:txBody>
+                  <a:tcPr/>
+                </a:tc>
+                <a:tc>
+                  <a:txBody>
+                    <a:bodyPr/>
+                    <a:lstStyle/>
+                    <a:p>
+                      <a:r>
+                        <a:rPr lang="en-US" sz="2000" dirty="0"/>
+                        <a:t>Strategic connectors</a:t>
+                      </a:r>
+                    </a:p>
+                  </a:txBody>
+                  <a:tcPr/>
+                </a:tc>
+                <a:tc>
+                  <a:txBody>
+                    <a:bodyPr/>
+                    <a:lstStyle/>
+                    <a:p>
+                      <a:r>
+                        <a:rPr lang="en-US" sz="2000" dirty="0"/>
+                        <a:t>Distributed importance</a:t>
+                      </a:r>
+                    </a:p>
+                  </a:txBody>
+                  <a:tcPr/>
+                </a:tc>
+                <a:tc>
+                  <a:txBody>
+                    <a:bodyPr/>
+                    <a:lstStyle/>
+                    <a:p>
+                      <a:r>
+                        <a:rPr lang="en-US" sz="2000" dirty="0"/>
+                        <a:t>Structural Bottleneck</a:t>
+                      </a:r>
+                    </a:p>
+                  </a:txBody>
+                  <a:tcPr/>
+                </a:tc>
+                <a:extLst>
+                  <a:ext uri="{0D108BD9-81ED-4DB2-BD59-A6C34878D82A}">
+                    <a16:rowId xmlns:a16="http://schemas.microsoft.com/office/drawing/2014/main" val="3473861958"/>
+                  </a:ext>
+                </a:extLst>
+              </a:tr>
+            </a:tbl>
+          </a:graphicData>
+        </a:graphic>
+      </p:graphicFrame>
+    </p:spTree>
+    <p:extLst>
+      <p:ext uri="{BB962C8B-B14F-4D97-AF65-F5344CB8AC3E}">
+        <p14:creationId xmlns:p14="http://schemas.microsoft.com/office/powerpoint/2010/main" val="1327103432"/>
+      </p:ext>
+    </p:extLst>
+  </p:cSld>
+  <p:clrMapOvr>
+    <a:masterClrMapping/>
+  </p:clrMapOvr>
+</p:sld>
+</file>
+
+<file path=ppt/slides/slide14.xml><?xml version="1.0" encoding="utf-8"?>
+<p:sld xmlns:a="http://schemas.openxmlformats.org/drawingml/2006/main" xmlns:r="http://schemas.openxmlformats.org/officeDocument/2006/relationships" xmlns:p="http://schemas.openxmlformats.org/presentationml/2006/main">
+  <p:cSld>
+    <p:spTree>
+      <p:nvGrpSpPr>
+        <p:cNvPr id="1" name=""/>
+        <p:cNvGrpSpPr/>
+        <p:nvPr/>
+      </p:nvGrpSpPr>
+      <p:grpSpPr>
+        <a:xfrm>
+          <a:off x="0" y="0"/>
+          <a:ext cx="0" cy="0"/>
+          <a:chOff x="0" y="0"/>
+          <a:chExt cx="0" cy="0"/>
+        </a:xfrm>
+      </p:grpSpPr>
+      <p:sp>
+        <p:nvSpPr>
+          <p:cNvPr id="2" name="Title 1">
+            <a:extLst>
+              <a:ext uri="{FF2B5EF4-FFF2-40B4-BE49-F238E27FC236}">
+                <a16:creationId xmlns:a16="http://schemas.microsoft.com/office/drawing/2014/main" id="{5DC2F755-FA74-89D1-AB53-CBFDF8CB5DEC}"/>
+              </a:ext>
+            </a:extLst>
+          </p:cNvPr>
+          <p:cNvSpPr>
+            <a:spLocks noGrp="1"/>
+          </p:cNvSpPr>
+          <p:nvPr>
+            <p:ph type="title"/>
+          </p:nvPr>
+        </p:nvSpPr>
+        <p:spPr/>
+        <p:txBody>
+          <a:bodyPr>
+            <a:normAutofit/>
+          </a:bodyPr>
+          <a:lstStyle/>
+          <a:p>
+            <a:r>
+              <a:rPr lang="en-US" sz="3600" b="1" dirty="0"/>
+              <a:t>What type of network is the selected real network?</a:t>
+            </a:r>
+          </a:p>
+        </p:txBody>
+      </p:sp>
+      <p:sp>
+        <p:nvSpPr>
+          <p:cNvPr id="3" name="Content Placeholder 2">
+            <a:extLst>
+              <a:ext uri="{FF2B5EF4-FFF2-40B4-BE49-F238E27FC236}">
+                <a16:creationId xmlns:a16="http://schemas.microsoft.com/office/drawing/2014/main" id="{53670E19-1A00-7C37-3B63-9C311043CFE5}"/>
+              </a:ext>
+            </a:extLst>
+          </p:cNvPr>
+          <p:cNvSpPr>
+            <a:spLocks noGrp="1"/>
+          </p:cNvSpPr>
+          <p:nvPr>
+            <p:ph idx="1"/>
+          </p:nvPr>
+        </p:nvSpPr>
+        <p:spPr/>
+        <p:txBody>
+          <a:bodyPr>
+            <a:normAutofit/>
+          </a:bodyPr>
+          <a:lstStyle/>
+          <a:p>
+            <a:pPr marL="0" indent="0">
+              <a:buNone/>
+            </a:pPr>
+            <a:r>
+              <a:rPr lang="en-US" sz="2000" dirty="0"/>
+              <a:t>The </a:t>
+            </a:r>
+            <a:r>
+              <a:rPr lang="en-US" sz="2000" b="1" dirty="0"/>
+              <a:t>dimacs10-netscience</a:t>
+            </a:r>
+            <a:r>
+              <a:rPr lang="en-US" sz="2000" dirty="0"/>
+              <a:t> dataset is an undirected network of co-authorships in the area of network science. </a:t>
+            </a:r>
+          </a:p>
+          <a:p>
+            <a:pPr marL="0" indent="0">
+              <a:buNone/>
+            </a:pPr>
+            <a:endParaRPr lang="en-US" sz="2000" dirty="0"/>
+          </a:p>
+          <a:p>
+            <a:pPr marL="0" indent="0">
+              <a:buNone/>
+            </a:pPr>
+            <a:r>
+              <a:rPr lang="en-US" sz="2000" b="1" dirty="0"/>
+              <a:t>Significance &amp; Meaning:</a:t>
+            </a:r>
+            <a:r>
+              <a:rPr lang="en-US" sz="2000" dirty="0"/>
+              <a:t> Nodes represent authors (researchers), and links represent a co-authorship between them (they have written a paper together).</a:t>
+            </a:r>
+          </a:p>
+          <a:p>
+            <a:pPr marL="0" indent="0">
+              <a:buNone/>
+            </a:pPr>
+            <a:endParaRPr lang="en-US" sz="2000" dirty="0"/>
+          </a:p>
+          <a:p>
+            <a:pPr marL="0" indent="0">
+              <a:buNone/>
+            </a:pPr>
+            <a:r>
+              <a:rPr lang="en-US" sz="2000" b="1" dirty="0"/>
+              <a:t>Type of Network:</a:t>
+            </a:r>
+            <a:r>
+              <a:rPr lang="en-US" sz="2000" dirty="0"/>
+              <a:t> It is a </a:t>
+            </a:r>
+            <a:r>
+              <a:rPr lang="en-US" sz="2000" b="1" dirty="0"/>
+              <a:t>Co-authorship/Collaboration Network</a:t>
+            </a:r>
+            <a:r>
+              <a:rPr lang="en-US" sz="2000" dirty="0"/>
+              <a:t>. Because it reflects human collaboration and distinct research communities, it exhibits "small-world" properties (a high clustering coefficient, as co-authors of a researcher are very likely to co-author with each other) and "scale-free" characteristics (a heavy-tailed degree distribution where a few highly published researchers act as massive hubs). We can observe these hallmarks by comparing its structural metrics to the Erdős-Rényi and </a:t>
+            </a:r>
+            <a:r>
+              <a:rPr lang="en-US" sz="2000" dirty="0" err="1"/>
+              <a:t>Barabási</a:t>
+            </a:r>
+            <a:r>
+              <a:rPr lang="en-US" sz="2000" dirty="0"/>
+              <a:t>-Albert models.</a:t>
+            </a:r>
+          </a:p>
+          <a:p>
+            <a:endParaRPr lang="en-US" sz="2000" dirty="0"/>
+          </a:p>
+        </p:txBody>
+      </p:sp>
+    </p:spTree>
+    <p:extLst>
+      <p:ext uri="{BB962C8B-B14F-4D97-AF65-F5344CB8AC3E}">
+        <p14:creationId xmlns:p14="http://schemas.microsoft.com/office/powerpoint/2010/main" val="978290815"/>
+      </p:ext>
+    </p:extLst>
   </p:cSld>
   <p:clrMapOvr>
     <a:masterClrMapping/>
@@ -3179,6 +4691,7 @@
           <a:lstStyle/>
           <a:p>
             <a:r>
+              <a:rPr dirty="0"/>
               <a:t>Dataset Overview</a:t>
             </a:r>
           </a:p>
@@ -3192,8 +4705,8 @@
         </p:nvSpPr>
         <p:spPr>
           <a:xfrm>
-            <a:off x="731520" y="1280160"/>
-            <a:ext cx="10698480" cy="4754880"/>
+            <a:off x="2255521" y="1280160"/>
+            <a:ext cx="7010317" cy="1569660"/>
           </a:xfrm>
           <a:prstGeom prst="rect">
             <a:avLst/>
@@ -3210,7 +4723,7 @@
               <a:defRPr sz="2400"/>
             </a:pPr>
             <a:r>
-              <a:rPr dirty="0"/>
+              <a:rPr sz="2400" dirty="0"/>
               <a:t>Dataset: dimacs10-netscience (co-authorship network)</a:t>
             </a:r>
           </a:p>
@@ -3219,7 +4732,7 @@
               <a:defRPr sz="2400"/>
             </a:pPr>
             <a:r>
-              <a:rPr dirty="0"/>
+              <a:rPr sz="2400" dirty="0"/>
               <a:t>Nodes (authors): 1461</a:t>
             </a:r>
           </a:p>
@@ -3228,7 +4741,7 @@
               <a:defRPr sz="2400"/>
             </a:pPr>
             <a:r>
-              <a:rPr dirty="0"/>
+              <a:rPr sz="2400" dirty="0"/>
               <a:t>Edges (co-authorship links): 2742</a:t>
             </a:r>
           </a:p>
@@ -3237,7 +4750,7 @@
               <a:defRPr sz="2400"/>
             </a:pPr>
             <a:r>
-              <a:rPr dirty="0"/>
+              <a:rPr sz="2400" dirty="0"/>
               <a:t>Graph type: undirected, unweighted, no self-loops</a:t>
             </a:r>
           </a:p>
@@ -3297,7 +4810,7 @@
         </p:nvSpPr>
         <p:spPr>
           <a:xfrm>
-            <a:off x="731520" y="1280160"/>
+            <a:off x="2255520" y="1280160"/>
             <a:ext cx="7818872" cy="1938992"/>
           </a:xfrm>
           <a:prstGeom prst="rect">
@@ -3315,15 +4828,15 @@
               <a:defRPr sz="2400"/>
             </a:pPr>
             <a:r>
-              <a:rPr dirty="0"/>
+              <a:rPr sz="2400" dirty="0"/>
               <a:t>Null model 1: </a:t>
             </a:r>
             <a:r>
-              <a:rPr dirty="0" err="1"/>
+              <a:rPr sz="2400" dirty="0" err="1"/>
               <a:t>Erdos-Renyi</a:t>
             </a:r>
             <a:r>
-              <a:rPr dirty="0"/>
+              <a:rPr sz="2400" dirty="0"/>
               <a:t> G(n, p) using real-network density</a:t>
             </a:r>
           </a:p>
@@ -3332,15 +4845,15 @@
               <a:defRPr sz="2400"/>
             </a:pPr>
             <a:r>
-              <a:rPr dirty="0"/>
+              <a:rPr sz="2400" dirty="0"/>
               <a:t>Null model 2: </a:t>
             </a:r>
             <a:r>
-              <a:rPr dirty="0" err="1"/>
+              <a:rPr sz="2400" dirty="0" err="1"/>
               <a:t>Barabasi</a:t>
             </a:r>
             <a:r>
-              <a:rPr dirty="0"/>
+              <a:rPr sz="2400" dirty="0"/>
               <a:t>-Albert using m ~ M/N</a:t>
             </a:r>
           </a:p>
@@ -3349,17 +4862,17 @@
               <a:defRPr sz="2400"/>
             </a:pPr>
             <a:r>
-              <a:rPr dirty="0"/>
+              <a:rPr sz="2400" dirty="0"/>
               <a:t>Purpose: compare random, preferential-attachment, and real</a:t>
             </a:r>
-            <a:endParaRPr lang="en-US" dirty="0"/>
+            <a:endParaRPr lang="en-US" sz="2400" dirty="0"/>
           </a:p>
           <a:p>
             <a:pPr>
               <a:defRPr sz="2400"/>
             </a:pPr>
             <a:r>
-              <a:rPr dirty="0"/>
+              <a:rPr sz="2400" dirty="0"/>
               <a:t>collaboration structure</a:t>
             </a:r>
           </a:p>
@@ -3368,7 +4881,7 @@
               <a:defRPr sz="2400"/>
             </a:pPr>
             <a:r>
-              <a:rPr dirty="0"/>
+              <a:rPr sz="2400" dirty="0"/>
               <a:t>ER p used: 0.002571; BA m used: 2</a:t>
             </a:r>
           </a:p>
@@ -3436,7 +4949,7 @@
         </p:blipFill>
         <p:spPr>
           <a:xfrm>
-            <a:off x="531561" y="2100997"/>
+            <a:off x="2055562" y="2100998"/>
             <a:ext cx="8080877" cy="2656005"/>
           </a:xfrm>
           <a:prstGeom prst="rect">
@@ -3506,7 +5019,7 @@
         </p:blipFill>
         <p:spPr>
           <a:xfrm>
-            <a:off x="559525" y="2444878"/>
+            <a:off x="2083526" y="2444879"/>
             <a:ext cx="8024949" cy="1968243"/>
           </a:xfrm>
           <a:prstGeom prst="rect">
@@ -3568,7 +5081,7 @@
         </p:nvSpPr>
         <p:spPr>
           <a:xfrm>
-            <a:off x="731520" y="1280160"/>
+            <a:off x="2255520" y="1280160"/>
             <a:ext cx="6787114" cy="1938992"/>
           </a:xfrm>
           <a:prstGeom prst="rect">
@@ -3586,7 +5099,7 @@
               <a:defRPr sz="2400"/>
             </a:pPr>
             <a:r>
-              <a:rPr dirty="0"/>
+              <a:rPr sz="2400" dirty="0"/>
               <a:t>Real graph clustering is high: 0.694</a:t>
             </a:r>
           </a:p>
@@ -3595,7 +5108,7 @@
               <a:defRPr sz="2400"/>
             </a:pPr>
             <a:r>
-              <a:rPr dirty="0"/>
+              <a:rPr sz="2400" dirty="0"/>
               <a:t>ER clustering is very low: 0.004</a:t>
             </a:r>
           </a:p>
@@ -3604,7 +5117,7 @@
               <a:defRPr sz="2400"/>
             </a:pPr>
             <a:r>
-              <a:rPr dirty="0"/>
+              <a:rPr sz="2400" dirty="0"/>
               <a:t>BA max degree is much larger than ER: 103 vs 12</a:t>
             </a:r>
           </a:p>
@@ -3613,17 +5126,17 @@
               <a:defRPr sz="2400"/>
             </a:pPr>
             <a:r>
-              <a:rPr dirty="0"/>
+              <a:rPr sz="2400" dirty="0"/>
               <a:t>Interpretation: real network shows both small-world </a:t>
             </a:r>
-            <a:endParaRPr lang="en-US" dirty="0"/>
+            <a:endParaRPr lang="en-US" sz="2400" dirty="0"/>
           </a:p>
           <a:p>
             <a:pPr>
               <a:defRPr sz="2400"/>
             </a:pPr>
             <a:r>
-              <a:rPr dirty="0"/>
+              <a:rPr sz="2400" dirty="0"/>
               <a:t>clustering and hub structure</a:t>
             </a:r>
           </a:p>
@@ -3683,7 +5196,7 @@
         </p:nvSpPr>
         <p:spPr>
           <a:xfrm>
-            <a:off x="731520" y="1280160"/>
+            <a:off x="2255520" y="1280160"/>
             <a:ext cx="7105984" cy="1938992"/>
           </a:xfrm>
           <a:prstGeom prst="rect">
@@ -3701,7 +5214,7 @@
               <a:defRPr sz="2400"/>
             </a:pPr>
             <a:r>
-              <a:rPr dirty="0"/>
+              <a:rPr sz="2400" dirty="0"/>
               <a:t>Real: components=268, LCC=379, diameter=17</a:t>
             </a:r>
           </a:p>
@@ -3710,7 +5223,7 @@
               <a:defRPr sz="2400"/>
             </a:pPr>
             <a:r>
-              <a:rPr dirty="0"/>
+              <a:rPr sz="2400" dirty="0"/>
               <a:t>ER: components=46, LCC=1415, diameter=12</a:t>
             </a:r>
           </a:p>
@@ -3719,7 +5232,7 @@
               <a:defRPr sz="2400"/>
             </a:pPr>
             <a:r>
-              <a:rPr dirty="0"/>
+              <a:rPr sz="2400" dirty="0"/>
               <a:t>BA: components=1, LCC=1461, diameter=8</a:t>
             </a:r>
           </a:p>
@@ -3728,23 +5241,816 @@
               <a:defRPr sz="2400"/>
             </a:pPr>
             <a:r>
-              <a:rPr dirty="0"/>
+              <a:rPr sz="2400" dirty="0"/>
               <a:t>Conclusion: real collaboration is neither purely random </a:t>
             </a:r>
-            <a:endParaRPr lang="en-US" dirty="0"/>
+            <a:endParaRPr lang="en-US" sz="2400" dirty="0"/>
           </a:p>
           <a:p>
             <a:pPr>
               <a:defRPr sz="2400"/>
             </a:pPr>
             <a:r>
-              <a:rPr dirty="0"/>
+              <a:rPr sz="2400" dirty="0"/>
               <a:t>nor purely preferential attachment</a:t>
             </a:r>
           </a:p>
         </p:txBody>
       </p:sp>
     </p:spTree>
+  </p:cSld>
+  <p:clrMapOvr>
+    <a:masterClrMapping/>
+  </p:clrMapOvr>
+</p:sld>
+</file>
+
+<file path=ppt/slides/slide8.xml><?xml version="1.0" encoding="utf-8"?>
+<p:sld xmlns:a="http://schemas.openxmlformats.org/drawingml/2006/main" xmlns:r="http://schemas.openxmlformats.org/officeDocument/2006/relationships" xmlns:p="http://schemas.openxmlformats.org/presentationml/2006/main">
+  <p:cSld>
+    <p:spTree>
+      <p:nvGrpSpPr>
+        <p:cNvPr id="1" name=""/>
+        <p:cNvGrpSpPr/>
+        <p:nvPr/>
+      </p:nvGrpSpPr>
+      <p:grpSpPr>
+        <a:xfrm>
+          <a:off x="0" y="0"/>
+          <a:ext cx="0" cy="0"/>
+          <a:chOff x="0" y="0"/>
+          <a:chExt cx="0" cy="0"/>
+        </a:xfrm>
+      </p:grpSpPr>
+      <p:sp>
+        <p:nvSpPr>
+          <p:cNvPr id="2" name="Title 1">
+            <a:extLst>
+              <a:ext uri="{FF2B5EF4-FFF2-40B4-BE49-F238E27FC236}">
+                <a16:creationId xmlns:a16="http://schemas.microsoft.com/office/drawing/2014/main" id="{FB130DDC-2453-78F8-C678-F51482938D1F}"/>
+              </a:ext>
+            </a:extLst>
+          </p:cNvPr>
+          <p:cNvSpPr>
+            <a:spLocks noGrp="1"/>
+          </p:cNvSpPr>
+          <p:nvPr>
+            <p:ph type="title"/>
+          </p:nvPr>
+        </p:nvSpPr>
+        <p:spPr/>
+        <p:txBody>
+          <a:bodyPr>
+            <a:normAutofit/>
+          </a:bodyPr>
+          <a:lstStyle/>
+          <a:p>
+            <a:r>
+              <a:rPr lang="en-US" sz="3600" b="1" dirty="0"/>
+              <a:t>Network Description</a:t>
+            </a:r>
+          </a:p>
+        </p:txBody>
+      </p:sp>
+      <p:sp>
+        <p:nvSpPr>
+          <p:cNvPr id="3" name="Content Placeholder 2">
+            <a:extLst>
+              <a:ext uri="{FF2B5EF4-FFF2-40B4-BE49-F238E27FC236}">
+                <a16:creationId xmlns:a16="http://schemas.microsoft.com/office/drawing/2014/main" id="{6CB4BB62-872C-8532-AE7B-F4092C482C11}"/>
+              </a:ext>
+            </a:extLst>
+          </p:cNvPr>
+          <p:cNvSpPr>
+            <a:spLocks noGrp="1"/>
+          </p:cNvSpPr>
+          <p:nvPr>
+            <p:ph idx="1"/>
+          </p:nvPr>
+        </p:nvSpPr>
+        <p:spPr/>
+        <p:txBody>
+          <a:bodyPr>
+            <a:normAutofit lnSpcReduction="10000"/>
+          </a:bodyPr>
+          <a:lstStyle/>
+          <a:p>
+            <a:pPr marL="0" indent="0">
+              <a:buNone/>
+              <a:defRPr sz="2400"/>
+            </a:pPr>
+            <a:r>
+              <a:rPr lang="en-US" sz="2400" b="1" dirty="0"/>
+              <a:t>dimacs10-netscience (co-authorship network)</a:t>
+            </a:r>
+          </a:p>
+          <a:p>
+            <a:pPr>
+              <a:defRPr sz="2400"/>
+            </a:pPr>
+            <a:r>
+              <a:rPr lang="en-US" sz="2000" dirty="0"/>
+              <a:t>Nodes (authors): 1461</a:t>
+            </a:r>
+          </a:p>
+          <a:p>
+            <a:pPr>
+              <a:defRPr sz="2400"/>
+            </a:pPr>
+            <a:r>
+              <a:rPr lang="en-US" sz="2000" dirty="0"/>
+              <a:t>Edges (co-authorship links): 2742</a:t>
+            </a:r>
+          </a:p>
+          <a:p>
+            <a:pPr>
+              <a:defRPr sz="2400"/>
+            </a:pPr>
+            <a:r>
+              <a:rPr lang="en-US" sz="2000" dirty="0"/>
+              <a:t>Graph type: undirected, unweighted, no self-loops</a:t>
+            </a:r>
+          </a:p>
+          <a:p>
+            <a:pPr>
+              <a:defRPr sz="2400"/>
+            </a:pPr>
+            <a:endParaRPr lang="en-US" sz="2000" dirty="0"/>
+          </a:p>
+          <a:p>
+            <a:pPr marL="0" indent="0">
+              <a:buNone/>
+              <a:defRPr sz="2400"/>
+            </a:pPr>
+            <a:r>
+              <a:rPr lang="en-US" sz="2400" b="1" dirty="0"/>
+              <a:t>Random Network: Erdos-</a:t>
+            </a:r>
+            <a:r>
+              <a:rPr lang="en-US" sz="2400" b="1" dirty="0" err="1"/>
+              <a:t>Renyi</a:t>
+            </a:r>
+            <a:r>
+              <a:rPr lang="en-US" sz="2400" b="1" dirty="0"/>
+              <a:t> model</a:t>
+            </a:r>
+          </a:p>
+          <a:p>
+            <a:pPr>
+              <a:defRPr sz="2400"/>
+            </a:pPr>
+            <a:r>
+              <a:rPr lang="en-US" sz="2000" dirty="0"/>
+              <a:t>Nodes: 1461</a:t>
+            </a:r>
+          </a:p>
+          <a:p>
+            <a:pPr>
+              <a:defRPr sz="2400"/>
+            </a:pPr>
+            <a:r>
+              <a:rPr lang="en-US" sz="2000" dirty="0"/>
+              <a:t>Edges: 2728</a:t>
+            </a:r>
+          </a:p>
+          <a:p>
+            <a:pPr>
+              <a:defRPr sz="2400"/>
+            </a:pPr>
+            <a:endParaRPr lang="en-US" sz="2000" dirty="0"/>
+          </a:p>
+          <a:p>
+            <a:pPr marL="0" indent="0">
+              <a:buNone/>
+              <a:defRPr sz="2400"/>
+            </a:pPr>
+            <a:r>
+              <a:rPr lang="en-US" sz="2400" b="1" dirty="0"/>
+              <a:t>Scale-free Network: </a:t>
+            </a:r>
+            <a:r>
+              <a:rPr lang="en-US" sz="2400" b="1" dirty="0" err="1"/>
+              <a:t>Barabasi</a:t>
+            </a:r>
+            <a:r>
+              <a:rPr lang="en-US" sz="2400" b="1" dirty="0"/>
+              <a:t>-Albert model</a:t>
+            </a:r>
+          </a:p>
+          <a:p>
+            <a:pPr>
+              <a:defRPr sz="2400"/>
+            </a:pPr>
+            <a:r>
+              <a:rPr lang="en-US" sz="2000" dirty="0"/>
+              <a:t>Nodes: 1461</a:t>
+            </a:r>
+          </a:p>
+          <a:p>
+            <a:pPr>
+              <a:defRPr sz="2400"/>
+            </a:pPr>
+            <a:r>
+              <a:rPr lang="en-US" sz="2000" dirty="0"/>
+              <a:t>Edges: 2918</a:t>
+            </a:r>
+          </a:p>
+        </p:txBody>
+      </p:sp>
+    </p:spTree>
+    <p:extLst>
+      <p:ext uri="{BB962C8B-B14F-4D97-AF65-F5344CB8AC3E}">
+        <p14:creationId xmlns:p14="http://schemas.microsoft.com/office/powerpoint/2010/main" val="2281326393"/>
+      </p:ext>
+    </p:extLst>
+  </p:cSld>
+  <p:clrMapOvr>
+    <a:masterClrMapping/>
+  </p:clrMapOvr>
+</p:sld>
+</file>
+
+<file path=ppt/slides/slide9.xml><?xml version="1.0" encoding="utf-8"?>
+<p:sld xmlns:a="http://schemas.openxmlformats.org/drawingml/2006/main" xmlns:r="http://schemas.openxmlformats.org/officeDocument/2006/relationships" xmlns:p="http://schemas.openxmlformats.org/presentationml/2006/main">
+  <p:cSld>
+    <p:spTree>
+      <p:nvGrpSpPr>
+        <p:cNvPr id="1" name=""/>
+        <p:cNvGrpSpPr/>
+        <p:nvPr/>
+      </p:nvGrpSpPr>
+      <p:grpSpPr>
+        <a:xfrm>
+          <a:off x="0" y="0"/>
+          <a:ext cx="0" cy="0"/>
+          <a:chOff x="0" y="0"/>
+          <a:chExt cx="0" cy="0"/>
+        </a:xfrm>
+      </p:grpSpPr>
+      <p:sp>
+        <p:nvSpPr>
+          <p:cNvPr id="2" name="Title 1">
+            <a:extLst>
+              <a:ext uri="{FF2B5EF4-FFF2-40B4-BE49-F238E27FC236}">
+                <a16:creationId xmlns:a16="http://schemas.microsoft.com/office/drawing/2014/main" id="{A3CA0CB8-73ED-02B6-1533-4A33527E686C}"/>
+              </a:ext>
+            </a:extLst>
+          </p:cNvPr>
+          <p:cNvSpPr>
+            <a:spLocks noGrp="1"/>
+          </p:cNvSpPr>
+          <p:nvPr>
+            <p:ph type="title"/>
+          </p:nvPr>
+        </p:nvSpPr>
+        <p:spPr/>
+        <p:txBody>
+          <a:bodyPr>
+            <a:normAutofit/>
+          </a:bodyPr>
+          <a:lstStyle/>
+          <a:p>
+            <a:r>
+              <a:rPr lang="en-US" sz="3600" b="1" dirty="0"/>
+              <a:t>Network Properties</a:t>
+            </a:r>
+          </a:p>
+        </p:txBody>
+      </p:sp>
+      <p:graphicFrame>
+        <p:nvGraphicFramePr>
+          <p:cNvPr id="5" name="Table 4">
+            <a:extLst>
+              <a:ext uri="{FF2B5EF4-FFF2-40B4-BE49-F238E27FC236}">
+                <a16:creationId xmlns:a16="http://schemas.microsoft.com/office/drawing/2014/main" id="{8902F6E5-D50D-156C-6973-88B90B218EE6}"/>
+              </a:ext>
+            </a:extLst>
+          </p:cNvPr>
+          <p:cNvGraphicFramePr>
+            <a:graphicFrameLocks noGrp="1"/>
+          </p:cNvGraphicFramePr>
+          <p:nvPr>
+            <p:extLst>
+              <p:ext uri="{D42A27DB-BD31-4B8C-83A1-F6EECF244321}">
+                <p14:modId xmlns:p14="http://schemas.microsoft.com/office/powerpoint/2010/main" val="2179173524"/>
+              </p:ext>
+            </p:extLst>
+          </p:nvPr>
+        </p:nvGraphicFramePr>
+        <p:xfrm>
+          <a:off x="1595025" y="2048958"/>
+          <a:ext cx="9001949" cy="2765637"/>
+        </p:xfrm>
+        <a:graphic>
+          <a:graphicData uri="http://schemas.openxmlformats.org/drawingml/2006/table">
+            <a:tbl>
+              <a:tblPr firstRow="1" bandRow="1">
+                <a:tableStyleId>{5C22544A-7EE6-4342-B048-85BDC9FD1C3A}</a:tableStyleId>
+              </a:tblPr>
+              <a:tblGrid>
+                <a:gridCol w="3281297">
+                  <a:extLst>
+                    <a:ext uri="{9D8B030D-6E8A-4147-A177-3AD203B41FA5}">
+                      <a16:colId xmlns:a16="http://schemas.microsoft.com/office/drawing/2014/main" val="3737601808"/>
+                    </a:ext>
+                  </a:extLst>
+                </a:gridCol>
+                <a:gridCol w="1827213">
+                  <a:extLst>
+                    <a:ext uri="{9D8B030D-6E8A-4147-A177-3AD203B41FA5}">
+                      <a16:colId xmlns:a16="http://schemas.microsoft.com/office/drawing/2014/main" val="2060914983"/>
+                    </a:ext>
+                  </a:extLst>
+                </a:gridCol>
+                <a:gridCol w="1876425">
+                  <a:extLst>
+                    <a:ext uri="{9D8B030D-6E8A-4147-A177-3AD203B41FA5}">
+                      <a16:colId xmlns:a16="http://schemas.microsoft.com/office/drawing/2014/main" val="1384432102"/>
+                    </a:ext>
+                  </a:extLst>
+                </a:gridCol>
+                <a:gridCol w="2017014">
+                  <a:extLst>
+                    <a:ext uri="{9D8B030D-6E8A-4147-A177-3AD203B41FA5}">
+                      <a16:colId xmlns:a16="http://schemas.microsoft.com/office/drawing/2014/main" val="1731971228"/>
+                    </a:ext>
+                  </a:extLst>
+                </a:gridCol>
+              </a:tblGrid>
+              <a:tr h="388197">
+                <a:tc>
+                  <a:txBody>
+                    <a:bodyPr/>
+                    <a:lstStyle/>
+                    <a:p>
+                      <a:endParaRPr lang="en-US"/>
+                    </a:p>
+                  </a:txBody>
+                  <a:tcPr/>
+                </a:tc>
+                <a:tc>
+                  <a:txBody>
+                    <a:bodyPr/>
+                    <a:lstStyle/>
+                    <a:p>
+                      <a:r>
+                        <a:rPr lang="en-US" dirty="0"/>
+                        <a:t>Real network</a:t>
+                      </a:r>
+                    </a:p>
+                  </a:txBody>
+                  <a:tcPr/>
+                </a:tc>
+                <a:tc>
+                  <a:txBody>
+                    <a:bodyPr/>
+                    <a:lstStyle/>
+                    <a:p>
+                      <a:r>
+                        <a:rPr lang="en-US" dirty="0"/>
+                        <a:t>Random network</a:t>
+                      </a:r>
+                    </a:p>
+                  </a:txBody>
+                  <a:tcPr/>
+                </a:tc>
+                <a:tc>
+                  <a:txBody>
+                    <a:bodyPr/>
+                    <a:lstStyle/>
+                    <a:p>
+                      <a:r>
+                        <a:rPr lang="en-US" dirty="0"/>
+                        <a:t>Scale-free network</a:t>
+                      </a:r>
+                    </a:p>
+                  </a:txBody>
+                  <a:tcPr/>
+                </a:tc>
+                <a:extLst>
+                  <a:ext uri="{0D108BD9-81ED-4DB2-BD59-A6C34878D82A}">
+                    <a16:rowId xmlns:a16="http://schemas.microsoft.com/office/drawing/2014/main" val="2364562667"/>
+                  </a:ext>
+                </a:extLst>
+              </a:tr>
+              <a:tr h="388197">
+                <a:tc>
+                  <a:txBody>
+                    <a:bodyPr/>
+                    <a:lstStyle/>
+                    <a:p>
+                      <a:r>
+                        <a:rPr lang="en-US" sz="2000" dirty="0"/>
+                        <a:t>Min/Max/Average Degree</a:t>
+                      </a:r>
+                    </a:p>
+                  </a:txBody>
+                  <a:tcPr/>
+                </a:tc>
+                <a:tc>
+                  <a:txBody>
+                    <a:bodyPr/>
+                    <a:lstStyle/>
+                    <a:p>
+                      <a:r>
+                        <a:rPr lang="en-US" sz="2000" dirty="0"/>
+                        <a:t>1 / 34 / 3.75</a:t>
+                      </a:r>
+                    </a:p>
+                  </a:txBody>
+                  <a:tcPr/>
+                </a:tc>
+                <a:tc>
+                  <a:txBody>
+                    <a:bodyPr/>
+                    <a:lstStyle/>
+                    <a:p>
+                      <a:r>
+                        <a:rPr lang="en-US" sz="2000" dirty="0"/>
+                        <a:t>0 / 12 / 3.73</a:t>
+                      </a:r>
+                    </a:p>
+                  </a:txBody>
+                  <a:tcPr/>
+                </a:tc>
+                <a:tc>
+                  <a:txBody>
+                    <a:bodyPr/>
+                    <a:lstStyle/>
+                    <a:p>
+                      <a:r>
+                        <a:rPr lang="en-US" sz="2000" dirty="0"/>
+                        <a:t>2 / 103 / 3.99</a:t>
+                      </a:r>
+                    </a:p>
+                  </a:txBody>
+                  <a:tcPr/>
+                </a:tc>
+                <a:extLst>
+                  <a:ext uri="{0D108BD9-81ED-4DB2-BD59-A6C34878D82A}">
+                    <a16:rowId xmlns:a16="http://schemas.microsoft.com/office/drawing/2014/main" val="2366982699"/>
+                  </a:ext>
+                </a:extLst>
+              </a:tr>
+              <a:tr h="388197">
+                <a:tc>
+                  <a:txBody>
+                    <a:bodyPr/>
+                    <a:lstStyle/>
+                    <a:p>
+                      <a:r>
+                        <a:rPr lang="en-US" sz="2000" dirty="0"/>
+                        <a:t>Diameter</a:t>
+                      </a:r>
+                    </a:p>
+                  </a:txBody>
+                  <a:tcPr/>
+                </a:tc>
+                <a:tc>
+                  <a:txBody>
+                    <a:bodyPr/>
+                    <a:lstStyle/>
+                    <a:p>
+                      <a:r>
+                        <a:rPr lang="en-US" sz="2000" dirty="0"/>
+                        <a:t>17</a:t>
+                      </a:r>
+                    </a:p>
+                  </a:txBody>
+                  <a:tcPr/>
+                </a:tc>
+                <a:tc>
+                  <a:txBody>
+                    <a:bodyPr/>
+                    <a:lstStyle/>
+                    <a:p>
+                      <a:r>
+                        <a:rPr lang="en-US" sz="2000" dirty="0"/>
+                        <a:t>12</a:t>
+                      </a:r>
+                    </a:p>
+                  </a:txBody>
+                  <a:tcPr/>
+                </a:tc>
+                <a:tc>
+                  <a:txBody>
+                    <a:bodyPr/>
+                    <a:lstStyle/>
+                    <a:p>
+                      <a:r>
+                        <a:rPr lang="en-US" sz="2000" dirty="0"/>
+                        <a:t>8</a:t>
+                      </a:r>
+                    </a:p>
+                  </a:txBody>
+                  <a:tcPr/>
+                </a:tc>
+                <a:extLst>
+                  <a:ext uri="{0D108BD9-81ED-4DB2-BD59-A6C34878D82A}">
+                    <a16:rowId xmlns:a16="http://schemas.microsoft.com/office/drawing/2014/main" val="533775939"/>
+                  </a:ext>
+                </a:extLst>
+              </a:tr>
+              <a:tr h="388197">
+                <a:tc>
+                  <a:txBody>
+                    <a:bodyPr/>
+                    <a:lstStyle/>
+                    <a:p>
+                      <a:r>
+                        <a:rPr lang="en-US" sz="2000" dirty="0"/>
+                        <a:t>Connected Components</a:t>
+                      </a:r>
+                    </a:p>
+                  </a:txBody>
+                  <a:tcPr/>
+                </a:tc>
+                <a:tc>
+                  <a:txBody>
+                    <a:bodyPr/>
+                    <a:lstStyle/>
+                    <a:p>
+                      <a:r>
+                        <a:rPr lang="en-US" sz="2000" dirty="0"/>
+                        <a:t>268</a:t>
+                      </a:r>
+                    </a:p>
+                  </a:txBody>
+                  <a:tcPr/>
+                </a:tc>
+                <a:tc>
+                  <a:txBody>
+                    <a:bodyPr/>
+                    <a:lstStyle/>
+                    <a:p>
+                      <a:r>
+                        <a:rPr lang="en-US" sz="2000" dirty="0"/>
+                        <a:t>46</a:t>
+                      </a:r>
+                    </a:p>
+                  </a:txBody>
+                  <a:tcPr/>
+                </a:tc>
+                <a:tc>
+                  <a:txBody>
+                    <a:bodyPr/>
+                    <a:lstStyle/>
+                    <a:p>
+                      <a:r>
+                        <a:rPr lang="en-US" sz="2000" dirty="0"/>
+                        <a:t>1</a:t>
+                      </a:r>
+                    </a:p>
+                  </a:txBody>
+                  <a:tcPr/>
+                </a:tc>
+                <a:extLst>
+                  <a:ext uri="{0D108BD9-81ED-4DB2-BD59-A6C34878D82A}">
+                    <a16:rowId xmlns:a16="http://schemas.microsoft.com/office/drawing/2014/main" val="2894749781"/>
+                  </a:ext>
+                </a:extLst>
+              </a:tr>
+              <a:tr h="388197">
+                <a:tc>
+                  <a:txBody>
+                    <a:bodyPr/>
+                    <a:lstStyle/>
+                    <a:p>
+                      <a:r>
+                        <a:rPr lang="en-US" sz="2000" dirty="0"/>
+                        <a:t>Largest Component Size</a:t>
+                      </a:r>
+                    </a:p>
+                  </a:txBody>
+                  <a:tcPr/>
+                </a:tc>
+                <a:tc>
+                  <a:txBody>
+                    <a:bodyPr/>
+                    <a:lstStyle/>
+                    <a:p>
+                      <a:r>
+                        <a:rPr lang="en-US" sz="2000" dirty="0"/>
+                        <a:t>379</a:t>
+                      </a:r>
+                    </a:p>
+                  </a:txBody>
+                  <a:tcPr/>
+                </a:tc>
+                <a:tc>
+                  <a:txBody>
+                    <a:bodyPr/>
+                    <a:lstStyle/>
+                    <a:p>
+                      <a:r>
+                        <a:rPr lang="en-US" sz="2000" dirty="0"/>
+                        <a:t>1415</a:t>
+                      </a:r>
+                    </a:p>
+                  </a:txBody>
+                  <a:tcPr/>
+                </a:tc>
+                <a:tc>
+                  <a:txBody>
+                    <a:bodyPr/>
+                    <a:lstStyle/>
+                    <a:p>
+                      <a:r>
+                        <a:rPr lang="en-US" sz="2000" dirty="0"/>
+                        <a:t>1461</a:t>
+                      </a:r>
+                    </a:p>
+                  </a:txBody>
+                  <a:tcPr/>
+                </a:tc>
+                <a:extLst>
+                  <a:ext uri="{0D108BD9-81ED-4DB2-BD59-A6C34878D82A}">
+                    <a16:rowId xmlns:a16="http://schemas.microsoft.com/office/drawing/2014/main" val="951618927"/>
+                  </a:ext>
+                </a:extLst>
+              </a:tr>
+              <a:tr h="388197">
+                <a:tc>
+                  <a:txBody>
+                    <a:bodyPr/>
+                    <a:lstStyle/>
+                    <a:p>
+                      <a:r>
+                        <a:rPr lang="en-US" sz="2000" dirty="0"/>
+                        <a:t>Average shortest path</a:t>
+                      </a:r>
+                    </a:p>
+                  </a:txBody>
+                  <a:tcPr/>
+                </a:tc>
+                <a:tc>
+                  <a:txBody>
+                    <a:bodyPr/>
+                    <a:lstStyle/>
+                    <a:p>
+                      <a:r>
+                        <a:rPr lang="en-US" sz="2000" b="0" i="0" kern="1200" dirty="0">
+                          <a:solidFill>
+                            <a:schemeClr val="dk1"/>
+                          </a:solidFill>
+                          <a:effectLst/>
+                          <a:latin typeface="+mn-lt"/>
+                          <a:ea typeface="+mn-ea"/>
+                          <a:cs typeface="+mn-cs"/>
+                        </a:rPr>
+                        <a:t>6.04</a:t>
+                      </a:r>
+                      <a:endParaRPr lang="en-US" sz="2000" dirty="0"/>
+                    </a:p>
+                  </a:txBody>
+                  <a:tcPr/>
+                </a:tc>
+                <a:tc>
+                  <a:txBody>
+                    <a:bodyPr/>
+                    <a:lstStyle/>
+                    <a:p>
+                      <a:r>
+                        <a:rPr lang="en-US" sz="2000" b="0" i="0" kern="1200" dirty="0">
+                          <a:solidFill>
+                            <a:schemeClr val="dk1"/>
+                          </a:solidFill>
+                          <a:effectLst/>
+                          <a:latin typeface="+mn-lt"/>
+                          <a:ea typeface="+mn-ea"/>
+                          <a:cs typeface="+mn-cs"/>
+                        </a:rPr>
+                        <a:t>5.59</a:t>
+                      </a:r>
+                      <a:endParaRPr lang="en-US" sz="2000" dirty="0"/>
+                    </a:p>
+                  </a:txBody>
+                  <a:tcPr/>
+                </a:tc>
+                <a:tc>
+                  <a:txBody>
+                    <a:bodyPr/>
+                    <a:lstStyle/>
+                    <a:p>
+                      <a:r>
+                        <a:rPr lang="en-US" sz="2000" b="0" i="0" kern="1200" dirty="0">
+                          <a:solidFill>
+                            <a:schemeClr val="dk1"/>
+                          </a:solidFill>
+                          <a:effectLst/>
+                          <a:latin typeface="+mn-lt"/>
+                          <a:ea typeface="+mn-ea"/>
+                          <a:cs typeface="+mn-cs"/>
+                        </a:rPr>
+                        <a:t>4.24</a:t>
+                      </a:r>
+                      <a:endParaRPr lang="en-US" sz="2000" dirty="0"/>
+                    </a:p>
+                  </a:txBody>
+                  <a:tcPr/>
+                </a:tc>
+                <a:extLst>
+                  <a:ext uri="{0D108BD9-81ED-4DB2-BD59-A6C34878D82A}">
+                    <a16:rowId xmlns:a16="http://schemas.microsoft.com/office/drawing/2014/main" val="3568186649"/>
+                  </a:ext>
+                </a:extLst>
+              </a:tr>
+              <a:tr h="388197">
+                <a:tc>
+                  <a:txBody>
+                    <a:bodyPr/>
+                    <a:lstStyle/>
+                    <a:p>
+                      <a:r>
+                        <a:rPr lang="en-US" sz="2000" dirty="0"/>
+                        <a:t>Average clustering coefficient</a:t>
+                      </a:r>
+                    </a:p>
+                  </a:txBody>
+                  <a:tcPr/>
+                </a:tc>
+                <a:tc>
+                  <a:txBody>
+                    <a:bodyPr/>
+                    <a:lstStyle/>
+                    <a:p>
+                      <a:r>
+                        <a:rPr lang="en-US" sz="2000" b="0" i="0" kern="1200" dirty="0">
+                          <a:solidFill>
+                            <a:schemeClr val="dk1"/>
+                          </a:solidFill>
+                          <a:effectLst/>
+                          <a:latin typeface="+mn-lt"/>
+                          <a:ea typeface="+mn-ea"/>
+                          <a:cs typeface="+mn-cs"/>
+                        </a:rPr>
+                        <a:t>0.69</a:t>
+                      </a:r>
+                      <a:endParaRPr lang="en-US" sz="2000" dirty="0"/>
+                    </a:p>
+                  </a:txBody>
+                  <a:tcPr/>
+                </a:tc>
+                <a:tc>
+                  <a:txBody>
+                    <a:bodyPr/>
+                    <a:lstStyle/>
+                    <a:p>
+                      <a:r>
+                        <a:rPr lang="en-US" sz="2000" b="0" i="0" kern="1200" dirty="0">
+                          <a:solidFill>
+                            <a:schemeClr val="dk1"/>
+                          </a:solidFill>
+                          <a:effectLst/>
+                          <a:latin typeface="+mn-lt"/>
+                          <a:ea typeface="+mn-ea"/>
+                          <a:cs typeface="+mn-cs"/>
+                        </a:rPr>
+                        <a:t>0.004</a:t>
+                      </a:r>
+                      <a:endParaRPr lang="en-US" sz="2000" dirty="0"/>
+                    </a:p>
+                  </a:txBody>
+                  <a:tcPr/>
+                </a:tc>
+                <a:tc>
+                  <a:txBody>
+                    <a:bodyPr/>
+                    <a:lstStyle/>
+                    <a:p>
+                      <a:r>
+                        <a:rPr lang="en-US" sz="2000" b="0" i="0" kern="1200" dirty="0">
+                          <a:solidFill>
+                            <a:schemeClr val="dk1"/>
+                          </a:solidFill>
+                          <a:effectLst/>
+                          <a:latin typeface="+mn-lt"/>
+                          <a:ea typeface="+mn-ea"/>
+                          <a:cs typeface="+mn-cs"/>
+                        </a:rPr>
+                        <a:t>0.02</a:t>
+                      </a:r>
+                      <a:endParaRPr lang="en-US" sz="2000" dirty="0"/>
+                    </a:p>
+                  </a:txBody>
+                  <a:tcPr/>
+                </a:tc>
+                <a:extLst>
+                  <a:ext uri="{0D108BD9-81ED-4DB2-BD59-A6C34878D82A}">
+                    <a16:rowId xmlns:a16="http://schemas.microsoft.com/office/drawing/2014/main" val="1790762521"/>
+                  </a:ext>
+                </a:extLst>
+              </a:tr>
+            </a:tbl>
+          </a:graphicData>
+        </a:graphic>
+      </p:graphicFrame>
+    </p:spTree>
+    <p:extLst>
+      <p:ext uri="{BB962C8B-B14F-4D97-AF65-F5344CB8AC3E}">
+        <p14:creationId xmlns:p14="http://schemas.microsoft.com/office/powerpoint/2010/main" val="3892594497"/>
+      </p:ext>
+    </p:extLst>
   </p:cSld>
   <p:clrMapOvr>
     <a:masterClrMapping/>

</xml_diff>

<commit_message>
docs: preliminary presentation pptx final version
</commit_message>
<xml_diff>
--- a/NetworkScience_Presentation.pptx
+++ b/NetworkScience_Presentation.pptx
@@ -6,19 +6,14 @@
   </p:sldMasterIdLst>
   <p:sldIdLst>
     <p:sldId id="256" r:id="rId2"/>
-    <p:sldId id="257" r:id="rId3"/>
-    <p:sldId id="258" r:id="rId4"/>
-    <p:sldId id="259" r:id="rId5"/>
-    <p:sldId id="260" r:id="rId6"/>
-    <p:sldId id="261" r:id="rId7"/>
-    <p:sldId id="262" r:id="rId8"/>
-    <p:sldId id="263" r:id="rId9"/>
-    <p:sldId id="264" r:id="rId10"/>
-    <p:sldId id="265" r:id="rId11"/>
-    <p:sldId id="266" r:id="rId12"/>
-    <p:sldId id="267" r:id="rId13"/>
-    <p:sldId id="268" r:id="rId14"/>
-    <p:sldId id="269" r:id="rId15"/>
+    <p:sldId id="263" r:id="rId3"/>
+    <p:sldId id="264" r:id="rId4"/>
+    <p:sldId id="265" r:id="rId5"/>
+    <p:sldId id="266" r:id="rId6"/>
+    <p:sldId id="267" r:id="rId7"/>
+    <p:sldId id="268" r:id="rId8"/>
+    <p:sldId id="269" r:id="rId9"/>
+    <p:sldId id="271" r:id="rId10"/>
   </p:sldIdLst>
   <p:sldSz cx="12192000" cy="6858000"/>
   <p:notesSz cx="6858000" cy="9144000"/>
@@ -2582,9 +2577,14 @@
 <p:sldMaster xmlns:a="http://schemas.openxmlformats.org/drawingml/2006/main" xmlns:r="http://schemas.openxmlformats.org/officeDocument/2006/relationships" xmlns:p="http://schemas.openxmlformats.org/presentationml/2006/main">
   <p:cSld>
     <p:bg>
-      <p:bgRef idx="1001">
-        <a:schemeClr val="bg1"/>
-      </p:bgRef>
+      <p:bgPr>
+        <a:solidFill>
+          <a:schemeClr val="tx2">
+            <a:alpha val="0"/>
+          </a:schemeClr>
+        </a:solidFill>
+        <a:effectLst/>
+      </p:bgPr>
     </p:bg>
     <p:spTree>
       <p:nvGrpSpPr>
@@ -3145,7 +3145,7 @@
         <p:spPr>
           <a:xfrm>
             <a:off x="2803849" y="3883155"/>
-            <a:ext cx="6584302" cy="1752600"/>
+            <a:ext cx="6584302" cy="816436"/>
           </a:xfrm>
         </p:spPr>
         <p:txBody>
@@ -3155,24 +3155,278 @@
           <a:lstStyle/>
           <a:p>
             <a:r>
-              <a:rPr lang="en-US" sz="2200" dirty="0"/>
+              <a:rPr lang="en-US" sz="2200" dirty="0">
+                <a:solidFill>
+                  <a:schemeClr val="tx1">
+                    <a:lumMod val="75000"/>
+                    <a:lumOff val="25000"/>
+                  </a:schemeClr>
+                </a:solidFill>
+              </a:rPr>
               <a:t>dimacs10-netscience vs Erdos-</a:t>
             </a:r>
             <a:r>
-              <a:rPr lang="en-US" sz="2200" dirty="0" err="1"/>
+              <a:rPr lang="en-US" sz="2200" dirty="0" err="1">
+                <a:solidFill>
+                  <a:schemeClr val="tx1">
+                    <a:lumMod val="75000"/>
+                    <a:lumOff val="25000"/>
+                  </a:schemeClr>
+                </a:solidFill>
+              </a:rPr>
               <a:t>Renyi</a:t>
             </a:r>
             <a:r>
-              <a:rPr lang="en-US" sz="2200" dirty="0"/>
+              <a:rPr lang="en-US" sz="2200" dirty="0">
+                <a:solidFill>
+                  <a:schemeClr val="tx1">
+                    <a:lumMod val="75000"/>
+                    <a:lumOff val="25000"/>
+                  </a:schemeClr>
+                </a:solidFill>
+              </a:rPr>
               <a:t> and </a:t>
             </a:r>
             <a:r>
-              <a:rPr lang="en-US" sz="2200" dirty="0" err="1"/>
+              <a:rPr lang="en-US" sz="2200" dirty="0" err="1">
+                <a:solidFill>
+                  <a:schemeClr val="tx1">
+                    <a:lumMod val="75000"/>
+                    <a:lumOff val="25000"/>
+                  </a:schemeClr>
+                </a:solidFill>
+              </a:rPr>
               <a:t>Barabasi</a:t>
             </a:r>
             <a:r>
-              <a:rPr lang="en-US" sz="2200" dirty="0"/>
+              <a:rPr lang="en-US" sz="2200" dirty="0">
+                <a:solidFill>
+                  <a:schemeClr val="tx1">
+                    <a:lumMod val="75000"/>
+                    <a:lumOff val="25000"/>
+                  </a:schemeClr>
+                </a:solidFill>
+              </a:rPr>
               <a:t>-Albert</a:t>
+            </a:r>
+          </a:p>
+        </p:txBody>
+      </p:sp>
+      <p:sp>
+        <p:nvSpPr>
+          <p:cNvPr id="4" name="Subtitle 2">
+            <a:extLst>
+              <a:ext uri="{FF2B5EF4-FFF2-40B4-BE49-F238E27FC236}">
+                <a16:creationId xmlns:a16="http://schemas.microsoft.com/office/drawing/2014/main" id="{36218A55-FEB3-E111-8B80-584227228084}"/>
+              </a:ext>
+            </a:extLst>
+          </p:cNvPr>
+          <p:cNvSpPr txBox="1">
+            <a:spLocks/>
+          </p:cNvSpPr>
+          <p:nvPr/>
+        </p:nvSpPr>
+        <p:spPr>
+          <a:xfrm>
+            <a:off x="5607698" y="6041564"/>
+            <a:ext cx="6584302" cy="816436"/>
+          </a:xfrm>
+          <a:prstGeom prst="rect">
+            <a:avLst/>
+          </a:prstGeom>
+        </p:spPr>
+        <p:txBody>
+          <a:bodyPr vert="horz" lIns="91440" tIns="45720" rIns="91440" bIns="45720" rtlCol="0">
+            <a:normAutofit/>
+          </a:bodyPr>
+          <a:lstStyle>
+            <a:lvl1pPr marL="0" indent="0" algn="ctr" defTabSz="457200" rtl="0" eaLnBrk="1" latinLnBrk="0" hangingPunct="1">
+              <a:spcBef>
+                <a:spcPct val="20000"/>
+              </a:spcBef>
+              <a:buFont typeface="Arial"/>
+              <a:buNone/>
+              <a:defRPr sz="3200" kern="1200">
+                <a:solidFill>
+                  <a:schemeClr val="tx1">
+                    <a:tint val="75000"/>
+                  </a:schemeClr>
+                </a:solidFill>
+                <a:latin typeface="+mn-lt"/>
+                <a:ea typeface="+mn-ea"/>
+                <a:cs typeface="+mn-cs"/>
+              </a:defRPr>
+            </a:lvl1pPr>
+            <a:lvl2pPr marL="457200" indent="0" algn="ctr" defTabSz="457200" rtl="0" eaLnBrk="1" latinLnBrk="0" hangingPunct="1">
+              <a:spcBef>
+                <a:spcPct val="20000"/>
+              </a:spcBef>
+              <a:buFont typeface="Arial"/>
+              <a:buNone/>
+              <a:defRPr sz="2800" kern="1200">
+                <a:solidFill>
+                  <a:schemeClr val="tx1">
+                    <a:tint val="75000"/>
+                  </a:schemeClr>
+                </a:solidFill>
+                <a:latin typeface="+mn-lt"/>
+                <a:ea typeface="+mn-ea"/>
+                <a:cs typeface="+mn-cs"/>
+              </a:defRPr>
+            </a:lvl2pPr>
+            <a:lvl3pPr marL="914400" indent="0" algn="ctr" defTabSz="457200" rtl="0" eaLnBrk="1" latinLnBrk="0" hangingPunct="1">
+              <a:spcBef>
+                <a:spcPct val="20000"/>
+              </a:spcBef>
+              <a:buFont typeface="Arial"/>
+              <a:buNone/>
+              <a:defRPr sz="2400" kern="1200">
+                <a:solidFill>
+                  <a:schemeClr val="tx1">
+                    <a:tint val="75000"/>
+                  </a:schemeClr>
+                </a:solidFill>
+                <a:latin typeface="+mn-lt"/>
+                <a:ea typeface="+mn-ea"/>
+                <a:cs typeface="+mn-cs"/>
+              </a:defRPr>
+            </a:lvl3pPr>
+            <a:lvl4pPr marL="1371600" indent="0" algn="ctr" defTabSz="457200" rtl="0" eaLnBrk="1" latinLnBrk="0" hangingPunct="1">
+              <a:spcBef>
+                <a:spcPct val="20000"/>
+              </a:spcBef>
+              <a:buFont typeface="Arial"/>
+              <a:buNone/>
+              <a:defRPr sz="2000" kern="1200">
+                <a:solidFill>
+                  <a:schemeClr val="tx1">
+                    <a:tint val="75000"/>
+                  </a:schemeClr>
+                </a:solidFill>
+                <a:latin typeface="+mn-lt"/>
+                <a:ea typeface="+mn-ea"/>
+                <a:cs typeface="+mn-cs"/>
+              </a:defRPr>
+            </a:lvl4pPr>
+            <a:lvl5pPr marL="1828800" indent="0" algn="ctr" defTabSz="457200" rtl="0" eaLnBrk="1" latinLnBrk="0" hangingPunct="1">
+              <a:spcBef>
+                <a:spcPct val="20000"/>
+              </a:spcBef>
+              <a:buFont typeface="Arial"/>
+              <a:buNone/>
+              <a:defRPr sz="2000" kern="1200">
+                <a:solidFill>
+                  <a:schemeClr val="tx1">
+                    <a:tint val="75000"/>
+                  </a:schemeClr>
+                </a:solidFill>
+                <a:latin typeface="+mn-lt"/>
+                <a:ea typeface="+mn-ea"/>
+                <a:cs typeface="+mn-cs"/>
+              </a:defRPr>
+            </a:lvl5pPr>
+            <a:lvl6pPr marL="2286000" indent="0" algn="ctr" defTabSz="457200" rtl="0" eaLnBrk="1" latinLnBrk="0" hangingPunct="1">
+              <a:spcBef>
+                <a:spcPct val="20000"/>
+              </a:spcBef>
+              <a:buFont typeface="Arial"/>
+              <a:buNone/>
+              <a:defRPr sz="2000" kern="1200">
+                <a:solidFill>
+                  <a:schemeClr val="tx1">
+                    <a:tint val="75000"/>
+                  </a:schemeClr>
+                </a:solidFill>
+                <a:latin typeface="+mn-lt"/>
+                <a:ea typeface="+mn-ea"/>
+                <a:cs typeface="+mn-cs"/>
+              </a:defRPr>
+            </a:lvl6pPr>
+            <a:lvl7pPr marL="2743200" indent="0" algn="ctr" defTabSz="457200" rtl="0" eaLnBrk="1" latinLnBrk="0" hangingPunct="1">
+              <a:spcBef>
+                <a:spcPct val="20000"/>
+              </a:spcBef>
+              <a:buFont typeface="Arial"/>
+              <a:buNone/>
+              <a:defRPr sz="2000" kern="1200">
+                <a:solidFill>
+                  <a:schemeClr val="tx1">
+                    <a:tint val="75000"/>
+                  </a:schemeClr>
+                </a:solidFill>
+                <a:latin typeface="+mn-lt"/>
+                <a:ea typeface="+mn-ea"/>
+                <a:cs typeface="+mn-cs"/>
+              </a:defRPr>
+            </a:lvl7pPr>
+            <a:lvl8pPr marL="3200400" indent="0" algn="ctr" defTabSz="457200" rtl="0" eaLnBrk="1" latinLnBrk="0" hangingPunct="1">
+              <a:spcBef>
+                <a:spcPct val="20000"/>
+              </a:spcBef>
+              <a:buFont typeface="Arial"/>
+              <a:buNone/>
+              <a:defRPr sz="2000" kern="1200">
+                <a:solidFill>
+                  <a:schemeClr val="tx1">
+                    <a:tint val="75000"/>
+                  </a:schemeClr>
+                </a:solidFill>
+                <a:latin typeface="+mn-lt"/>
+                <a:ea typeface="+mn-ea"/>
+                <a:cs typeface="+mn-cs"/>
+              </a:defRPr>
+            </a:lvl8pPr>
+            <a:lvl9pPr marL="3657600" indent="0" algn="ctr" defTabSz="457200" rtl="0" eaLnBrk="1" latinLnBrk="0" hangingPunct="1">
+              <a:spcBef>
+                <a:spcPct val="20000"/>
+              </a:spcBef>
+              <a:buFont typeface="Arial"/>
+              <a:buNone/>
+              <a:defRPr sz="2000" kern="1200">
+                <a:solidFill>
+                  <a:schemeClr val="tx1">
+                    <a:tint val="75000"/>
+                  </a:schemeClr>
+                </a:solidFill>
+                <a:latin typeface="+mn-lt"/>
+                <a:ea typeface="+mn-ea"/>
+                <a:cs typeface="+mn-cs"/>
+              </a:defRPr>
+            </a:lvl9pPr>
+          </a:lstStyle>
+          <a:p>
+            <a:r>
+              <a:rPr lang="en-US" sz="2200" dirty="0">
+                <a:solidFill>
+                  <a:schemeClr val="tx1">
+                    <a:lumMod val="85000"/>
+                    <a:lumOff val="15000"/>
+                  </a:schemeClr>
+                </a:solidFill>
+              </a:rPr>
+              <a:t>Pop Cristian, Pop Răzvan, </a:t>
+            </a:r>
+            <a:r>
+              <a:rPr lang="en-US" sz="2200" dirty="0" err="1">
+                <a:solidFill>
+                  <a:schemeClr val="tx1">
+                    <a:lumMod val="85000"/>
+                    <a:lumOff val="15000"/>
+                  </a:schemeClr>
+                </a:solidFill>
+              </a:rPr>
+              <a:t>Selegean</a:t>
+            </a:r>
+            <a:r>
+              <a:rPr lang="en-US" sz="2200" dirty="0">
+                <a:solidFill>
+                  <a:schemeClr val="tx1">
+                    <a:lumMod val="85000"/>
+                    <a:lumOff val="15000"/>
+                  </a:schemeClr>
+                </a:solidFill>
+              </a:rPr>
+              <a:t> Victor, Tripon David</a:t>
             </a:r>
           </a:p>
         </p:txBody>
@@ -3185,7 +3439,7 @@
 </p:sld>
 </file>
 
-<file path=ppt/slides/slide10.xml><?xml version="1.0" encoding="utf-8"?>
+<file path=ppt/slides/slide2.xml><?xml version="1.0" encoding="utf-8"?>
 <p:sld xmlns:a="http://schemas.openxmlformats.org/drawingml/2006/main" xmlns:r="http://schemas.openxmlformats.org/officeDocument/2006/relationships" xmlns:p="http://schemas.openxmlformats.org/presentationml/2006/main">
   <p:cSld>
     <p:spTree>
@@ -3207,6 +3461,804 @@
           <p:cNvPr id="2" name="Title 1">
             <a:extLst>
               <a:ext uri="{FF2B5EF4-FFF2-40B4-BE49-F238E27FC236}">
+                <a16:creationId xmlns:a16="http://schemas.microsoft.com/office/drawing/2014/main" id="{FB130DDC-2453-78F8-C678-F51482938D1F}"/>
+              </a:ext>
+            </a:extLst>
+          </p:cNvPr>
+          <p:cNvSpPr>
+            <a:spLocks noGrp="1"/>
+          </p:cNvSpPr>
+          <p:nvPr>
+            <p:ph type="title"/>
+          </p:nvPr>
+        </p:nvSpPr>
+        <p:spPr/>
+        <p:txBody>
+          <a:bodyPr>
+            <a:normAutofit/>
+          </a:bodyPr>
+          <a:lstStyle/>
+          <a:p>
+            <a:r>
+              <a:rPr lang="en-US" dirty="0"/>
+              <a:t>Network Description</a:t>
+            </a:r>
+          </a:p>
+        </p:txBody>
+      </p:sp>
+      <p:sp>
+        <p:nvSpPr>
+          <p:cNvPr id="3" name="Content Placeholder 2">
+            <a:extLst>
+              <a:ext uri="{FF2B5EF4-FFF2-40B4-BE49-F238E27FC236}">
+                <a16:creationId xmlns:a16="http://schemas.microsoft.com/office/drawing/2014/main" id="{6CB4BB62-872C-8532-AE7B-F4092C482C11}"/>
+              </a:ext>
+            </a:extLst>
+          </p:cNvPr>
+          <p:cNvSpPr>
+            <a:spLocks noGrp="1"/>
+          </p:cNvSpPr>
+          <p:nvPr>
+            <p:ph idx="1"/>
+          </p:nvPr>
+        </p:nvSpPr>
+        <p:spPr/>
+        <p:txBody>
+          <a:bodyPr>
+            <a:normAutofit lnSpcReduction="10000"/>
+          </a:bodyPr>
+          <a:lstStyle/>
+          <a:p>
+            <a:pPr marL="0" indent="0">
+              <a:buNone/>
+              <a:defRPr sz="2400"/>
+            </a:pPr>
+            <a:r>
+              <a:rPr lang="en-US" sz="2400" b="1" dirty="0"/>
+              <a:t>dimacs10-netscience (co-authorship network)</a:t>
+            </a:r>
+          </a:p>
+          <a:p>
+            <a:pPr>
+              <a:defRPr sz="2400"/>
+            </a:pPr>
+            <a:r>
+              <a:rPr lang="en-US" sz="2000" dirty="0"/>
+              <a:t>Nodes (authors): 1461</a:t>
+            </a:r>
+          </a:p>
+          <a:p>
+            <a:pPr>
+              <a:defRPr sz="2400"/>
+            </a:pPr>
+            <a:r>
+              <a:rPr lang="en-US" sz="2000" dirty="0"/>
+              <a:t>Edges (co-authorship links): 2742</a:t>
+            </a:r>
+          </a:p>
+          <a:p>
+            <a:pPr>
+              <a:defRPr sz="2400"/>
+            </a:pPr>
+            <a:r>
+              <a:rPr lang="en-US" sz="2000" dirty="0"/>
+              <a:t>Graph type: undirected, unweighted, </a:t>
+            </a:r>
+            <a:r>
+              <a:rPr lang="en-US" sz="2000"/>
+              <a:t>no self-loop</a:t>
+            </a:r>
+          </a:p>
+          <a:p>
+            <a:pPr marL="0" indent="0">
+              <a:buNone/>
+              <a:defRPr sz="2400"/>
+            </a:pPr>
+            <a:endParaRPr lang="en-US" sz="2000" dirty="0"/>
+          </a:p>
+          <a:p>
+            <a:pPr marL="0" indent="0">
+              <a:buNone/>
+              <a:defRPr sz="2400"/>
+            </a:pPr>
+            <a:r>
+              <a:rPr lang="en-US" sz="2400" b="1" dirty="0"/>
+              <a:t>Random Network: Erdos-</a:t>
+            </a:r>
+            <a:r>
+              <a:rPr lang="en-US" sz="2400" b="1" dirty="0" err="1"/>
+              <a:t>Renyi</a:t>
+            </a:r>
+            <a:r>
+              <a:rPr lang="en-US" sz="2400" b="1" dirty="0"/>
+              <a:t> model</a:t>
+            </a:r>
+          </a:p>
+          <a:p>
+            <a:pPr>
+              <a:defRPr sz="2400"/>
+            </a:pPr>
+            <a:r>
+              <a:rPr lang="en-US" sz="2000" dirty="0"/>
+              <a:t>Nodes: 1461</a:t>
+            </a:r>
+          </a:p>
+          <a:p>
+            <a:pPr>
+              <a:defRPr sz="2400"/>
+            </a:pPr>
+            <a:r>
+              <a:rPr lang="en-US" sz="2000" dirty="0"/>
+              <a:t>Edges: 2728</a:t>
+            </a:r>
+          </a:p>
+          <a:p>
+            <a:pPr>
+              <a:defRPr sz="2400"/>
+            </a:pPr>
+            <a:endParaRPr lang="en-US" sz="2000" dirty="0"/>
+          </a:p>
+          <a:p>
+            <a:pPr marL="0" indent="0">
+              <a:buNone/>
+              <a:defRPr sz="2400"/>
+            </a:pPr>
+            <a:r>
+              <a:rPr lang="en-US" sz="2400" b="1" dirty="0"/>
+              <a:t>Scale-free Network: </a:t>
+            </a:r>
+            <a:r>
+              <a:rPr lang="en-US" sz="2400" b="1" dirty="0" err="1"/>
+              <a:t>Barabasi</a:t>
+            </a:r>
+            <a:r>
+              <a:rPr lang="en-US" sz="2400" b="1" dirty="0"/>
+              <a:t>-Albert model</a:t>
+            </a:r>
+          </a:p>
+          <a:p>
+            <a:pPr>
+              <a:defRPr sz="2400"/>
+            </a:pPr>
+            <a:r>
+              <a:rPr lang="en-US" sz="2000" dirty="0"/>
+              <a:t>Nodes: 1461</a:t>
+            </a:r>
+          </a:p>
+          <a:p>
+            <a:pPr>
+              <a:defRPr sz="2400"/>
+            </a:pPr>
+            <a:r>
+              <a:rPr lang="en-US" sz="2000" dirty="0"/>
+              <a:t>Edges: 2918</a:t>
+            </a:r>
+          </a:p>
+        </p:txBody>
+      </p:sp>
+    </p:spTree>
+    <p:extLst>
+      <p:ext uri="{BB962C8B-B14F-4D97-AF65-F5344CB8AC3E}">
+        <p14:creationId xmlns:p14="http://schemas.microsoft.com/office/powerpoint/2010/main" val="2281326393"/>
+      </p:ext>
+    </p:extLst>
+  </p:cSld>
+  <p:clrMapOvr>
+    <a:masterClrMapping/>
+  </p:clrMapOvr>
+</p:sld>
+</file>
+
+<file path=ppt/slides/slide3.xml><?xml version="1.0" encoding="utf-8"?>
+<p:sld xmlns:a="http://schemas.openxmlformats.org/drawingml/2006/main" xmlns:r="http://schemas.openxmlformats.org/officeDocument/2006/relationships" xmlns:p="http://schemas.openxmlformats.org/presentationml/2006/main">
+  <p:cSld>
+    <p:spTree>
+      <p:nvGrpSpPr>
+        <p:cNvPr id="1" name=""/>
+        <p:cNvGrpSpPr/>
+        <p:nvPr/>
+      </p:nvGrpSpPr>
+      <p:grpSpPr>
+        <a:xfrm>
+          <a:off x="0" y="0"/>
+          <a:ext cx="0" cy="0"/>
+          <a:chOff x="0" y="0"/>
+          <a:chExt cx="0" cy="0"/>
+        </a:xfrm>
+      </p:grpSpPr>
+      <p:sp>
+        <p:nvSpPr>
+          <p:cNvPr id="2" name="Title 1">
+            <a:extLst>
+              <a:ext uri="{FF2B5EF4-FFF2-40B4-BE49-F238E27FC236}">
+                <a16:creationId xmlns:a16="http://schemas.microsoft.com/office/drawing/2014/main" id="{A3CA0CB8-73ED-02B6-1533-4A33527E686C}"/>
+              </a:ext>
+            </a:extLst>
+          </p:cNvPr>
+          <p:cNvSpPr>
+            <a:spLocks noGrp="1"/>
+          </p:cNvSpPr>
+          <p:nvPr>
+            <p:ph type="title"/>
+          </p:nvPr>
+        </p:nvSpPr>
+        <p:spPr/>
+        <p:txBody>
+          <a:bodyPr>
+            <a:normAutofit/>
+          </a:bodyPr>
+          <a:lstStyle/>
+          <a:p>
+            <a:r>
+              <a:rPr lang="en-US" dirty="0"/>
+              <a:t>Network Properties</a:t>
+            </a:r>
+          </a:p>
+        </p:txBody>
+      </p:sp>
+      <p:graphicFrame>
+        <p:nvGraphicFramePr>
+          <p:cNvPr id="5" name="Table 4">
+            <a:extLst>
+              <a:ext uri="{FF2B5EF4-FFF2-40B4-BE49-F238E27FC236}">
+                <a16:creationId xmlns:a16="http://schemas.microsoft.com/office/drawing/2014/main" id="{8902F6E5-D50D-156C-6973-88B90B218EE6}"/>
+              </a:ext>
+            </a:extLst>
+          </p:cNvPr>
+          <p:cNvGraphicFramePr>
+            <a:graphicFrameLocks noGrp="1"/>
+          </p:cNvGraphicFramePr>
+          <p:nvPr>
+            <p:extLst>
+              <p:ext uri="{D42A27DB-BD31-4B8C-83A1-F6EECF244321}">
+                <p14:modId xmlns:p14="http://schemas.microsoft.com/office/powerpoint/2010/main" val="2179173524"/>
+              </p:ext>
+            </p:extLst>
+          </p:nvPr>
+        </p:nvGraphicFramePr>
+        <p:xfrm>
+          <a:off x="1595025" y="2048958"/>
+          <a:ext cx="9001949" cy="2765637"/>
+        </p:xfrm>
+        <a:graphic>
+          <a:graphicData uri="http://schemas.openxmlformats.org/drawingml/2006/table">
+            <a:tbl>
+              <a:tblPr firstRow="1" bandRow="1">
+                <a:tableStyleId>{5C22544A-7EE6-4342-B048-85BDC9FD1C3A}</a:tableStyleId>
+              </a:tblPr>
+              <a:tblGrid>
+                <a:gridCol w="3281297">
+                  <a:extLst>
+                    <a:ext uri="{9D8B030D-6E8A-4147-A177-3AD203B41FA5}">
+                      <a16:colId xmlns:a16="http://schemas.microsoft.com/office/drawing/2014/main" val="3737601808"/>
+                    </a:ext>
+                  </a:extLst>
+                </a:gridCol>
+                <a:gridCol w="1827213">
+                  <a:extLst>
+                    <a:ext uri="{9D8B030D-6E8A-4147-A177-3AD203B41FA5}">
+                      <a16:colId xmlns:a16="http://schemas.microsoft.com/office/drawing/2014/main" val="2060914983"/>
+                    </a:ext>
+                  </a:extLst>
+                </a:gridCol>
+                <a:gridCol w="1876425">
+                  <a:extLst>
+                    <a:ext uri="{9D8B030D-6E8A-4147-A177-3AD203B41FA5}">
+                      <a16:colId xmlns:a16="http://schemas.microsoft.com/office/drawing/2014/main" val="1384432102"/>
+                    </a:ext>
+                  </a:extLst>
+                </a:gridCol>
+                <a:gridCol w="2017014">
+                  <a:extLst>
+                    <a:ext uri="{9D8B030D-6E8A-4147-A177-3AD203B41FA5}">
+                      <a16:colId xmlns:a16="http://schemas.microsoft.com/office/drawing/2014/main" val="1731971228"/>
+                    </a:ext>
+                  </a:extLst>
+                </a:gridCol>
+              </a:tblGrid>
+              <a:tr h="388197">
+                <a:tc>
+                  <a:txBody>
+                    <a:bodyPr/>
+                    <a:lstStyle/>
+                    <a:p>
+                      <a:endParaRPr lang="en-US"/>
+                    </a:p>
+                  </a:txBody>
+                  <a:tcPr/>
+                </a:tc>
+                <a:tc>
+                  <a:txBody>
+                    <a:bodyPr/>
+                    <a:lstStyle/>
+                    <a:p>
+                      <a:r>
+                        <a:rPr lang="en-US" dirty="0"/>
+                        <a:t>Real network</a:t>
+                      </a:r>
+                    </a:p>
+                  </a:txBody>
+                  <a:tcPr/>
+                </a:tc>
+                <a:tc>
+                  <a:txBody>
+                    <a:bodyPr/>
+                    <a:lstStyle/>
+                    <a:p>
+                      <a:r>
+                        <a:rPr lang="en-US" dirty="0"/>
+                        <a:t>Random network</a:t>
+                      </a:r>
+                    </a:p>
+                  </a:txBody>
+                  <a:tcPr/>
+                </a:tc>
+                <a:tc>
+                  <a:txBody>
+                    <a:bodyPr/>
+                    <a:lstStyle/>
+                    <a:p>
+                      <a:r>
+                        <a:rPr lang="en-US" dirty="0"/>
+                        <a:t>Scale-free network</a:t>
+                      </a:r>
+                    </a:p>
+                  </a:txBody>
+                  <a:tcPr/>
+                </a:tc>
+                <a:extLst>
+                  <a:ext uri="{0D108BD9-81ED-4DB2-BD59-A6C34878D82A}">
+                    <a16:rowId xmlns:a16="http://schemas.microsoft.com/office/drawing/2014/main" val="2364562667"/>
+                  </a:ext>
+                </a:extLst>
+              </a:tr>
+              <a:tr h="388197">
+                <a:tc>
+                  <a:txBody>
+                    <a:bodyPr/>
+                    <a:lstStyle/>
+                    <a:p>
+                      <a:r>
+                        <a:rPr lang="en-US" sz="2000" dirty="0"/>
+                        <a:t>Min/Max/Average Degree</a:t>
+                      </a:r>
+                    </a:p>
+                  </a:txBody>
+                  <a:tcPr/>
+                </a:tc>
+                <a:tc>
+                  <a:txBody>
+                    <a:bodyPr/>
+                    <a:lstStyle/>
+                    <a:p>
+                      <a:r>
+                        <a:rPr lang="en-US" sz="2000" dirty="0"/>
+                        <a:t>1 / 34 / 3.75</a:t>
+                      </a:r>
+                    </a:p>
+                  </a:txBody>
+                  <a:tcPr/>
+                </a:tc>
+                <a:tc>
+                  <a:txBody>
+                    <a:bodyPr/>
+                    <a:lstStyle/>
+                    <a:p>
+                      <a:r>
+                        <a:rPr lang="en-US" sz="2000" dirty="0"/>
+                        <a:t>0 / 12 / 3.73</a:t>
+                      </a:r>
+                    </a:p>
+                  </a:txBody>
+                  <a:tcPr/>
+                </a:tc>
+                <a:tc>
+                  <a:txBody>
+                    <a:bodyPr/>
+                    <a:lstStyle/>
+                    <a:p>
+                      <a:r>
+                        <a:rPr lang="en-US" sz="2000" dirty="0"/>
+                        <a:t>2 / 103 / 3.99</a:t>
+                      </a:r>
+                    </a:p>
+                  </a:txBody>
+                  <a:tcPr/>
+                </a:tc>
+                <a:extLst>
+                  <a:ext uri="{0D108BD9-81ED-4DB2-BD59-A6C34878D82A}">
+                    <a16:rowId xmlns:a16="http://schemas.microsoft.com/office/drawing/2014/main" val="2366982699"/>
+                  </a:ext>
+                </a:extLst>
+              </a:tr>
+              <a:tr h="388197">
+                <a:tc>
+                  <a:txBody>
+                    <a:bodyPr/>
+                    <a:lstStyle/>
+                    <a:p>
+                      <a:r>
+                        <a:rPr lang="en-US" sz="2000" dirty="0"/>
+                        <a:t>Diameter</a:t>
+                      </a:r>
+                    </a:p>
+                  </a:txBody>
+                  <a:tcPr/>
+                </a:tc>
+                <a:tc>
+                  <a:txBody>
+                    <a:bodyPr/>
+                    <a:lstStyle/>
+                    <a:p>
+                      <a:r>
+                        <a:rPr lang="en-US" sz="2000" dirty="0"/>
+                        <a:t>17</a:t>
+                      </a:r>
+                    </a:p>
+                  </a:txBody>
+                  <a:tcPr/>
+                </a:tc>
+                <a:tc>
+                  <a:txBody>
+                    <a:bodyPr/>
+                    <a:lstStyle/>
+                    <a:p>
+                      <a:r>
+                        <a:rPr lang="en-US" sz="2000" dirty="0"/>
+                        <a:t>12</a:t>
+                      </a:r>
+                    </a:p>
+                  </a:txBody>
+                  <a:tcPr/>
+                </a:tc>
+                <a:tc>
+                  <a:txBody>
+                    <a:bodyPr/>
+                    <a:lstStyle/>
+                    <a:p>
+                      <a:r>
+                        <a:rPr lang="en-US" sz="2000" dirty="0"/>
+                        <a:t>8</a:t>
+                      </a:r>
+                    </a:p>
+                  </a:txBody>
+                  <a:tcPr/>
+                </a:tc>
+                <a:extLst>
+                  <a:ext uri="{0D108BD9-81ED-4DB2-BD59-A6C34878D82A}">
+                    <a16:rowId xmlns:a16="http://schemas.microsoft.com/office/drawing/2014/main" val="533775939"/>
+                  </a:ext>
+                </a:extLst>
+              </a:tr>
+              <a:tr h="388197">
+                <a:tc>
+                  <a:txBody>
+                    <a:bodyPr/>
+                    <a:lstStyle/>
+                    <a:p>
+                      <a:r>
+                        <a:rPr lang="en-US" sz="2000" dirty="0"/>
+                        <a:t>Connected Components</a:t>
+                      </a:r>
+                    </a:p>
+                  </a:txBody>
+                  <a:tcPr/>
+                </a:tc>
+                <a:tc>
+                  <a:txBody>
+                    <a:bodyPr/>
+                    <a:lstStyle/>
+                    <a:p>
+                      <a:r>
+                        <a:rPr lang="en-US" sz="2000" dirty="0"/>
+                        <a:t>268</a:t>
+                      </a:r>
+                    </a:p>
+                  </a:txBody>
+                  <a:tcPr/>
+                </a:tc>
+                <a:tc>
+                  <a:txBody>
+                    <a:bodyPr/>
+                    <a:lstStyle/>
+                    <a:p>
+                      <a:r>
+                        <a:rPr lang="en-US" sz="2000" dirty="0"/>
+                        <a:t>46</a:t>
+                      </a:r>
+                    </a:p>
+                  </a:txBody>
+                  <a:tcPr/>
+                </a:tc>
+                <a:tc>
+                  <a:txBody>
+                    <a:bodyPr/>
+                    <a:lstStyle/>
+                    <a:p>
+                      <a:r>
+                        <a:rPr lang="en-US" sz="2000" dirty="0"/>
+                        <a:t>1</a:t>
+                      </a:r>
+                    </a:p>
+                  </a:txBody>
+                  <a:tcPr/>
+                </a:tc>
+                <a:extLst>
+                  <a:ext uri="{0D108BD9-81ED-4DB2-BD59-A6C34878D82A}">
+                    <a16:rowId xmlns:a16="http://schemas.microsoft.com/office/drawing/2014/main" val="2894749781"/>
+                  </a:ext>
+                </a:extLst>
+              </a:tr>
+              <a:tr h="388197">
+                <a:tc>
+                  <a:txBody>
+                    <a:bodyPr/>
+                    <a:lstStyle/>
+                    <a:p>
+                      <a:r>
+                        <a:rPr lang="en-US" sz="2000" dirty="0"/>
+                        <a:t>Largest Component Size</a:t>
+                      </a:r>
+                    </a:p>
+                  </a:txBody>
+                  <a:tcPr/>
+                </a:tc>
+                <a:tc>
+                  <a:txBody>
+                    <a:bodyPr/>
+                    <a:lstStyle/>
+                    <a:p>
+                      <a:r>
+                        <a:rPr lang="en-US" sz="2000" dirty="0"/>
+                        <a:t>379</a:t>
+                      </a:r>
+                    </a:p>
+                  </a:txBody>
+                  <a:tcPr/>
+                </a:tc>
+                <a:tc>
+                  <a:txBody>
+                    <a:bodyPr/>
+                    <a:lstStyle/>
+                    <a:p>
+                      <a:r>
+                        <a:rPr lang="en-US" sz="2000" dirty="0"/>
+                        <a:t>1415</a:t>
+                      </a:r>
+                    </a:p>
+                  </a:txBody>
+                  <a:tcPr/>
+                </a:tc>
+                <a:tc>
+                  <a:txBody>
+                    <a:bodyPr/>
+                    <a:lstStyle/>
+                    <a:p>
+                      <a:r>
+                        <a:rPr lang="en-US" sz="2000" dirty="0"/>
+                        <a:t>1461</a:t>
+                      </a:r>
+                    </a:p>
+                  </a:txBody>
+                  <a:tcPr/>
+                </a:tc>
+                <a:extLst>
+                  <a:ext uri="{0D108BD9-81ED-4DB2-BD59-A6C34878D82A}">
+                    <a16:rowId xmlns:a16="http://schemas.microsoft.com/office/drawing/2014/main" val="951618927"/>
+                  </a:ext>
+                </a:extLst>
+              </a:tr>
+              <a:tr h="388197">
+                <a:tc>
+                  <a:txBody>
+                    <a:bodyPr/>
+                    <a:lstStyle/>
+                    <a:p>
+                      <a:r>
+                        <a:rPr lang="en-US" sz="2000" dirty="0"/>
+                        <a:t>Average shortest path</a:t>
+                      </a:r>
+                    </a:p>
+                  </a:txBody>
+                  <a:tcPr/>
+                </a:tc>
+                <a:tc>
+                  <a:txBody>
+                    <a:bodyPr/>
+                    <a:lstStyle/>
+                    <a:p>
+                      <a:r>
+                        <a:rPr lang="en-US" sz="2000" b="0" i="0" kern="1200" dirty="0">
+                          <a:solidFill>
+                            <a:schemeClr val="dk1"/>
+                          </a:solidFill>
+                          <a:effectLst/>
+                          <a:latin typeface="+mn-lt"/>
+                          <a:ea typeface="+mn-ea"/>
+                          <a:cs typeface="+mn-cs"/>
+                        </a:rPr>
+                        <a:t>6.04</a:t>
+                      </a:r>
+                      <a:endParaRPr lang="en-US" sz="2000" dirty="0"/>
+                    </a:p>
+                  </a:txBody>
+                  <a:tcPr/>
+                </a:tc>
+                <a:tc>
+                  <a:txBody>
+                    <a:bodyPr/>
+                    <a:lstStyle/>
+                    <a:p>
+                      <a:r>
+                        <a:rPr lang="en-US" sz="2000" b="0" i="0" kern="1200" dirty="0">
+                          <a:solidFill>
+                            <a:schemeClr val="dk1"/>
+                          </a:solidFill>
+                          <a:effectLst/>
+                          <a:latin typeface="+mn-lt"/>
+                          <a:ea typeface="+mn-ea"/>
+                          <a:cs typeface="+mn-cs"/>
+                        </a:rPr>
+                        <a:t>5.59</a:t>
+                      </a:r>
+                      <a:endParaRPr lang="en-US" sz="2000" dirty="0"/>
+                    </a:p>
+                  </a:txBody>
+                  <a:tcPr/>
+                </a:tc>
+                <a:tc>
+                  <a:txBody>
+                    <a:bodyPr/>
+                    <a:lstStyle/>
+                    <a:p>
+                      <a:r>
+                        <a:rPr lang="en-US" sz="2000" b="0" i="0" kern="1200" dirty="0">
+                          <a:solidFill>
+                            <a:schemeClr val="dk1"/>
+                          </a:solidFill>
+                          <a:effectLst/>
+                          <a:latin typeface="+mn-lt"/>
+                          <a:ea typeface="+mn-ea"/>
+                          <a:cs typeface="+mn-cs"/>
+                        </a:rPr>
+                        <a:t>4.24</a:t>
+                      </a:r>
+                      <a:endParaRPr lang="en-US" sz="2000" dirty="0"/>
+                    </a:p>
+                  </a:txBody>
+                  <a:tcPr/>
+                </a:tc>
+                <a:extLst>
+                  <a:ext uri="{0D108BD9-81ED-4DB2-BD59-A6C34878D82A}">
+                    <a16:rowId xmlns:a16="http://schemas.microsoft.com/office/drawing/2014/main" val="3568186649"/>
+                  </a:ext>
+                </a:extLst>
+              </a:tr>
+              <a:tr h="388197">
+                <a:tc>
+                  <a:txBody>
+                    <a:bodyPr/>
+                    <a:lstStyle/>
+                    <a:p>
+                      <a:r>
+                        <a:rPr lang="en-US" sz="2000" dirty="0"/>
+                        <a:t>Average clustering coefficient</a:t>
+                      </a:r>
+                    </a:p>
+                  </a:txBody>
+                  <a:tcPr/>
+                </a:tc>
+                <a:tc>
+                  <a:txBody>
+                    <a:bodyPr/>
+                    <a:lstStyle/>
+                    <a:p>
+                      <a:r>
+                        <a:rPr lang="en-US" sz="2000" b="0" i="0" kern="1200" dirty="0">
+                          <a:solidFill>
+                            <a:schemeClr val="dk1"/>
+                          </a:solidFill>
+                          <a:effectLst/>
+                          <a:latin typeface="+mn-lt"/>
+                          <a:ea typeface="+mn-ea"/>
+                          <a:cs typeface="+mn-cs"/>
+                        </a:rPr>
+                        <a:t>0.69</a:t>
+                      </a:r>
+                      <a:endParaRPr lang="en-US" sz="2000" dirty="0"/>
+                    </a:p>
+                  </a:txBody>
+                  <a:tcPr/>
+                </a:tc>
+                <a:tc>
+                  <a:txBody>
+                    <a:bodyPr/>
+                    <a:lstStyle/>
+                    <a:p>
+                      <a:r>
+                        <a:rPr lang="en-US" sz="2000" b="0" i="0" kern="1200" dirty="0">
+                          <a:solidFill>
+                            <a:schemeClr val="dk1"/>
+                          </a:solidFill>
+                          <a:effectLst/>
+                          <a:latin typeface="+mn-lt"/>
+                          <a:ea typeface="+mn-ea"/>
+                          <a:cs typeface="+mn-cs"/>
+                        </a:rPr>
+                        <a:t>0.004</a:t>
+                      </a:r>
+                      <a:endParaRPr lang="en-US" sz="2000" dirty="0"/>
+                    </a:p>
+                  </a:txBody>
+                  <a:tcPr/>
+                </a:tc>
+                <a:tc>
+                  <a:txBody>
+                    <a:bodyPr/>
+                    <a:lstStyle/>
+                    <a:p>
+                      <a:r>
+                        <a:rPr lang="en-US" sz="2000" b="0" i="0" kern="1200" dirty="0">
+                          <a:solidFill>
+                            <a:schemeClr val="dk1"/>
+                          </a:solidFill>
+                          <a:effectLst/>
+                          <a:latin typeface="+mn-lt"/>
+                          <a:ea typeface="+mn-ea"/>
+                          <a:cs typeface="+mn-cs"/>
+                        </a:rPr>
+                        <a:t>0.02</a:t>
+                      </a:r>
+                      <a:endParaRPr lang="en-US" sz="2000" dirty="0"/>
+                    </a:p>
+                  </a:txBody>
+                  <a:tcPr/>
+                </a:tc>
+                <a:extLst>
+                  <a:ext uri="{0D108BD9-81ED-4DB2-BD59-A6C34878D82A}">
+                    <a16:rowId xmlns:a16="http://schemas.microsoft.com/office/drawing/2014/main" val="1790762521"/>
+                  </a:ext>
+                </a:extLst>
+              </a:tr>
+            </a:tbl>
+          </a:graphicData>
+        </a:graphic>
+      </p:graphicFrame>
+    </p:spTree>
+    <p:extLst>
+      <p:ext uri="{BB962C8B-B14F-4D97-AF65-F5344CB8AC3E}">
+        <p14:creationId xmlns:p14="http://schemas.microsoft.com/office/powerpoint/2010/main" val="3892594497"/>
+      </p:ext>
+    </p:extLst>
+  </p:cSld>
+  <p:clrMapOvr>
+    <a:masterClrMapping/>
+  </p:clrMapOvr>
+</p:sld>
+</file>
+
+<file path=ppt/slides/slide4.xml><?xml version="1.0" encoding="utf-8"?>
+<p:sld xmlns:a="http://schemas.openxmlformats.org/drawingml/2006/main" xmlns:r="http://schemas.openxmlformats.org/officeDocument/2006/relationships" xmlns:p="http://schemas.openxmlformats.org/presentationml/2006/main">
+  <p:cSld>
+    <p:spTree>
+      <p:nvGrpSpPr>
+        <p:cNvPr id="1" name=""/>
+        <p:cNvGrpSpPr/>
+        <p:nvPr/>
+      </p:nvGrpSpPr>
+      <p:grpSpPr>
+        <a:xfrm>
+          <a:off x="0" y="0"/>
+          <a:ext cx="0" cy="0"/>
+          <a:chOff x="0" y="0"/>
+          <a:chExt cx="0" cy="0"/>
+        </a:xfrm>
+      </p:grpSpPr>
+      <p:sp>
+        <p:nvSpPr>
+          <p:cNvPr id="2" name="Title 1">
+            <a:extLst>
+              <a:ext uri="{FF2B5EF4-FFF2-40B4-BE49-F238E27FC236}">
                 <a16:creationId xmlns:a16="http://schemas.microsoft.com/office/drawing/2014/main" id="{3343424C-E439-20D8-CED5-BA96DDBF373D}"/>
               </a:ext>
             </a:extLst>
@@ -3226,7 +4278,7 @@
           <a:lstStyle/>
           <a:p>
             <a:r>
-              <a:rPr lang="en-US" sz="3600" b="1" dirty="0"/>
+              <a:rPr lang="en-US" dirty="0"/>
               <a:t>Network Visualization I</a:t>
             </a:r>
           </a:p>
@@ -3275,7 +4327,7 @@
 </p:sld>
 </file>
 
-<file path=ppt/slides/slide11.xml><?xml version="1.0" encoding="utf-8"?>
+<file path=ppt/slides/slide5.xml><?xml version="1.0" encoding="utf-8"?>
 <p:sld xmlns:a="http://schemas.openxmlformats.org/drawingml/2006/main" xmlns:r="http://schemas.openxmlformats.org/officeDocument/2006/relationships" xmlns:p="http://schemas.openxmlformats.org/presentationml/2006/main">
   <p:cSld>
     <p:spTree>
@@ -3316,10 +4368,9 @@
           <a:lstStyle/>
           <a:p>
             <a:r>
-              <a:rPr lang="en-US" sz="3600" b="1" dirty="0"/>
+              <a:rPr lang="en-US" dirty="0"/>
               <a:t>Network Visualization II</a:t>
             </a:r>
-            <a:endParaRPr lang="en-US" sz="3600" dirty="0"/>
           </a:p>
         </p:txBody>
       </p:sp>
@@ -3535,7 +4586,7 @@
 </p:sld>
 </file>
 
-<file path=ppt/slides/slide12.xml><?xml version="1.0" encoding="utf-8"?>
+<file path=ppt/slides/slide6.xml><?xml version="1.0" encoding="utf-8"?>
 <p:sld xmlns:a="http://schemas.openxmlformats.org/drawingml/2006/main" xmlns:r="http://schemas.openxmlformats.org/officeDocument/2006/relationships" xmlns:p="http://schemas.openxmlformats.org/presentationml/2006/main">
   <p:cSld>
     <p:spTree>
@@ -3576,7 +4627,7 @@
           <a:lstStyle/>
           <a:p>
             <a:r>
-              <a:rPr lang="en-US" sz="3600" b="1" dirty="0"/>
+              <a:rPr lang="en-US" dirty="0"/>
               <a:t>Network Visualization III</a:t>
             </a:r>
           </a:p>
@@ -3584,10 +4635,10 @@
       </p:sp>
       <p:pic>
         <p:nvPicPr>
-          <p:cNvPr id="5" name="Picture 4">
+          <p:cNvPr id="7" name="Picture 6">
             <a:extLst>
               <a:ext uri="{FF2B5EF4-FFF2-40B4-BE49-F238E27FC236}">
-                <a16:creationId xmlns:a16="http://schemas.microsoft.com/office/drawing/2014/main" id="{B6A01586-0EB0-B6FC-CAA9-C6A5F45C1AAB}"/>
+                <a16:creationId xmlns:a16="http://schemas.microsoft.com/office/drawing/2014/main" id="{1236196F-4122-9A57-9944-28B5EFE9CB97}"/>
               </a:ext>
             </a:extLst>
           </p:cNvPr>
@@ -3604,37 +4655,7 @@
         </p:blipFill>
         <p:spPr>
           <a:xfrm>
-            <a:off x="0" y="1417638"/>
-            <a:ext cx="4280710" cy="2785192"/>
-          </a:xfrm>
-          <a:prstGeom prst="rect">
-            <a:avLst/>
-          </a:prstGeom>
-        </p:spPr>
-      </p:pic>
-      <p:pic>
-        <p:nvPicPr>
-          <p:cNvPr id="7" name="Picture 6">
-            <a:extLst>
-              <a:ext uri="{FF2B5EF4-FFF2-40B4-BE49-F238E27FC236}">
-                <a16:creationId xmlns:a16="http://schemas.microsoft.com/office/drawing/2014/main" id="{1236196F-4122-9A57-9944-28B5EFE9CB97}"/>
-              </a:ext>
-            </a:extLst>
-          </p:cNvPr>
-          <p:cNvPicPr>
-            <a:picLocks noChangeAspect="1"/>
-          </p:cNvPicPr>
-          <p:nvPr/>
-        </p:nvPicPr>
-        <p:blipFill>
-          <a:blip r:embed="rId3"/>
-          <a:stretch>
-            <a:fillRect/>
-          </a:stretch>
-        </p:blipFill>
-        <p:spPr>
-          <a:xfrm>
-            <a:off x="6988606" y="1417638"/>
+            <a:off x="7528778" y="1417638"/>
             <a:ext cx="4280710" cy="2785192"/>
           </a:xfrm>
           <a:prstGeom prst="rect">
@@ -3657,6 +4678,36 @@
           <p:nvPr/>
         </p:nvPicPr>
         <p:blipFill>
+          <a:blip r:embed="rId3"/>
+          <a:stretch>
+            <a:fillRect/>
+          </a:stretch>
+        </p:blipFill>
+        <p:spPr>
+          <a:xfrm>
+            <a:off x="3671947" y="3429000"/>
+            <a:ext cx="4848106" cy="3154362"/>
+          </a:xfrm>
+          <a:prstGeom prst="rect">
+            <a:avLst/>
+          </a:prstGeom>
+        </p:spPr>
+      </p:pic>
+      <p:pic>
+        <p:nvPicPr>
+          <p:cNvPr id="5" name="Picture 4">
+            <a:extLst>
+              <a:ext uri="{FF2B5EF4-FFF2-40B4-BE49-F238E27FC236}">
+                <a16:creationId xmlns:a16="http://schemas.microsoft.com/office/drawing/2014/main" id="{B6A01586-0EB0-B6FC-CAA9-C6A5F45C1AAB}"/>
+              </a:ext>
+            </a:extLst>
+          </p:cNvPr>
+          <p:cNvPicPr>
+            <a:picLocks noChangeAspect="1"/>
+          </p:cNvPicPr>
+          <p:nvPr/>
+        </p:nvPicPr>
+        <p:blipFill>
           <a:blip r:embed="rId4"/>
           <a:stretch>
             <a:fillRect/>
@@ -3664,8 +4715,8 @@
         </p:blipFill>
         <p:spPr>
           <a:xfrm>
-            <a:off x="3333069" y="3429001"/>
-            <a:ext cx="4848106" cy="3154362"/>
+            <a:off x="382512" y="1417638"/>
+            <a:ext cx="4280710" cy="2785192"/>
           </a:xfrm>
           <a:prstGeom prst="rect">
             <a:avLst/>
@@ -3678,1471 +4729,6 @@
         <p14:creationId xmlns:p14="http://schemas.microsoft.com/office/powerpoint/2010/main" val="3432858617"/>
       </p:ext>
     </p:extLst>
-  </p:cSld>
-  <p:clrMapOvr>
-    <a:masterClrMapping/>
-  </p:clrMapOvr>
-</p:sld>
-</file>
-
-<file path=ppt/slides/slide13.xml><?xml version="1.0" encoding="utf-8"?>
-<p:sld xmlns:a="http://schemas.openxmlformats.org/drawingml/2006/main" xmlns:r="http://schemas.openxmlformats.org/officeDocument/2006/relationships" xmlns:p="http://schemas.openxmlformats.org/presentationml/2006/main">
-  <p:cSld>
-    <p:spTree>
-      <p:nvGrpSpPr>
-        <p:cNvPr id="1" name=""/>
-        <p:cNvGrpSpPr/>
-        <p:nvPr/>
-      </p:nvGrpSpPr>
-      <p:grpSpPr>
-        <a:xfrm>
-          <a:off x="0" y="0"/>
-          <a:ext cx="0" cy="0"/>
-          <a:chOff x="0" y="0"/>
-          <a:chExt cx="0" cy="0"/>
-        </a:xfrm>
-      </p:grpSpPr>
-      <p:sp>
-        <p:nvSpPr>
-          <p:cNvPr id="2" name="Title 1">
-            <a:extLst>
-              <a:ext uri="{FF2B5EF4-FFF2-40B4-BE49-F238E27FC236}">
-                <a16:creationId xmlns:a16="http://schemas.microsoft.com/office/drawing/2014/main" id="{79EE23CE-3967-3E06-F685-FAD97CD86183}"/>
-              </a:ext>
-            </a:extLst>
-          </p:cNvPr>
-          <p:cNvSpPr>
-            <a:spLocks noGrp="1"/>
-          </p:cNvSpPr>
-          <p:nvPr>
-            <p:ph type="title"/>
-          </p:nvPr>
-        </p:nvSpPr>
-        <p:spPr/>
-        <p:txBody>
-          <a:bodyPr>
-            <a:normAutofit/>
-          </a:bodyPr>
-          <a:lstStyle/>
-          <a:p>
-            <a:r>
-              <a:rPr lang="en-US" sz="3600" b="1" dirty="0"/>
-              <a:t>Important Nodes</a:t>
-            </a:r>
-          </a:p>
-        </p:txBody>
-      </p:sp>
-      <p:sp>
-        <p:nvSpPr>
-          <p:cNvPr id="3" name="Content Placeholder 2">
-            <a:extLst>
-              <a:ext uri="{FF2B5EF4-FFF2-40B4-BE49-F238E27FC236}">
-                <a16:creationId xmlns:a16="http://schemas.microsoft.com/office/drawing/2014/main" id="{49E7C214-9017-0F08-EA44-DF5A2B478FC4}"/>
-              </a:ext>
-            </a:extLst>
-          </p:cNvPr>
-          <p:cNvSpPr>
-            <a:spLocks noGrp="1"/>
-          </p:cNvSpPr>
-          <p:nvPr>
-            <p:ph idx="1"/>
-          </p:nvPr>
-        </p:nvSpPr>
-        <p:spPr>
-          <a:xfrm>
-            <a:off x="609600" y="1417638"/>
-            <a:ext cx="3831771" cy="5165724"/>
-          </a:xfrm>
-        </p:spPr>
-        <p:txBody>
-          <a:bodyPr>
-            <a:normAutofit fontScale="47500" lnSpcReduction="20000"/>
-          </a:bodyPr>
-          <a:lstStyle/>
-          <a:p>
-            <a:pPr marL="0" indent="0">
-              <a:buNone/>
-            </a:pPr>
-            <a:r>
-              <a:rPr lang="en-US" sz="5100" b="1" dirty="0"/>
-              <a:t>Highly Central Nodes in Real Graph</a:t>
-            </a:r>
-          </a:p>
-          <a:p>
-            <a:pPr marL="0" indent="0">
-              <a:buNone/>
-            </a:pPr>
-            <a:endParaRPr lang="en-US" dirty="0"/>
-          </a:p>
-          <a:p>
-            <a:pPr marL="0" indent="0">
-              <a:buNone/>
-            </a:pPr>
-            <a:r>
-              <a:rPr lang="en-US" sz="4200" dirty="0"/>
-              <a:t>Top 5 by Degree: </a:t>
-            </a:r>
-          </a:p>
-          <a:p>
-            <a:pPr marL="0" indent="0">
-              <a:buNone/>
-            </a:pPr>
-            <a:r>
-              <a:rPr lang="en-US" sz="4200" dirty="0"/>
-              <a:t>Node 44: 34 edges </a:t>
-            </a:r>
-          </a:p>
-          <a:p>
-            <a:pPr marL="0" indent="0">
-              <a:buNone/>
-            </a:pPr>
-            <a:r>
-              <a:rPr lang="en-US" sz="4200" dirty="0"/>
-              <a:t>Node 45: 27 edges </a:t>
-            </a:r>
-          </a:p>
-          <a:p>
-            <a:pPr marL="0" indent="0">
-              <a:buNone/>
-            </a:pPr>
-            <a:r>
-              <a:rPr lang="en-US" sz="4200" dirty="0"/>
-              <a:t>Node 107: 27 edges </a:t>
-            </a:r>
-          </a:p>
-          <a:p>
-            <a:pPr marL="0" indent="0">
-              <a:buNone/>
-            </a:pPr>
-            <a:r>
-              <a:rPr lang="en-US" sz="4200" dirty="0"/>
-              <a:t>Node 46: 21 edges </a:t>
-            </a:r>
-          </a:p>
-          <a:p>
-            <a:pPr marL="0" indent="0">
-              <a:buNone/>
-            </a:pPr>
-            <a:r>
-              <a:rPr lang="en-US" sz="4200" dirty="0"/>
-              <a:t>Node 532: 20 edges </a:t>
-            </a:r>
-          </a:p>
-          <a:p>
-            <a:pPr marL="0" indent="0">
-              <a:buNone/>
-            </a:pPr>
-            <a:endParaRPr lang="en-US" sz="4200" dirty="0"/>
-          </a:p>
-          <a:p>
-            <a:pPr marL="0" indent="0">
-              <a:buNone/>
-            </a:pPr>
-            <a:r>
-              <a:rPr lang="en-US" sz="4200" dirty="0"/>
-              <a:t>Top 5 by Betweenness Centrality: </a:t>
-            </a:r>
-          </a:p>
-          <a:p>
-            <a:pPr marL="0" indent="0">
-              <a:buNone/>
-            </a:pPr>
-            <a:r>
-              <a:rPr lang="en-US" sz="4200" dirty="0"/>
-              <a:t>Node 107: 0.021924 </a:t>
-            </a:r>
-          </a:p>
-          <a:p>
-            <a:pPr marL="0" indent="0">
-              <a:buNone/>
-            </a:pPr>
-            <a:r>
-              <a:rPr lang="en-US" sz="4200" dirty="0"/>
-              <a:t>Node 185: 0.017579 </a:t>
-            </a:r>
-          </a:p>
-          <a:p>
-            <a:pPr marL="0" indent="0">
-              <a:buNone/>
-            </a:pPr>
-            <a:r>
-              <a:rPr lang="en-US" sz="4200" dirty="0"/>
-              <a:t>Node 329: 0.017510 </a:t>
-            </a:r>
-          </a:p>
-          <a:p>
-            <a:pPr marL="0" indent="0">
-              <a:buNone/>
-            </a:pPr>
-            <a:r>
-              <a:rPr lang="en-US" sz="4200" dirty="0"/>
-              <a:t>Node 121: 0.017130 </a:t>
-            </a:r>
-          </a:p>
-          <a:p>
-            <a:pPr marL="0" indent="0">
-              <a:buNone/>
-            </a:pPr>
-            <a:r>
-              <a:rPr lang="en-US" sz="4200" dirty="0"/>
-              <a:t>Node 205: 0.013582 </a:t>
-            </a:r>
-          </a:p>
-          <a:p>
-            <a:pPr marL="0" indent="0">
-              <a:buNone/>
-            </a:pPr>
-            <a:endParaRPr lang="en-US" dirty="0"/>
-          </a:p>
-          <a:p>
-            <a:pPr marL="0" indent="0">
-              <a:buNone/>
-            </a:pPr>
-            <a:endParaRPr lang="en-US" dirty="0"/>
-          </a:p>
-        </p:txBody>
-      </p:sp>
-      <p:sp>
-        <p:nvSpPr>
-          <p:cNvPr id="4" name="TextBox 3">
-            <a:extLst>
-              <a:ext uri="{FF2B5EF4-FFF2-40B4-BE49-F238E27FC236}">
-                <a16:creationId xmlns:a16="http://schemas.microsoft.com/office/drawing/2014/main" id="{6C074C14-C96B-825E-1B75-AD00B68CA4FC}"/>
-              </a:ext>
-            </a:extLst>
-          </p:cNvPr>
-          <p:cNvSpPr txBox="1"/>
-          <p:nvPr/>
-        </p:nvSpPr>
-        <p:spPr>
-          <a:xfrm>
-            <a:off x="4441371" y="1305670"/>
-            <a:ext cx="3676262" cy="5109091"/>
-          </a:xfrm>
-          <a:prstGeom prst="rect">
-            <a:avLst/>
-          </a:prstGeom>
-          <a:noFill/>
-        </p:spPr>
-        <p:txBody>
-          <a:bodyPr wrap="square" rtlCol="0">
-            <a:spAutoFit/>
-          </a:bodyPr>
-          <a:lstStyle/>
-          <a:p>
-            <a:r>
-              <a:rPr lang="en-US" sz="2400" b="1" dirty="0"/>
-              <a:t>Highly Central Nodes in Random Graph</a:t>
-            </a:r>
-          </a:p>
-          <a:p>
-            <a:endParaRPr lang="en-US" dirty="0"/>
-          </a:p>
-          <a:p>
-            <a:r>
-              <a:rPr lang="en-US" sz="2000" dirty="0"/>
-              <a:t>Top 5 by Degree: </a:t>
-            </a:r>
-          </a:p>
-          <a:p>
-            <a:r>
-              <a:rPr lang="en-US" sz="2000" dirty="0"/>
-              <a:t>Node 670: 12 edges </a:t>
-            </a:r>
-          </a:p>
-          <a:p>
-            <a:r>
-              <a:rPr lang="en-US" sz="2000" dirty="0"/>
-              <a:t>Node 690: 12 edges </a:t>
-            </a:r>
-          </a:p>
-          <a:p>
-            <a:r>
-              <a:rPr lang="en-US" sz="2000" dirty="0"/>
-              <a:t>Node 154: 11 edges </a:t>
-            </a:r>
-          </a:p>
-          <a:p>
-            <a:r>
-              <a:rPr lang="en-US" sz="2000" dirty="0"/>
-              <a:t>Node 29: 10 edges </a:t>
-            </a:r>
-          </a:p>
-          <a:p>
-            <a:r>
-              <a:rPr lang="en-US" sz="2000" dirty="0"/>
-              <a:t>Node 261: 10 edges </a:t>
-            </a:r>
-          </a:p>
-          <a:p>
-            <a:endParaRPr lang="en-US" sz="2000" dirty="0"/>
-          </a:p>
-          <a:p>
-            <a:r>
-              <a:rPr lang="en-US" sz="2000" dirty="0"/>
-              <a:t>Top 5 by Betweenness Centrality: </a:t>
-            </a:r>
-          </a:p>
-          <a:p>
-            <a:r>
-              <a:rPr lang="en-US" sz="2000" dirty="0"/>
-              <a:t>Node 1063: 0.022408 </a:t>
-            </a:r>
-          </a:p>
-          <a:p>
-            <a:r>
-              <a:rPr lang="en-US" sz="2000" dirty="0"/>
-              <a:t>Node 1426: 0.022274 </a:t>
-            </a:r>
-          </a:p>
-          <a:p>
-            <a:r>
-              <a:rPr lang="en-US" sz="2000" dirty="0"/>
-              <a:t>Node 670: 0.021199 </a:t>
-            </a:r>
-          </a:p>
-          <a:p>
-            <a:r>
-              <a:rPr lang="en-US" sz="2000" dirty="0"/>
-              <a:t>Node 29: 0.020611 </a:t>
-            </a:r>
-          </a:p>
-          <a:p>
-            <a:r>
-              <a:rPr lang="en-US" sz="2000" dirty="0"/>
-              <a:t>Node 154: 0.020269 </a:t>
-            </a:r>
-          </a:p>
-        </p:txBody>
-      </p:sp>
-      <p:sp>
-        <p:nvSpPr>
-          <p:cNvPr id="5" name="TextBox 4">
-            <a:extLst>
-              <a:ext uri="{FF2B5EF4-FFF2-40B4-BE49-F238E27FC236}">
-                <a16:creationId xmlns:a16="http://schemas.microsoft.com/office/drawing/2014/main" id="{B5A0743E-3302-1D62-F94B-0DA145953297}"/>
-              </a:ext>
-            </a:extLst>
-          </p:cNvPr>
-          <p:cNvSpPr txBox="1"/>
-          <p:nvPr/>
-        </p:nvSpPr>
-        <p:spPr>
-          <a:xfrm>
-            <a:off x="8223379" y="1286905"/>
-            <a:ext cx="3676262" cy="5109091"/>
-          </a:xfrm>
-          <a:prstGeom prst="rect">
-            <a:avLst/>
-          </a:prstGeom>
-          <a:noFill/>
-        </p:spPr>
-        <p:txBody>
-          <a:bodyPr wrap="square" rtlCol="0">
-            <a:spAutoFit/>
-          </a:bodyPr>
-          <a:lstStyle/>
-          <a:p>
-            <a:r>
-              <a:rPr lang="en-US" sz="2400" b="1" dirty="0"/>
-              <a:t>Highly Central Nodes in Scale-Free Graph</a:t>
-            </a:r>
-          </a:p>
-          <a:p>
-            <a:endParaRPr lang="en-US" dirty="0"/>
-          </a:p>
-          <a:p>
-            <a:r>
-              <a:rPr lang="en-US" sz="2000" dirty="0"/>
-              <a:t>Top 5 by Degree:</a:t>
-            </a:r>
-          </a:p>
-          <a:p>
-            <a:r>
-              <a:rPr lang="en-US" sz="2000" dirty="0"/>
-              <a:t>Node 0: 103 edges </a:t>
-            </a:r>
-          </a:p>
-          <a:p>
-            <a:r>
-              <a:rPr lang="en-US" sz="2000" dirty="0"/>
-              <a:t>Node 1: 89 edges </a:t>
-            </a:r>
-          </a:p>
-          <a:p>
-            <a:r>
-              <a:rPr lang="en-US" sz="2000" dirty="0"/>
-              <a:t>Node 4: 78 edges </a:t>
-            </a:r>
-          </a:p>
-          <a:p>
-            <a:r>
-              <a:rPr lang="en-US" sz="2000" dirty="0"/>
-              <a:t>Node 6: 62 edges </a:t>
-            </a:r>
-          </a:p>
-          <a:p>
-            <a:r>
-              <a:rPr lang="en-US" sz="2000" dirty="0"/>
-              <a:t>Node 16: 42 edges </a:t>
-            </a:r>
-          </a:p>
-          <a:p>
-            <a:endParaRPr lang="en-US" sz="2000" dirty="0"/>
-          </a:p>
-          <a:p>
-            <a:r>
-              <a:rPr lang="en-US" sz="2000" dirty="0"/>
-              <a:t>Top 5 by Betweenness Centrality: </a:t>
-            </a:r>
-          </a:p>
-          <a:p>
-            <a:r>
-              <a:rPr lang="en-US" sz="2000" dirty="0"/>
-              <a:t>Node 0: 0.235513 </a:t>
-            </a:r>
-          </a:p>
-          <a:p>
-            <a:r>
-              <a:rPr lang="en-US" sz="2000" dirty="0"/>
-              <a:t>Node 1: 0.214777 </a:t>
-            </a:r>
-          </a:p>
-          <a:p>
-            <a:r>
-              <a:rPr lang="en-US" sz="2000" dirty="0"/>
-              <a:t>Node 4: 0.178849</a:t>
-            </a:r>
-          </a:p>
-          <a:p>
-            <a:r>
-              <a:rPr lang="en-US" sz="2000" dirty="0"/>
-              <a:t>Node 6: 0.160739 </a:t>
-            </a:r>
-          </a:p>
-          <a:p>
-            <a:r>
-              <a:rPr lang="en-US" sz="2000" dirty="0"/>
-              <a:t>Node 16: 0.060915</a:t>
-            </a:r>
-          </a:p>
-        </p:txBody>
-      </p:sp>
-      <p:graphicFrame>
-        <p:nvGraphicFramePr>
-          <p:cNvPr id="6" name="Table 5">
-            <a:extLst>
-              <a:ext uri="{FF2B5EF4-FFF2-40B4-BE49-F238E27FC236}">
-                <a16:creationId xmlns:a16="http://schemas.microsoft.com/office/drawing/2014/main" id="{12CE1A74-3532-598C-DFE4-3C95E2F1AF02}"/>
-              </a:ext>
-            </a:extLst>
-          </p:cNvPr>
-          <p:cNvGraphicFramePr>
-            <a:graphicFrameLocks noGrp="1"/>
-          </p:cNvGraphicFramePr>
-          <p:nvPr>
-            <p:extLst>
-              <p:ext uri="{D42A27DB-BD31-4B8C-83A1-F6EECF244321}">
-                <p14:modId xmlns:p14="http://schemas.microsoft.com/office/powerpoint/2010/main" val="696217807"/>
-              </p:ext>
-            </p:extLst>
-          </p:nvPr>
-        </p:nvGraphicFramePr>
-        <p:xfrm>
-          <a:off x="1147533" y="2772084"/>
-          <a:ext cx="9683814" cy="2325345"/>
-        </p:xfrm>
-        <a:graphic>
-          <a:graphicData uri="http://schemas.openxmlformats.org/drawingml/2006/table">
-            <a:tbl>
-              <a:tblPr firstRow="1" bandRow="1">
-                <a:tableStyleId>{5C22544A-7EE6-4342-B048-85BDC9FD1C3A}</a:tableStyleId>
-              </a:tblPr>
-              <a:tblGrid>
-                <a:gridCol w="1827530">
-                  <a:extLst>
-                    <a:ext uri="{9D8B030D-6E8A-4147-A177-3AD203B41FA5}">
-                      <a16:colId xmlns:a16="http://schemas.microsoft.com/office/drawing/2014/main" val="3907867901"/>
-                    </a:ext>
-                  </a:extLst>
-                </a:gridCol>
-                <a:gridCol w="2790000">
-                  <a:extLst>
-                    <a:ext uri="{9D8B030D-6E8A-4147-A177-3AD203B41FA5}">
-                      <a16:colId xmlns:a16="http://schemas.microsoft.com/office/drawing/2014/main" val="2873117807"/>
-                    </a:ext>
-                  </a:extLst>
-                </a:gridCol>
-                <a:gridCol w="2642743">
-                  <a:extLst>
-                    <a:ext uri="{9D8B030D-6E8A-4147-A177-3AD203B41FA5}">
-                      <a16:colId xmlns:a16="http://schemas.microsoft.com/office/drawing/2014/main" val="3202549202"/>
-                    </a:ext>
-                  </a:extLst>
-                </a:gridCol>
-                <a:gridCol w="2423541">
-                  <a:extLst>
-                    <a:ext uri="{9D8B030D-6E8A-4147-A177-3AD203B41FA5}">
-                      <a16:colId xmlns:a16="http://schemas.microsoft.com/office/drawing/2014/main" val="1808895448"/>
-                    </a:ext>
-                  </a:extLst>
-                </a:gridCol>
-              </a:tblGrid>
-              <a:tr h="677973">
-                <a:tc>
-                  <a:txBody>
-                    <a:bodyPr/>
-                    <a:lstStyle/>
-                    <a:p>
-                      <a:r>
-                        <a:rPr lang="en-US" sz="2000" dirty="0"/>
-                        <a:t>Centrality Type</a:t>
-                      </a:r>
-                    </a:p>
-                  </a:txBody>
-                  <a:tcPr/>
-                </a:tc>
-                <a:tc>
-                  <a:txBody>
-                    <a:bodyPr/>
-                    <a:lstStyle/>
-                    <a:p>
-                      <a:r>
-                        <a:rPr lang="en-US" sz="2000" dirty="0"/>
-                        <a:t>Real Network</a:t>
-                      </a:r>
-                    </a:p>
-                  </a:txBody>
-                  <a:tcPr/>
-                </a:tc>
-                <a:tc>
-                  <a:txBody>
-                    <a:bodyPr/>
-                    <a:lstStyle/>
-                    <a:p>
-                      <a:r>
-                        <a:rPr lang="en-US" sz="2000" dirty="0"/>
-                        <a:t>Random Network</a:t>
-                      </a:r>
-                    </a:p>
-                  </a:txBody>
-                  <a:tcPr/>
-                </a:tc>
-                <a:tc>
-                  <a:txBody>
-                    <a:bodyPr/>
-                    <a:lstStyle/>
-                    <a:p>
-                      <a:r>
-                        <a:rPr lang="en-US" sz="2000" dirty="0"/>
-                        <a:t>Scale-free Network</a:t>
-                      </a:r>
-                    </a:p>
-                  </a:txBody>
-                  <a:tcPr/>
-                </a:tc>
-                <a:extLst>
-                  <a:ext uri="{0D108BD9-81ED-4DB2-BD59-A6C34878D82A}">
-                    <a16:rowId xmlns:a16="http://schemas.microsoft.com/office/drawing/2014/main" val="1630775892"/>
-                  </a:ext>
-                </a:extLst>
-              </a:tr>
-              <a:tr h="370840">
-                <a:tc>
-                  <a:txBody>
-                    <a:bodyPr/>
-                    <a:lstStyle/>
-                    <a:p>
-                      <a:r>
-                        <a:rPr lang="en-US" sz="2000" dirty="0"/>
-                        <a:t>Hubs(Degree)</a:t>
-                      </a:r>
-                    </a:p>
-                  </a:txBody>
-                  <a:tcPr/>
-                </a:tc>
-                <a:tc>
-                  <a:txBody>
-                    <a:bodyPr/>
-                    <a:lstStyle/>
-                    <a:p>
-                      <a:r>
-                        <a:rPr lang="en-US" sz="2000" dirty="0"/>
-                        <a:t>Node 44 (34 edges)</a:t>
-                      </a:r>
-                    </a:p>
-                  </a:txBody>
-                  <a:tcPr/>
-                </a:tc>
-                <a:tc>
-                  <a:txBody>
-                    <a:bodyPr/>
-                    <a:lstStyle/>
-                    <a:p>
-                      <a:r>
-                        <a:rPr lang="en-US" sz="2000" dirty="0"/>
-                        <a:t>Node 670 (12 edges)</a:t>
-                      </a:r>
-                    </a:p>
-                  </a:txBody>
-                  <a:tcPr/>
-                </a:tc>
-                <a:tc>
-                  <a:txBody>
-                    <a:bodyPr/>
-                    <a:lstStyle/>
-                    <a:p>
-                      <a:r>
-                        <a:rPr lang="en-US" sz="2000" dirty="0"/>
-                        <a:t>Node 0 (103 edges)</a:t>
-                      </a:r>
-                    </a:p>
-                  </a:txBody>
-                  <a:tcPr/>
-                </a:tc>
-                <a:extLst>
-                  <a:ext uri="{0D108BD9-81ED-4DB2-BD59-A6C34878D82A}">
-                    <a16:rowId xmlns:a16="http://schemas.microsoft.com/office/drawing/2014/main" val="3377972218"/>
-                  </a:ext>
-                </a:extLst>
-              </a:tr>
-              <a:tr h="370840">
-                <a:tc>
-                  <a:txBody>
-                    <a:bodyPr/>
-                    <a:lstStyle/>
-                    <a:p>
-                      <a:r>
-                        <a:rPr lang="en-US" sz="2000" dirty="0"/>
-                        <a:t>Insight</a:t>
-                      </a:r>
-                    </a:p>
-                  </a:txBody>
-                  <a:tcPr/>
-                </a:tc>
-                <a:tc>
-                  <a:txBody>
-                    <a:bodyPr/>
-                    <a:lstStyle/>
-                    <a:p>
-                      <a:r>
-                        <a:rPr lang="en-US" sz="2000" dirty="0"/>
-                        <a:t>Moderate Concentration</a:t>
-                      </a:r>
-                    </a:p>
-                  </a:txBody>
-                  <a:tcPr/>
-                </a:tc>
-                <a:tc>
-                  <a:txBody>
-                    <a:bodyPr/>
-                    <a:lstStyle/>
-                    <a:p>
-                      <a:r>
-                        <a:rPr lang="en-US" sz="2000" dirty="0"/>
-                        <a:t>Very flat</a:t>
-                      </a:r>
-                    </a:p>
-                  </a:txBody>
-                  <a:tcPr/>
-                </a:tc>
-                <a:tc>
-                  <a:txBody>
-                    <a:bodyPr/>
-                    <a:lstStyle/>
-                    <a:p>
-                      <a:r>
-                        <a:rPr lang="en-US" sz="2000" dirty="0"/>
-                        <a:t>Massive hub</a:t>
-                      </a:r>
-                    </a:p>
-                  </a:txBody>
-                  <a:tcPr/>
-                </a:tc>
-                <a:extLst>
-                  <a:ext uri="{0D108BD9-81ED-4DB2-BD59-A6C34878D82A}">
-                    <a16:rowId xmlns:a16="http://schemas.microsoft.com/office/drawing/2014/main" val="597515445"/>
-                  </a:ext>
-                </a:extLst>
-              </a:tr>
-              <a:tr h="458652">
-                <a:tc>
-                  <a:txBody>
-                    <a:bodyPr/>
-                    <a:lstStyle/>
-                    <a:p>
-                      <a:r>
-                        <a:rPr lang="en-US" sz="2000" dirty="0"/>
-                        <a:t>Betweenness</a:t>
-                      </a:r>
-                    </a:p>
-                  </a:txBody>
-                  <a:tcPr/>
-                </a:tc>
-                <a:tc>
-                  <a:txBody>
-                    <a:bodyPr/>
-                    <a:lstStyle/>
-                    <a:p>
-                      <a:r>
-                        <a:rPr lang="en-US" sz="2000" dirty="0"/>
-                        <a:t>Node 107 (0.022)</a:t>
-                      </a:r>
-                    </a:p>
-                  </a:txBody>
-                  <a:tcPr/>
-                </a:tc>
-                <a:tc>
-                  <a:txBody>
-                    <a:bodyPr/>
-                    <a:lstStyle/>
-                    <a:p>
-                      <a:r>
-                        <a:rPr lang="en-US" sz="2000" dirty="0"/>
-                        <a:t>Node 1063 (0.022)</a:t>
-                      </a:r>
-                    </a:p>
-                  </a:txBody>
-                  <a:tcPr/>
-                </a:tc>
-                <a:tc>
-                  <a:txBody>
-                    <a:bodyPr/>
-                    <a:lstStyle/>
-                    <a:p>
-                      <a:r>
-                        <a:rPr lang="en-US" sz="2000" dirty="0"/>
-                        <a:t>Node 0 (0.24)</a:t>
-                      </a:r>
-                    </a:p>
-                  </a:txBody>
-                  <a:tcPr/>
-                </a:tc>
-                <a:extLst>
-                  <a:ext uri="{0D108BD9-81ED-4DB2-BD59-A6C34878D82A}">
-                    <a16:rowId xmlns:a16="http://schemas.microsoft.com/office/drawing/2014/main" val="2362316916"/>
-                  </a:ext>
-                </a:extLst>
-              </a:tr>
-              <a:tr h="370840">
-                <a:tc>
-                  <a:txBody>
-                    <a:bodyPr/>
-                    <a:lstStyle/>
-                    <a:p>
-                      <a:r>
-                        <a:rPr lang="en-US" sz="2000" dirty="0"/>
-                        <a:t>Insight</a:t>
-                      </a:r>
-                    </a:p>
-                  </a:txBody>
-                  <a:tcPr/>
-                </a:tc>
-                <a:tc>
-                  <a:txBody>
-                    <a:bodyPr/>
-                    <a:lstStyle/>
-                    <a:p>
-                      <a:r>
-                        <a:rPr lang="en-US" sz="2000" dirty="0"/>
-                        <a:t>Strategic connectors</a:t>
-                      </a:r>
-                    </a:p>
-                  </a:txBody>
-                  <a:tcPr/>
-                </a:tc>
-                <a:tc>
-                  <a:txBody>
-                    <a:bodyPr/>
-                    <a:lstStyle/>
-                    <a:p>
-                      <a:r>
-                        <a:rPr lang="en-US" sz="2000" dirty="0"/>
-                        <a:t>Distributed importance</a:t>
-                      </a:r>
-                    </a:p>
-                  </a:txBody>
-                  <a:tcPr/>
-                </a:tc>
-                <a:tc>
-                  <a:txBody>
-                    <a:bodyPr/>
-                    <a:lstStyle/>
-                    <a:p>
-                      <a:r>
-                        <a:rPr lang="en-US" sz="2000" dirty="0"/>
-                        <a:t>Structural Bottleneck</a:t>
-                      </a:r>
-                    </a:p>
-                  </a:txBody>
-                  <a:tcPr/>
-                </a:tc>
-                <a:extLst>
-                  <a:ext uri="{0D108BD9-81ED-4DB2-BD59-A6C34878D82A}">
-                    <a16:rowId xmlns:a16="http://schemas.microsoft.com/office/drawing/2014/main" val="3473861958"/>
-                  </a:ext>
-                </a:extLst>
-              </a:tr>
-            </a:tbl>
-          </a:graphicData>
-        </a:graphic>
-      </p:graphicFrame>
-    </p:spTree>
-    <p:extLst>
-      <p:ext uri="{BB962C8B-B14F-4D97-AF65-F5344CB8AC3E}">
-        <p14:creationId xmlns:p14="http://schemas.microsoft.com/office/powerpoint/2010/main" val="1327103432"/>
-      </p:ext>
-    </p:extLst>
-  </p:cSld>
-  <p:clrMapOvr>
-    <a:masterClrMapping/>
-  </p:clrMapOvr>
-</p:sld>
-</file>
-
-<file path=ppt/slides/slide14.xml><?xml version="1.0" encoding="utf-8"?>
-<p:sld xmlns:a="http://schemas.openxmlformats.org/drawingml/2006/main" xmlns:r="http://schemas.openxmlformats.org/officeDocument/2006/relationships" xmlns:p="http://schemas.openxmlformats.org/presentationml/2006/main">
-  <p:cSld>
-    <p:spTree>
-      <p:nvGrpSpPr>
-        <p:cNvPr id="1" name=""/>
-        <p:cNvGrpSpPr/>
-        <p:nvPr/>
-      </p:nvGrpSpPr>
-      <p:grpSpPr>
-        <a:xfrm>
-          <a:off x="0" y="0"/>
-          <a:ext cx="0" cy="0"/>
-          <a:chOff x="0" y="0"/>
-          <a:chExt cx="0" cy="0"/>
-        </a:xfrm>
-      </p:grpSpPr>
-      <p:sp>
-        <p:nvSpPr>
-          <p:cNvPr id="2" name="Title 1">
-            <a:extLst>
-              <a:ext uri="{FF2B5EF4-FFF2-40B4-BE49-F238E27FC236}">
-                <a16:creationId xmlns:a16="http://schemas.microsoft.com/office/drawing/2014/main" id="{5DC2F755-FA74-89D1-AB53-CBFDF8CB5DEC}"/>
-              </a:ext>
-            </a:extLst>
-          </p:cNvPr>
-          <p:cNvSpPr>
-            <a:spLocks noGrp="1"/>
-          </p:cNvSpPr>
-          <p:nvPr>
-            <p:ph type="title"/>
-          </p:nvPr>
-        </p:nvSpPr>
-        <p:spPr/>
-        <p:txBody>
-          <a:bodyPr>
-            <a:normAutofit/>
-          </a:bodyPr>
-          <a:lstStyle/>
-          <a:p>
-            <a:r>
-              <a:rPr lang="en-US" sz="3600" b="1" dirty="0"/>
-              <a:t>What type of network is the selected real network?</a:t>
-            </a:r>
-          </a:p>
-        </p:txBody>
-      </p:sp>
-      <p:sp>
-        <p:nvSpPr>
-          <p:cNvPr id="3" name="Content Placeholder 2">
-            <a:extLst>
-              <a:ext uri="{FF2B5EF4-FFF2-40B4-BE49-F238E27FC236}">
-                <a16:creationId xmlns:a16="http://schemas.microsoft.com/office/drawing/2014/main" id="{53670E19-1A00-7C37-3B63-9C311043CFE5}"/>
-              </a:ext>
-            </a:extLst>
-          </p:cNvPr>
-          <p:cNvSpPr>
-            <a:spLocks noGrp="1"/>
-          </p:cNvSpPr>
-          <p:nvPr>
-            <p:ph idx="1"/>
-          </p:nvPr>
-        </p:nvSpPr>
-        <p:spPr/>
-        <p:txBody>
-          <a:bodyPr>
-            <a:normAutofit/>
-          </a:bodyPr>
-          <a:lstStyle/>
-          <a:p>
-            <a:pPr marL="0" indent="0">
-              <a:buNone/>
-            </a:pPr>
-            <a:r>
-              <a:rPr lang="en-US" sz="2000" dirty="0"/>
-              <a:t>The </a:t>
-            </a:r>
-            <a:r>
-              <a:rPr lang="en-US" sz="2000" b="1" dirty="0"/>
-              <a:t>dimacs10-netscience</a:t>
-            </a:r>
-            <a:r>
-              <a:rPr lang="en-US" sz="2000" dirty="0"/>
-              <a:t> dataset is an undirected network of co-authorships in the area of network science. </a:t>
-            </a:r>
-          </a:p>
-          <a:p>
-            <a:pPr marL="0" indent="0">
-              <a:buNone/>
-            </a:pPr>
-            <a:endParaRPr lang="en-US" sz="2000" dirty="0"/>
-          </a:p>
-          <a:p>
-            <a:pPr marL="0" indent="0">
-              <a:buNone/>
-            </a:pPr>
-            <a:r>
-              <a:rPr lang="en-US" sz="2000" b="1" dirty="0"/>
-              <a:t>Significance &amp; Meaning:</a:t>
-            </a:r>
-            <a:r>
-              <a:rPr lang="en-US" sz="2000" dirty="0"/>
-              <a:t> Nodes represent authors (researchers), and links represent a co-authorship between them (they have written a paper together).</a:t>
-            </a:r>
-          </a:p>
-          <a:p>
-            <a:pPr marL="0" indent="0">
-              <a:buNone/>
-            </a:pPr>
-            <a:endParaRPr lang="en-US" sz="2000" dirty="0"/>
-          </a:p>
-          <a:p>
-            <a:pPr marL="0" indent="0">
-              <a:buNone/>
-            </a:pPr>
-            <a:r>
-              <a:rPr lang="en-US" sz="2000" b="1" dirty="0"/>
-              <a:t>Type of Network:</a:t>
-            </a:r>
-            <a:r>
-              <a:rPr lang="en-US" sz="2000" dirty="0"/>
-              <a:t> It is a </a:t>
-            </a:r>
-            <a:r>
-              <a:rPr lang="en-US" sz="2000" b="1" dirty="0"/>
-              <a:t>Co-authorship/Collaboration Network</a:t>
-            </a:r>
-            <a:r>
-              <a:rPr lang="en-US" sz="2000" dirty="0"/>
-              <a:t>. Because it reflects human collaboration and distinct research communities, it exhibits "small-world" properties (a high clustering coefficient, as co-authors of a researcher are very likely to co-author with each other) and "scale-free" characteristics (a heavy-tailed degree distribution where a few highly published researchers act as massive hubs). We can observe these hallmarks by comparing its structural metrics to the Erdős-Rényi and </a:t>
-            </a:r>
-            <a:r>
-              <a:rPr lang="en-US" sz="2000" dirty="0" err="1"/>
-              <a:t>Barabási</a:t>
-            </a:r>
-            <a:r>
-              <a:rPr lang="en-US" sz="2000" dirty="0"/>
-              <a:t>-Albert models.</a:t>
-            </a:r>
-          </a:p>
-          <a:p>
-            <a:endParaRPr lang="en-US" sz="2000" dirty="0"/>
-          </a:p>
-        </p:txBody>
-      </p:sp>
-    </p:spTree>
-    <p:extLst>
-      <p:ext uri="{BB962C8B-B14F-4D97-AF65-F5344CB8AC3E}">
-        <p14:creationId xmlns:p14="http://schemas.microsoft.com/office/powerpoint/2010/main" val="978290815"/>
-      </p:ext>
-    </p:extLst>
-  </p:cSld>
-  <p:clrMapOvr>
-    <a:masterClrMapping/>
-  </p:clrMapOvr>
-</p:sld>
-</file>
-
-<file path=ppt/slides/slide2.xml><?xml version="1.0" encoding="utf-8"?>
-<p:sld xmlns:a="http://schemas.openxmlformats.org/drawingml/2006/main" xmlns:r="http://schemas.openxmlformats.org/officeDocument/2006/relationships" xmlns:p="http://schemas.openxmlformats.org/presentationml/2006/main">
-  <p:cSld>
-    <p:spTree>
-      <p:nvGrpSpPr>
-        <p:cNvPr id="1" name=""/>
-        <p:cNvGrpSpPr/>
-        <p:nvPr/>
-      </p:nvGrpSpPr>
-      <p:grpSpPr>
-        <a:xfrm>
-          <a:off x="0" y="0"/>
-          <a:ext cx="0" cy="0"/>
-          <a:chOff x="0" y="0"/>
-          <a:chExt cx="0" cy="0"/>
-        </a:xfrm>
-      </p:grpSpPr>
-      <p:sp>
-        <p:nvSpPr>
-          <p:cNvPr id="2" name="Title 1"/>
-          <p:cNvSpPr>
-            <a:spLocks noGrp="1"/>
-          </p:cNvSpPr>
-          <p:nvPr>
-            <p:ph type="title"/>
-          </p:nvPr>
-        </p:nvSpPr>
-        <p:spPr/>
-        <p:txBody>
-          <a:bodyPr/>
-          <a:lstStyle/>
-          <a:p>
-            <a:r>
-              <a:rPr dirty="0"/>
-              <a:t>Dataset Overview</a:t>
-            </a:r>
-          </a:p>
-        </p:txBody>
-      </p:sp>
-      <p:sp>
-        <p:nvSpPr>
-          <p:cNvPr id="4" name="TextBox 3"/>
-          <p:cNvSpPr txBox="1"/>
-          <p:nvPr/>
-        </p:nvSpPr>
-        <p:spPr>
-          <a:xfrm>
-            <a:off x="2255521" y="1280160"/>
-            <a:ext cx="7010317" cy="1569660"/>
-          </a:xfrm>
-          <a:prstGeom prst="rect">
-            <a:avLst/>
-          </a:prstGeom>
-          <a:noFill/>
-        </p:spPr>
-        <p:txBody>
-          <a:bodyPr wrap="none">
-            <a:spAutoFit/>
-          </a:bodyPr>
-          <a:lstStyle/>
-          <a:p>
-            <a:pPr>
-              <a:defRPr sz="2400"/>
-            </a:pPr>
-            <a:r>
-              <a:rPr sz="2400" dirty="0"/>
-              <a:t>Dataset: dimacs10-netscience (co-authorship network)</a:t>
-            </a:r>
-          </a:p>
-          <a:p>
-            <a:pPr>
-              <a:defRPr sz="2400"/>
-            </a:pPr>
-            <a:r>
-              <a:rPr sz="2400" dirty="0"/>
-              <a:t>Nodes (authors): 1461</a:t>
-            </a:r>
-          </a:p>
-          <a:p>
-            <a:pPr>
-              <a:defRPr sz="2400"/>
-            </a:pPr>
-            <a:r>
-              <a:rPr sz="2400" dirty="0"/>
-              <a:t>Edges (co-authorship links): 2742</a:t>
-            </a:r>
-          </a:p>
-          <a:p>
-            <a:pPr>
-              <a:defRPr sz="2400"/>
-            </a:pPr>
-            <a:r>
-              <a:rPr sz="2400" dirty="0"/>
-              <a:t>Graph type: undirected, unweighted, no self-loops</a:t>
-            </a:r>
-          </a:p>
-        </p:txBody>
-      </p:sp>
-    </p:spTree>
-  </p:cSld>
-  <p:clrMapOvr>
-    <a:masterClrMapping/>
-  </p:clrMapOvr>
-</p:sld>
-</file>
-
-<file path=ppt/slides/slide3.xml><?xml version="1.0" encoding="utf-8"?>
-<p:sld xmlns:a="http://schemas.openxmlformats.org/drawingml/2006/main" xmlns:r="http://schemas.openxmlformats.org/officeDocument/2006/relationships" xmlns:p="http://schemas.openxmlformats.org/presentationml/2006/main">
-  <p:cSld>
-    <p:spTree>
-      <p:nvGrpSpPr>
-        <p:cNvPr id="1" name=""/>
-        <p:cNvGrpSpPr/>
-        <p:nvPr/>
-      </p:nvGrpSpPr>
-      <p:grpSpPr>
-        <a:xfrm>
-          <a:off x="0" y="0"/>
-          <a:ext cx="0" cy="0"/>
-          <a:chOff x="0" y="0"/>
-          <a:chExt cx="0" cy="0"/>
-        </a:xfrm>
-      </p:grpSpPr>
-      <p:sp>
-        <p:nvSpPr>
-          <p:cNvPr id="2" name="Title 1"/>
-          <p:cNvSpPr>
-            <a:spLocks noGrp="1"/>
-          </p:cNvSpPr>
-          <p:nvPr>
-            <p:ph type="title"/>
-          </p:nvPr>
-        </p:nvSpPr>
-        <p:spPr/>
-        <p:txBody>
-          <a:bodyPr/>
-          <a:lstStyle/>
-          <a:p>
-            <a:r>
-              <a:t>Experimental Setup</a:t>
-            </a:r>
-          </a:p>
-        </p:txBody>
-      </p:sp>
-      <p:sp>
-        <p:nvSpPr>
-          <p:cNvPr id="4" name="TextBox 3"/>
-          <p:cNvSpPr txBox="1"/>
-          <p:nvPr/>
-        </p:nvSpPr>
-        <p:spPr>
-          <a:xfrm>
-            <a:off x="2255520" y="1280160"/>
-            <a:ext cx="7818872" cy="1938992"/>
-          </a:xfrm>
-          <a:prstGeom prst="rect">
-            <a:avLst/>
-          </a:prstGeom>
-          <a:noFill/>
-        </p:spPr>
-        <p:txBody>
-          <a:bodyPr wrap="none">
-            <a:spAutoFit/>
-          </a:bodyPr>
-          <a:lstStyle/>
-          <a:p>
-            <a:pPr>
-              <a:defRPr sz="2400"/>
-            </a:pPr>
-            <a:r>
-              <a:rPr sz="2400" dirty="0"/>
-              <a:t>Null model 1: </a:t>
-            </a:r>
-            <a:r>
-              <a:rPr sz="2400" dirty="0" err="1"/>
-              <a:t>Erdos-Renyi</a:t>
-            </a:r>
-            <a:r>
-              <a:rPr sz="2400" dirty="0"/>
-              <a:t> G(n, p) using real-network density</a:t>
-            </a:r>
-          </a:p>
-          <a:p>
-            <a:pPr>
-              <a:defRPr sz="2400"/>
-            </a:pPr>
-            <a:r>
-              <a:rPr sz="2400" dirty="0"/>
-              <a:t>Null model 2: </a:t>
-            </a:r>
-            <a:r>
-              <a:rPr sz="2400" dirty="0" err="1"/>
-              <a:t>Barabasi</a:t>
-            </a:r>
-            <a:r>
-              <a:rPr sz="2400" dirty="0"/>
-              <a:t>-Albert using m ~ M/N</a:t>
-            </a:r>
-          </a:p>
-          <a:p>
-            <a:pPr>
-              <a:defRPr sz="2400"/>
-            </a:pPr>
-            <a:r>
-              <a:rPr sz="2400" dirty="0"/>
-              <a:t>Purpose: compare random, preferential-attachment, and real</a:t>
-            </a:r>
-            <a:endParaRPr lang="en-US" sz="2400" dirty="0"/>
-          </a:p>
-          <a:p>
-            <a:pPr>
-              <a:defRPr sz="2400"/>
-            </a:pPr>
-            <a:r>
-              <a:rPr sz="2400" dirty="0"/>
-              <a:t>collaboration structure</a:t>
-            </a:r>
-          </a:p>
-          <a:p>
-            <a:pPr>
-              <a:defRPr sz="2400"/>
-            </a:pPr>
-            <a:r>
-              <a:rPr sz="2400" dirty="0"/>
-              <a:t>ER p used: 0.002571; BA m used: 2</a:t>
-            </a:r>
-          </a:p>
-        </p:txBody>
-      </p:sp>
-    </p:spTree>
-  </p:cSld>
-  <p:clrMapOvr>
-    <a:masterClrMapping/>
-  </p:clrMapOvr>
-</p:sld>
-</file>
-
-<file path=ppt/slides/slide4.xml><?xml version="1.0" encoding="utf-8"?>
-<p:sld xmlns:a="http://schemas.openxmlformats.org/drawingml/2006/main" xmlns:r="http://schemas.openxmlformats.org/officeDocument/2006/relationships" xmlns:p="http://schemas.openxmlformats.org/presentationml/2006/main">
-  <p:cSld>
-    <p:spTree>
-      <p:nvGrpSpPr>
-        <p:cNvPr id="1" name=""/>
-        <p:cNvGrpSpPr/>
-        <p:nvPr/>
-      </p:nvGrpSpPr>
-      <p:grpSpPr>
-        <a:xfrm>
-          <a:off x="0" y="0"/>
-          <a:ext cx="0" cy="0"/>
-          <a:chOff x="0" y="0"/>
-          <a:chExt cx="0" cy="0"/>
-        </a:xfrm>
-      </p:grpSpPr>
-      <p:sp>
-        <p:nvSpPr>
-          <p:cNvPr id="2" name="Title 1"/>
-          <p:cNvSpPr>
-            <a:spLocks noGrp="1"/>
-          </p:cNvSpPr>
-          <p:nvPr>
-            <p:ph type="title"/>
-          </p:nvPr>
-        </p:nvSpPr>
-        <p:spPr/>
-        <p:txBody>
-          <a:bodyPr/>
-          <a:lstStyle/>
-          <a:p>
-            <a:r>
-              <a:t>Topology Comparison</a:t>
-            </a:r>
-          </a:p>
-        </p:txBody>
-      </p:sp>
-      <p:pic>
-        <p:nvPicPr>
-          <p:cNvPr id="3" name="Picture 2" descr="topology_comparison.png"/>
-          <p:cNvPicPr>
-            <a:picLocks noChangeAspect="1"/>
-          </p:cNvPicPr>
-          <p:nvPr/>
-        </p:nvPicPr>
-        <p:blipFill>
-          <a:blip r:embed="rId2"/>
-          <a:stretch>
-            <a:fillRect/>
-          </a:stretch>
-        </p:blipFill>
-        <p:spPr>
-          <a:xfrm>
-            <a:off x="2055562" y="2100998"/>
-            <a:ext cx="8080877" cy="2656005"/>
-          </a:xfrm>
-          <a:prstGeom prst="rect">
-            <a:avLst/>
-          </a:prstGeom>
-        </p:spPr>
-      </p:pic>
-    </p:spTree>
-  </p:cSld>
-  <p:clrMapOvr>
-    <a:masterClrMapping/>
-  </p:clrMapOvr>
-</p:sld>
-</file>
-
-<file path=ppt/slides/slide5.xml><?xml version="1.0" encoding="utf-8"?>
-<p:sld xmlns:a="http://schemas.openxmlformats.org/drawingml/2006/main" xmlns:r="http://schemas.openxmlformats.org/officeDocument/2006/relationships" xmlns:p="http://schemas.openxmlformats.org/presentationml/2006/main">
-  <p:cSld>
-    <p:spTree>
-      <p:nvGrpSpPr>
-        <p:cNvPr id="1" name=""/>
-        <p:cNvGrpSpPr/>
-        <p:nvPr/>
-      </p:nvGrpSpPr>
-      <p:grpSpPr>
-        <a:xfrm>
-          <a:off x="0" y="0"/>
-          <a:ext cx="0" cy="0"/>
-          <a:chOff x="0" y="0"/>
-          <a:chExt cx="0" cy="0"/>
-        </a:xfrm>
-      </p:grpSpPr>
-      <p:sp>
-        <p:nvSpPr>
-          <p:cNvPr id="2" name="Title 1"/>
-          <p:cNvSpPr>
-            <a:spLocks noGrp="1"/>
-          </p:cNvSpPr>
-          <p:nvPr>
-            <p:ph type="title"/>
-          </p:nvPr>
-        </p:nvSpPr>
-        <p:spPr/>
-        <p:txBody>
-          <a:bodyPr/>
-          <a:lstStyle/>
-          <a:p>
-            <a:r>
-              <a:t>Degree Distribution (log-log)</a:t>
-            </a:r>
-          </a:p>
-        </p:txBody>
-      </p:sp>
-      <p:pic>
-        <p:nvPicPr>
-          <p:cNvPr id="3" name="Picture 2" descr="degree_distribution.png"/>
-          <p:cNvPicPr>
-            <a:picLocks noChangeAspect="1"/>
-          </p:cNvPicPr>
-          <p:nvPr/>
-        </p:nvPicPr>
-        <p:blipFill>
-          <a:blip r:embed="rId2"/>
-          <a:stretch>
-            <a:fillRect/>
-          </a:stretch>
-        </p:blipFill>
-        <p:spPr>
-          <a:xfrm>
-            <a:off x="2083526" y="2444879"/>
-            <a:ext cx="8024949" cy="1968243"/>
-          </a:xfrm>
-          <a:prstGeom prst="rect">
-            <a:avLst/>
-          </a:prstGeom>
-        </p:spPr>
-      </p:pic>
-    </p:spTree>
-  </p:cSld>
-  <p:clrMapOvr>
-    <a:masterClrMapping/>
-  </p:clrMapOvr>
-</p:sld>
-</file>
-
-<file path=ppt/slides/slide6.xml><?xml version="1.0" encoding="utf-8"?>
-<p:sld xmlns:a="http://schemas.openxmlformats.org/drawingml/2006/main" xmlns:r="http://schemas.openxmlformats.org/officeDocument/2006/relationships" xmlns:p="http://schemas.openxmlformats.org/presentationml/2006/main">
-  <p:cSld>
-    <p:spTree>
-      <p:nvGrpSpPr>
-        <p:cNvPr id="1" name=""/>
-        <p:cNvGrpSpPr/>
-        <p:nvPr/>
-      </p:nvGrpSpPr>
-      <p:grpSpPr>
-        <a:xfrm>
-          <a:off x="0" y="0"/>
-          <a:ext cx="0" cy="0"/>
-          <a:chOff x="0" y="0"/>
-          <a:chExt cx="0" cy="0"/>
-        </a:xfrm>
-      </p:grpSpPr>
-      <p:sp>
-        <p:nvSpPr>
-          <p:cNvPr id="2" name="Title 1"/>
-          <p:cNvSpPr>
-            <a:spLocks noGrp="1"/>
-          </p:cNvSpPr>
-          <p:nvPr>
-            <p:ph type="title"/>
-          </p:nvPr>
-        </p:nvSpPr>
-        <p:spPr/>
-        <p:txBody>
-          <a:bodyPr/>
-          <a:lstStyle/>
-          <a:p>
-            <a:r>
-              <a:t>Key Findings</a:t>
-            </a:r>
-          </a:p>
-        </p:txBody>
-      </p:sp>
-      <p:sp>
-        <p:nvSpPr>
-          <p:cNvPr id="4" name="TextBox 3"/>
-          <p:cNvSpPr txBox="1"/>
-          <p:nvPr/>
-        </p:nvSpPr>
-        <p:spPr>
-          <a:xfrm>
-            <a:off x="2255520" y="1280160"/>
-            <a:ext cx="6787114" cy="1938992"/>
-          </a:xfrm>
-          <a:prstGeom prst="rect">
-            <a:avLst/>
-          </a:prstGeom>
-          <a:noFill/>
-        </p:spPr>
-        <p:txBody>
-          <a:bodyPr wrap="none">
-            <a:spAutoFit/>
-          </a:bodyPr>
-          <a:lstStyle/>
-          <a:p>
-            <a:pPr>
-              <a:defRPr sz="2400"/>
-            </a:pPr>
-            <a:r>
-              <a:rPr sz="2400" dirty="0"/>
-              <a:t>Real graph clustering is high: 0.694</a:t>
-            </a:r>
-          </a:p>
-          <a:p>
-            <a:pPr>
-              <a:defRPr sz="2400"/>
-            </a:pPr>
-            <a:r>
-              <a:rPr sz="2400" dirty="0"/>
-              <a:t>ER clustering is very low: 0.004</a:t>
-            </a:r>
-          </a:p>
-          <a:p>
-            <a:pPr>
-              <a:defRPr sz="2400"/>
-            </a:pPr>
-            <a:r>
-              <a:rPr sz="2400" dirty="0"/>
-              <a:t>BA max degree is much larger than ER: 103 vs 12</a:t>
-            </a:r>
-          </a:p>
-          <a:p>
-            <a:pPr>
-              <a:defRPr sz="2400"/>
-            </a:pPr>
-            <a:r>
-              <a:rPr sz="2400" dirty="0"/>
-              <a:t>Interpretation: real network shows both small-world </a:t>
-            </a:r>
-            <a:endParaRPr lang="en-US" sz="2400" dirty="0"/>
-          </a:p>
-          <a:p>
-            <a:pPr>
-              <a:defRPr sz="2400"/>
-            </a:pPr>
-            <a:r>
-              <a:rPr sz="2400" dirty="0"/>
-              <a:t>clustering and hub structure</a:t>
-            </a:r>
-          </a:p>
-        </p:txBody>
-      </p:sp>
-    </p:spTree>
   </p:cSld>
   <p:clrMapOvr>
     <a:masterClrMapping/>
@@ -5169,7 +4755,13 @@
       </p:grpSpPr>
       <p:sp>
         <p:nvSpPr>
-          <p:cNvPr id="2" name="Title 1"/>
+          <p:cNvPr id="2" name="Title 1">
+            <a:extLst>
+              <a:ext uri="{FF2B5EF4-FFF2-40B4-BE49-F238E27FC236}">
+                <a16:creationId xmlns:a16="http://schemas.microsoft.com/office/drawing/2014/main" id="{79EE23CE-3967-3E06-F685-FAD97CD86183}"/>
+              </a:ext>
+            </a:extLst>
+          </p:cNvPr>
           <p:cNvSpPr>
             <a:spLocks noGrp="1"/>
           </p:cNvSpPr>
@@ -5179,25 +4771,700 @@
         </p:nvSpPr>
         <p:spPr/>
         <p:txBody>
-          <a:bodyPr/>
+          <a:bodyPr>
+            <a:normAutofit/>
+          </a:bodyPr>
           <a:lstStyle/>
           <a:p>
             <a:r>
-              <a:t>Core Metrics Summary</a:t>
-            </a:r>
-          </a:p>
-        </p:txBody>
-      </p:sp>
-      <p:sp>
-        <p:nvSpPr>
-          <p:cNvPr id="4" name="TextBox 3"/>
+              <a:rPr lang="en-US" dirty="0"/>
+              <a:t>Important Nodes</a:t>
+            </a:r>
+          </a:p>
+        </p:txBody>
+      </p:sp>
+      <p:graphicFrame>
+        <p:nvGraphicFramePr>
+          <p:cNvPr id="8" name="Table 7">
+            <a:extLst>
+              <a:ext uri="{FF2B5EF4-FFF2-40B4-BE49-F238E27FC236}">
+                <a16:creationId xmlns:a16="http://schemas.microsoft.com/office/drawing/2014/main" id="{9DC851AA-8634-D415-DBC6-5EC749ED3AEB}"/>
+              </a:ext>
+            </a:extLst>
+          </p:cNvPr>
+          <p:cNvGraphicFramePr>
+            <a:graphicFrameLocks noGrp="1"/>
+          </p:cNvGraphicFramePr>
+          <p:nvPr>
+            <p:extLst>
+              <p:ext uri="{D42A27DB-BD31-4B8C-83A1-F6EECF244321}">
+                <p14:modId xmlns:p14="http://schemas.microsoft.com/office/powerpoint/2010/main" val="2590311429"/>
+              </p:ext>
+            </p:extLst>
+          </p:nvPr>
+        </p:nvGraphicFramePr>
+        <p:xfrm>
+          <a:off x="725469" y="2738105"/>
+          <a:ext cx="4908308" cy="2494280"/>
+        </p:xfrm>
+        <a:graphic>
+          <a:graphicData uri="http://schemas.openxmlformats.org/drawingml/2006/table">
+            <a:tbl>
+              <a:tblPr firstRow="1" bandRow="1">
+                <a:tableStyleId>{5C22544A-7EE6-4342-B048-85BDC9FD1C3A}</a:tableStyleId>
+              </a:tblPr>
+              <a:tblGrid>
+                <a:gridCol w="1633089">
+                  <a:extLst>
+                    <a:ext uri="{9D8B030D-6E8A-4147-A177-3AD203B41FA5}">
+                      <a16:colId xmlns:a16="http://schemas.microsoft.com/office/drawing/2014/main" val="2127533527"/>
+                    </a:ext>
+                  </a:extLst>
+                </a:gridCol>
+                <a:gridCol w="1674272">
+                  <a:extLst>
+                    <a:ext uri="{9D8B030D-6E8A-4147-A177-3AD203B41FA5}">
+                      <a16:colId xmlns:a16="http://schemas.microsoft.com/office/drawing/2014/main" val="1414862941"/>
+                    </a:ext>
+                  </a:extLst>
+                </a:gridCol>
+                <a:gridCol w="1600947">
+                  <a:extLst>
+                    <a:ext uri="{9D8B030D-6E8A-4147-A177-3AD203B41FA5}">
+                      <a16:colId xmlns:a16="http://schemas.microsoft.com/office/drawing/2014/main" val="3040874083"/>
+                    </a:ext>
+                  </a:extLst>
+                </a:gridCol>
+              </a:tblGrid>
+              <a:tr h="356860">
+                <a:tc>
+                  <a:txBody>
+                    <a:bodyPr/>
+                    <a:lstStyle/>
+                    <a:p>
+                      <a:r>
+                        <a:rPr lang="en-US" dirty="0"/>
+                        <a:t>Real Network</a:t>
+                      </a:r>
+                    </a:p>
+                  </a:txBody>
+                  <a:tcPr/>
+                </a:tc>
+                <a:tc>
+                  <a:txBody>
+                    <a:bodyPr/>
+                    <a:lstStyle/>
+                    <a:p>
+                      <a:r>
+                        <a:rPr lang="en-US" dirty="0"/>
+                        <a:t>Random Network</a:t>
+                      </a:r>
+                    </a:p>
+                  </a:txBody>
+                  <a:tcPr/>
+                </a:tc>
+                <a:tc>
+                  <a:txBody>
+                    <a:bodyPr/>
+                    <a:lstStyle/>
+                    <a:p>
+                      <a:r>
+                        <a:rPr lang="en-US" dirty="0"/>
+                        <a:t>Scale Free Network</a:t>
+                      </a:r>
+                    </a:p>
+                  </a:txBody>
+                  <a:tcPr/>
+                </a:tc>
+                <a:extLst>
+                  <a:ext uri="{0D108BD9-81ED-4DB2-BD59-A6C34878D82A}">
+                    <a16:rowId xmlns:a16="http://schemas.microsoft.com/office/drawing/2014/main" val="1465639825"/>
+                  </a:ext>
+                </a:extLst>
+              </a:tr>
+              <a:tr h="370840">
+                <a:tc>
+                  <a:txBody>
+                    <a:bodyPr/>
+                    <a:lstStyle/>
+                    <a:p>
+                      <a:r>
+                        <a:rPr lang="en-US" dirty="0"/>
+                        <a:t>34</a:t>
+                      </a:r>
+                    </a:p>
+                  </a:txBody>
+                  <a:tcPr/>
+                </a:tc>
+                <a:tc>
+                  <a:txBody>
+                    <a:bodyPr/>
+                    <a:lstStyle/>
+                    <a:p>
+                      <a:r>
+                        <a:rPr lang="en-US" dirty="0"/>
+                        <a:t>12</a:t>
+                      </a:r>
+                    </a:p>
+                  </a:txBody>
+                  <a:tcPr/>
+                </a:tc>
+                <a:tc>
+                  <a:txBody>
+                    <a:bodyPr/>
+                    <a:lstStyle/>
+                    <a:p>
+                      <a:r>
+                        <a:rPr lang="en-US" dirty="0"/>
+                        <a:t>103</a:t>
+                      </a:r>
+                    </a:p>
+                  </a:txBody>
+                  <a:tcPr/>
+                </a:tc>
+                <a:extLst>
+                  <a:ext uri="{0D108BD9-81ED-4DB2-BD59-A6C34878D82A}">
+                    <a16:rowId xmlns:a16="http://schemas.microsoft.com/office/drawing/2014/main" val="460345241"/>
+                  </a:ext>
+                </a:extLst>
+              </a:tr>
+              <a:tr h="370840">
+                <a:tc>
+                  <a:txBody>
+                    <a:bodyPr/>
+                    <a:lstStyle/>
+                    <a:p>
+                      <a:r>
+                        <a:rPr lang="en-US" dirty="0"/>
+                        <a:t>27</a:t>
+                      </a:r>
+                    </a:p>
+                  </a:txBody>
+                  <a:tcPr/>
+                </a:tc>
+                <a:tc>
+                  <a:txBody>
+                    <a:bodyPr/>
+                    <a:lstStyle/>
+                    <a:p>
+                      <a:r>
+                        <a:rPr lang="en-US" dirty="0"/>
+                        <a:t>12</a:t>
+                      </a:r>
+                    </a:p>
+                  </a:txBody>
+                  <a:tcPr/>
+                </a:tc>
+                <a:tc>
+                  <a:txBody>
+                    <a:bodyPr/>
+                    <a:lstStyle/>
+                    <a:p>
+                      <a:r>
+                        <a:rPr lang="en-US" dirty="0"/>
+                        <a:t>89</a:t>
+                      </a:r>
+                    </a:p>
+                  </a:txBody>
+                  <a:tcPr/>
+                </a:tc>
+                <a:extLst>
+                  <a:ext uri="{0D108BD9-81ED-4DB2-BD59-A6C34878D82A}">
+                    <a16:rowId xmlns:a16="http://schemas.microsoft.com/office/drawing/2014/main" val="2397845370"/>
+                  </a:ext>
+                </a:extLst>
+              </a:tr>
+              <a:tr h="370840">
+                <a:tc>
+                  <a:txBody>
+                    <a:bodyPr/>
+                    <a:lstStyle/>
+                    <a:p>
+                      <a:r>
+                        <a:rPr lang="en-US" dirty="0"/>
+                        <a:t>27</a:t>
+                      </a:r>
+                    </a:p>
+                  </a:txBody>
+                  <a:tcPr/>
+                </a:tc>
+                <a:tc>
+                  <a:txBody>
+                    <a:bodyPr/>
+                    <a:lstStyle/>
+                    <a:p>
+                      <a:r>
+                        <a:rPr lang="en-US" dirty="0"/>
+                        <a:t>11</a:t>
+                      </a:r>
+                    </a:p>
+                  </a:txBody>
+                  <a:tcPr/>
+                </a:tc>
+                <a:tc>
+                  <a:txBody>
+                    <a:bodyPr/>
+                    <a:lstStyle/>
+                    <a:p>
+                      <a:r>
+                        <a:rPr lang="en-US" dirty="0"/>
+                        <a:t>78</a:t>
+                      </a:r>
+                    </a:p>
+                  </a:txBody>
+                  <a:tcPr/>
+                </a:tc>
+                <a:extLst>
+                  <a:ext uri="{0D108BD9-81ED-4DB2-BD59-A6C34878D82A}">
+                    <a16:rowId xmlns:a16="http://schemas.microsoft.com/office/drawing/2014/main" val="4171717739"/>
+                  </a:ext>
+                </a:extLst>
+              </a:tr>
+              <a:tr h="370840">
+                <a:tc>
+                  <a:txBody>
+                    <a:bodyPr/>
+                    <a:lstStyle/>
+                    <a:p>
+                      <a:r>
+                        <a:rPr lang="en-US" dirty="0"/>
+                        <a:t>21</a:t>
+                      </a:r>
+                    </a:p>
+                  </a:txBody>
+                  <a:tcPr/>
+                </a:tc>
+                <a:tc>
+                  <a:txBody>
+                    <a:bodyPr/>
+                    <a:lstStyle/>
+                    <a:p>
+                      <a:r>
+                        <a:rPr lang="en-US" dirty="0"/>
+                        <a:t>10</a:t>
+                      </a:r>
+                    </a:p>
+                  </a:txBody>
+                  <a:tcPr/>
+                </a:tc>
+                <a:tc>
+                  <a:txBody>
+                    <a:bodyPr/>
+                    <a:lstStyle/>
+                    <a:p>
+                      <a:r>
+                        <a:rPr lang="en-US" dirty="0"/>
+                        <a:t>62</a:t>
+                      </a:r>
+                    </a:p>
+                  </a:txBody>
+                  <a:tcPr/>
+                </a:tc>
+                <a:extLst>
+                  <a:ext uri="{0D108BD9-81ED-4DB2-BD59-A6C34878D82A}">
+                    <a16:rowId xmlns:a16="http://schemas.microsoft.com/office/drawing/2014/main" val="671563648"/>
+                  </a:ext>
+                </a:extLst>
+              </a:tr>
+              <a:tr h="370840">
+                <a:tc>
+                  <a:txBody>
+                    <a:bodyPr/>
+                    <a:lstStyle/>
+                    <a:p>
+                      <a:r>
+                        <a:rPr lang="en-US" dirty="0"/>
+                        <a:t>20</a:t>
+                      </a:r>
+                    </a:p>
+                  </a:txBody>
+                  <a:tcPr/>
+                </a:tc>
+                <a:tc>
+                  <a:txBody>
+                    <a:bodyPr/>
+                    <a:lstStyle/>
+                    <a:p>
+                      <a:r>
+                        <a:rPr lang="en-US" dirty="0"/>
+                        <a:t>10</a:t>
+                      </a:r>
+                    </a:p>
+                  </a:txBody>
+                  <a:tcPr/>
+                </a:tc>
+                <a:tc>
+                  <a:txBody>
+                    <a:bodyPr/>
+                    <a:lstStyle/>
+                    <a:p>
+                      <a:r>
+                        <a:rPr lang="en-US" dirty="0"/>
+                        <a:t>42</a:t>
+                      </a:r>
+                    </a:p>
+                  </a:txBody>
+                  <a:tcPr/>
+                </a:tc>
+                <a:extLst>
+                  <a:ext uri="{0D108BD9-81ED-4DB2-BD59-A6C34878D82A}">
+                    <a16:rowId xmlns:a16="http://schemas.microsoft.com/office/drawing/2014/main" val="3549531462"/>
+                  </a:ext>
+                </a:extLst>
+              </a:tr>
+            </a:tbl>
+          </a:graphicData>
+        </a:graphic>
+      </p:graphicFrame>
+      <p:graphicFrame>
+        <p:nvGraphicFramePr>
+          <p:cNvPr id="9" name="Table 8">
+            <a:extLst>
+              <a:ext uri="{FF2B5EF4-FFF2-40B4-BE49-F238E27FC236}">
+                <a16:creationId xmlns:a16="http://schemas.microsoft.com/office/drawing/2014/main" id="{AEBAA091-98CE-1587-64D6-FB14BF7DFFB6}"/>
+              </a:ext>
+            </a:extLst>
+          </p:cNvPr>
+          <p:cNvGraphicFramePr>
+            <a:graphicFrameLocks noGrp="1"/>
+          </p:cNvGraphicFramePr>
+          <p:nvPr>
+            <p:extLst>
+              <p:ext uri="{D42A27DB-BD31-4B8C-83A1-F6EECF244321}">
+                <p14:modId xmlns:p14="http://schemas.microsoft.com/office/powerpoint/2010/main" val="2461148213"/>
+              </p:ext>
+            </p:extLst>
+          </p:nvPr>
+        </p:nvGraphicFramePr>
+        <p:xfrm>
+          <a:off x="6873813" y="2741469"/>
+          <a:ext cx="4708587" cy="2494280"/>
+        </p:xfrm>
+        <a:graphic>
+          <a:graphicData uri="http://schemas.openxmlformats.org/drawingml/2006/table">
+            <a:tbl>
+              <a:tblPr firstRow="1" bandRow="1">
+                <a:tableStyleId>{5C22544A-7EE6-4342-B048-85BDC9FD1C3A}</a:tableStyleId>
+              </a:tblPr>
+              <a:tblGrid>
+                <a:gridCol w="1569529">
+                  <a:extLst>
+                    <a:ext uri="{9D8B030D-6E8A-4147-A177-3AD203B41FA5}">
+                      <a16:colId xmlns:a16="http://schemas.microsoft.com/office/drawing/2014/main" val="2127533527"/>
+                    </a:ext>
+                  </a:extLst>
+                </a:gridCol>
+                <a:gridCol w="1569529">
+                  <a:extLst>
+                    <a:ext uri="{9D8B030D-6E8A-4147-A177-3AD203B41FA5}">
+                      <a16:colId xmlns:a16="http://schemas.microsoft.com/office/drawing/2014/main" val="1414862941"/>
+                    </a:ext>
+                  </a:extLst>
+                </a:gridCol>
+                <a:gridCol w="1569529">
+                  <a:extLst>
+                    <a:ext uri="{9D8B030D-6E8A-4147-A177-3AD203B41FA5}">
+                      <a16:colId xmlns:a16="http://schemas.microsoft.com/office/drawing/2014/main" val="3040874083"/>
+                    </a:ext>
+                  </a:extLst>
+                </a:gridCol>
+              </a:tblGrid>
+              <a:tr h="349360">
+                <a:tc>
+                  <a:txBody>
+                    <a:bodyPr/>
+                    <a:lstStyle/>
+                    <a:p>
+                      <a:r>
+                        <a:rPr lang="en-US" dirty="0"/>
+                        <a:t>Real Network</a:t>
+                      </a:r>
+                    </a:p>
+                  </a:txBody>
+                  <a:tcPr/>
+                </a:tc>
+                <a:tc>
+                  <a:txBody>
+                    <a:bodyPr/>
+                    <a:lstStyle/>
+                    <a:p>
+                      <a:r>
+                        <a:rPr lang="en-US" dirty="0"/>
+                        <a:t>Random Network</a:t>
+                      </a:r>
+                    </a:p>
+                  </a:txBody>
+                  <a:tcPr/>
+                </a:tc>
+                <a:tc>
+                  <a:txBody>
+                    <a:bodyPr/>
+                    <a:lstStyle/>
+                    <a:p>
+                      <a:r>
+                        <a:rPr lang="en-US" dirty="0"/>
+                        <a:t>Scale Free Network</a:t>
+                      </a:r>
+                    </a:p>
+                  </a:txBody>
+                  <a:tcPr/>
+                </a:tc>
+                <a:extLst>
+                  <a:ext uri="{0D108BD9-81ED-4DB2-BD59-A6C34878D82A}">
+                    <a16:rowId xmlns:a16="http://schemas.microsoft.com/office/drawing/2014/main" val="1465639825"/>
+                  </a:ext>
+                </a:extLst>
+              </a:tr>
+              <a:tr h="370840">
+                <a:tc>
+                  <a:txBody>
+                    <a:bodyPr/>
+                    <a:lstStyle/>
+                    <a:p>
+                      <a:r>
+                        <a:rPr lang="en-US" dirty="0"/>
+                        <a:t>0.021924</a:t>
+                      </a:r>
+                    </a:p>
+                  </a:txBody>
+                  <a:tcPr/>
+                </a:tc>
+                <a:tc>
+                  <a:txBody>
+                    <a:bodyPr/>
+                    <a:lstStyle/>
+                    <a:p>
+                      <a:r>
+                        <a:rPr lang="en-US" dirty="0"/>
+                        <a:t>0.022408</a:t>
+                      </a:r>
+                    </a:p>
+                  </a:txBody>
+                  <a:tcPr/>
+                </a:tc>
+                <a:tc>
+                  <a:txBody>
+                    <a:bodyPr/>
+                    <a:lstStyle/>
+                    <a:p>
+                      <a:r>
+                        <a:rPr lang="en-US" dirty="0"/>
+                        <a:t>0.235513</a:t>
+                      </a:r>
+                    </a:p>
+                  </a:txBody>
+                  <a:tcPr/>
+                </a:tc>
+                <a:extLst>
+                  <a:ext uri="{0D108BD9-81ED-4DB2-BD59-A6C34878D82A}">
+                    <a16:rowId xmlns:a16="http://schemas.microsoft.com/office/drawing/2014/main" val="460345241"/>
+                  </a:ext>
+                </a:extLst>
+              </a:tr>
+              <a:tr h="370840">
+                <a:tc>
+                  <a:txBody>
+                    <a:bodyPr/>
+                    <a:lstStyle/>
+                    <a:p>
+                      <a:r>
+                        <a:rPr lang="en-US" dirty="0"/>
+                        <a:t>0.017579</a:t>
+                      </a:r>
+                    </a:p>
+                  </a:txBody>
+                  <a:tcPr/>
+                </a:tc>
+                <a:tc>
+                  <a:txBody>
+                    <a:bodyPr/>
+                    <a:lstStyle/>
+                    <a:p>
+                      <a:r>
+                        <a:rPr lang="en-US" dirty="0"/>
+                        <a:t>0.022274</a:t>
+                      </a:r>
+                    </a:p>
+                  </a:txBody>
+                  <a:tcPr/>
+                </a:tc>
+                <a:tc>
+                  <a:txBody>
+                    <a:bodyPr/>
+                    <a:lstStyle/>
+                    <a:p>
+                      <a:r>
+                        <a:rPr lang="en-US" dirty="0"/>
+                        <a:t>0.214777</a:t>
+                      </a:r>
+                    </a:p>
+                  </a:txBody>
+                  <a:tcPr/>
+                </a:tc>
+                <a:extLst>
+                  <a:ext uri="{0D108BD9-81ED-4DB2-BD59-A6C34878D82A}">
+                    <a16:rowId xmlns:a16="http://schemas.microsoft.com/office/drawing/2014/main" val="2397845370"/>
+                  </a:ext>
+                </a:extLst>
+              </a:tr>
+              <a:tr h="370840">
+                <a:tc>
+                  <a:txBody>
+                    <a:bodyPr/>
+                    <a:lstStyle/>
+                    <a:p>
+                      <a:r>
+                        <a:rPr lang="en-US" dirty="0"/>
+                        <a:t>0.017510</a:t>
+                      </a:r>
+                    </a:p>
+                  </a:txBody>
+                  <a:tcPr/>
+                </a:tc>
+                <a:tc>
+                  <a:txBody>
+                    <a:bodyPr/>
+                    <a:lstStyle/>
+                    <a:p>
+                      <a:r>
+                        <a:rPr lang="en-US" dirty="0"/>
+                        <a:t>0.021199</a:t>
+                      </a:r>
+                    </a:p>
+                  </a:txBody>
+                  <a:tcPr/>
+                </a:tc>
+                <a:tc>
+                  <a:txBody>
+                    <a:bodyPr/>
+                    <a:lstStyle/>
+                    <a:p>
+                      <a:r>
+                        <a:rPr lang="en-US" dirty="0"/>
+                        <a:t>0.178849</a:t>
+                      </a:r>
+                    </a:p>
+                  </a:txBody>
+                  <a:tcPr/>
+                </a:tc>
+                <a:extLst>
+                  <a:ext uri="{0D108BD9-81ED-4DB2-BD59-A6C34878D82A}">
+                    <a16:rowId xmlns:a16="http://schemas.microsoft.com/office/drawing/2014/main" val="4171717739"/>
+                  </a:ext>
+                </a:extLst>
+              </a:tr>
+              <a:tr h="370840">
+                <a:tc>
+                  <a:txBody>
+                    <a:bodyPr/>
+                    <a:lstStyle/>
+                    <a:p>
+                      <a:r>
+                        <a:rPr lang="en-US" dirty="0"/>
+                        <a:t>0.017130</a:t>
+                      </a:r>
+                    </a:p>
+                  </a:txBody>
+                  <a:tcPr/>
+                </a:tc>
+                <a:tc>
+                  <a:txBody>
+                    <a:bodyPr/>
+                    <a:lstStyle/>
+                    <a:p>
+                      <a:r>
+                        <a:rPr lang="en-US" dirty="0"/>
+                        <a:t>0.020611</a:t>
+                      </a:r>
+                    </a:p>
+                  </a:txBody>
+                  <a:tcPr/>
+                </a:tc>
+                <a:tc>
+                  <a:txBody>
+                    <a:bodyPr/>
+                    <a:lstStyle/>
+                    <a:p>
+                      <a:r>
+                        <a:rPr lang="en-US" dirty="0"/>
+                        <a:t>0.160739</a:t>
+                      </a:r>
+                    </a:p>
+                  </a:txBody>
+                  <a:tcPr/>
+                </a:tc>
+                <a:extLst>
+                  <a:ext uri="{0D108BD9-81ED-4DB2-BD59-A6C34878D82A}">
+                    <a16:rowId xmlns:a16="http://schemas.microsoft.com/office/drawing/2014/main" val="671563648"/>
+                  </a:ext>
+                </a:extLst>
+              </a:tr>
+              <a:tr h="370840">
+                <a:tc>
+                  <a:txBody>
+                    <a:bodyPr/>
+                    <a:lstStyle/>
+                    <a:p>
+                      <a:r>
+                        <a:rPr lang="en-US" dirty="0"/>
+                        <a:t>0.013582</a:t>
+                      </a:r>
+                    </a:p>
+                  </a:txBody>
+                  <a:tcPr/>
+                </a:tc>
+                <a:tc>
+                  <a:txBody>
+                    <a:bodyPr/>
+                    <a:lstStyle/>
+                    <a:p>
+                      <a:r>
+                        <a:rPr lang="en-US" dirty="0"/>
+                        <a:t>0.020269</a:t>
+                      </a:r>
+                    </a:p>
+                  </a:txBody>
+                  <a:tcPr/>
+                </a:tc>
+                <a:tc>
+                  <a:txBody>
+                    <a:bodyPr/>
+                    <a:lstStyle/>
+                    <a:p>
+                      <a:r>
+                        <a:rPr lang="en-US" dirty="0"/>
+                        <a:t>0.060915</a:t>
+                      </a:r>
+                    </a:p>
+                  </a:txBody>
+                  <a:tcPr/>
+                </a:tc>
+                <a:extLst>
+                  <a:ext uri="{0D108BD9-81ED-4DB2-BD59-A6C34878D82A}">
+                    <a16:rowId xmlns:a16="http://schemas.microsoft.com/office/drawing/2014/main" val="3549531462"/>
+                  </a:ext>
+                </a:extLst>
+              </a:tr>
+            </a:tbl>
+          </a:graphicData>
+        </a:graphic>
+      </p:graphicFrame>
+      <p:sp>
+        <p:nvSpPr>
+          <p:cNvPr id="12" name="TextBox 11">
+            <a:extLst>
+              <a:ext uri="{FF2B5EF4-FFF2-40B4-BE49-F238E27FC236}">
+                <a16:creationId xmlns:a16="http://schemas.microsoft.com/office/drawing/2014/main" id="{084FC62D-81E1-97D6-2CE3-C50BD825D5C5}"/>
+              </a:ext>
+            </a:extLst>
+          </p:cNvPr>
           <p:cNvSpPr txBox="1"/>
           <p:nvPr/>
         </p:nvSpPr>
         <p:spPr>
           <a:xfrm>
-            <a:off x="2255520" y="1280160"/>
-            <a:ext cx="7105984" cy="1938992"/>
+            <a:off x="1927822" y="2277513"/>
+            <a:ext cx="2473882" cy="461665"/>
           </a:xfrm>
           <a:prstGeom prst="rect">
             <a:avLst/>
@@ -5205,59 +5472,66 @@
           <a:noFill/>
         </p:spPr>
         <p:txBody>
-          <a:bodyPr wrap="none">
+          <a:bodyPr wrap="none" rtlCol="0">
             <a:spAutoFit/>
           </a:bodyPr>
           <a:lstStyle/>
           <a:p>
-            <a:pPr>
+            <a:r>
+              <a:rPr lang="en-US" sz="2400" dirty="0"/>
+              <a:t>Largest 5 Degrees:</a:t>
+            </a:r>
+          </a:p>
+        </p:txBody>
+      </p:sp>
+      <p:sp>
+        <p:nvSpPr>
+          <p:cNvPr id="13" name="TextBox 12">
+            <a:extLst>
+              <a:ext uri="{FF2B5EF4-FFF2-40B4-BE49-F238E27FC236}">
+                <a16:creationId xmlns:a16="http://schemas.microsoft.com/office/drawing/2014/main" id="{D1D43B55-4923-7754-FED3-FF520C91AEF2}"/>
+              </a:ext>
+            </a:extLst>
+          </p:cNvPr>
+          <p:cNvSpPr txBox="1"/>
+          <p:nvPr/>
+        </p:nvSpPr>
+        <p:spPr>
+          <a:xfrm>
+            <a:off x="6873813" y="2279659"/>
+            <a:ext cx="4604402" cy="461665"/>
+          </a:xfrm>
+          <a:prstGeom prst="rect">
+            <a:avLst/>
+          </a:prstGeom>
+          <a:noFill/>
+        </p:spPr>
+        <p:txBody>
+          <a:bodyPr wrap="none" rtlCol="0">
+            <a:spAutoFit/>
+          </a:bodyPr>
+          <a:lstStyle>
+            <a:defPPr>
+              <a:defRPr lang="en-US"/>
+            </a:defPPr>
+            <a:lvl1pPr>
               <a:defRPr sz="2400"/>
-            </a:pPr>
-            <a:r>
-              <a:rPr sz="2400" dirty="0"/>
-              <a:t>Real: components=268, LCC=379, diameter=17</a:t>
-            </a:r>
-          </a:p>
-          <a:p>
-            <a:pPr>
-              <a:defRPr sz="2400"/>
-            </a:pPr>
-            <a:r>
-              <a:rPr sz="2400" dirty="0"/>
-              <a:t>ER: components=46, LCC=1415, diameter=12</a:t>
-            </a:r>
-          </a:p>
-          <a:p>
-            <a:pPr>
-              <a:defRPr sz="2400"/>
-            </a:pPr>
-            <a:r>
-              <a:rPr sz="2400" dirty="0"/>
-              <a:t>BA: components=1, LCC=1461, diameter=8</a:t>
-            </a:r>
-          </a:p>
-          <a:p>
-            <a:pPr>
-              <a:defRPr sz="2400"/>
-            </a:pPr>
-            <a:r>
-              <a:rPr sz="2400" dirty="0"/>
-              <a:t>Conclusion: real collaboration is neither purely random </a:t>
-            </a:r>
-            <a:endParaRPr lang="en-US" sz="2400" dirty="0"/>
-          </a:p>
-          <a:p>
-            <a:pPr>
-              <a:defRPr sz="2400"/>
-            </a:pPr>
-            <a:r>
-              <a:rPr sz="2400" dirty="0"/>
-              <a:t>nor purely preferential attachment</a:t>
+            </a:lvl1pPr>
+          </a:lstStyle>
+          <a:p>
+            <a:r>
+              <a:rPr lang="en-US" dirty="0"/>
+              <a:t>Largest 5 Betweenness Centralities:</a:t>
             </a:r>
           </a:p>
         </p:txBody>
       </p:sp>
     </p:spTree>
+    <p:extLst>
+      <p:ext uri="{BB962C8B-B14F-4D97-AF65-F5344CB8AC3E}">
+        <p14:creationId xmlns:p14="http://schemas.microsoft.com/office/powerpoint/2010/main" val="1327103432"/>
+      </p:ext>
+    </p:extLst>
   </p:cSld>
   <p:clrMapOvr>
     <a:masterClrMapping/>
@@ -5287,7 +5561,7 @@
           <p:cNvPr id="2" name="Title 1">
             <a:extLst>
               <a:ext uri="{FF2B5EF4-FFF2-40B4-BE49-F238E27FC236}">
-                <a16:creationId xmlns:a16="http://schemas.microsoft.com/office/drawing/2014/main" id="{FB130DDC-2453-78F8-C678-F51482938D1F}"/>
+                <a16:creationId xmlns:a16="http://schemas.microsoft.com/office/drawing/2014/main" id="{5DC2F755-FA74-89D1-AB53-CBFDF8CB5DEC}"/>
               </a:ext>
             </a:extLst>
           </p:cNvPr>
@@ -5298,161 +5572,137 @@
             <p:ph type="title"/>
           </p:nvPr>
         </p:nvSpPr>
-        <p:spPr/>
+        <p:spPr>
+          <a:xfrm>
+            <a:off x="609600" y="508554"/>
+            <a:ext cx="10972800" cy="1143000"/>
+          </a:xfrm>
+        </p:spPr>
+        <p:txBody>
+          <a:bodyPr>
+            <a:noAutofit/>
+          </a:bodyPr>
+          <a:lstStyle/>
+          <a:p>
+            <a:r>
+              <a:rPr lang="en-US" dirty="0"/>
+              <a:t>What type of network is the selected real network?</a:t>
+            </a:r>
+          </a:p>
+        </p:txBody>
+      </p:sp>
+      <p:sp>
+        <p:nvSpPr>
+          <p:cNvPr id="3" name="Content Placeholder 2">
+            <a:extLst>
+              <a:ext uri="{FF2B5EF4-FFF2-40B4-BE49-F238E27FC236}">
+                <a16:creationId xmlns:a16="http://schemas.microsoft.com/office/drawing/2014/main" id="{53670E19-1A00-7C37-3B63-9C311043CFE5}"/>
+              </a:ext>
+            </a:extLst>
+          </p:cNvPr>
+          <p:cNvSpPr>
+            <a:spLocks noGrp="1"/>
+          </p:cNvSpPr>
+          <p:nvPr>
+            <p:ph idx="1"/>
+          </p:nvPr>
+        </p:nvSpPr>
+        <p:spPr>
+          <a:xfrm>
+            <a:off x="609600" y="1961708"/>
+            <a:ext cx="10972800" cy="4525963"/>
+          </a:xfrm>
+        </p:spPr>
         <p:txBody>
           <a:bodyPr>
             <a:normAutofit/>
           </a:bodyPr>
           <a:lstStyle/>
           <a:p>
-            <a:r>
-              <a:rPr lang="en-US" sz="3600" b="1" dirty="0"/>
-              <a:t>Network Description</a:t>
-            </a:r>
-          </a:p>
-        </p:txBody>
-      </p:sp>
-      <p:sp>
-        <p:nvSpPr>
-          <p:cNvPr id="3" name="Content Placeholder 2">
-            <a:extLst>
-              <a:ext uri="{FF2B5EF4-FFF2-40B4-BE49-F238E27FC236}">
-                <a16:creationId xmlns:a16="http://schemas.microsoft.com/office/drawing/2014/main" id="{6CB4BB62-872C-8532-AE7B-F4092C482C11}"/>
-              </a:ext>
-            </a:extLst>
-          </p:cNvPr>
-          <p:cNvSpPr>
-            <a:spLocks noGrp="1"/>
-          </p:cNvSpPr>
-          <p:nvPr>
-            <p:ph idx="1"/>
-          </p:nvPr>
-        </p:nvSpPr>
-        <p:spPr/>
-        <p:txBody>
-          <a:bodyPr>
-            <a:normAutofit lnSpcReduction="10000"/>
-          </a:bodyPr>
-          <a:lstStyle/>
-          <a:p>
             <a:pPr marL="0" indent="0">
               <a:buNone/>
-              <a:defRPr sz="2400"/>
             </a:pPr>
             <a:r>
-              <a:rPr lang="en-US" sz="2400" b="1" dirty="0"/>
-              <a:t>dimacs10-netscience (co-authorship network)</a:t>
-            </a:r>
-          </a:p>
-          <a:p>
-            <a:pPr>
-              <a:defRPr sz="2400"/>
+              <a:rPr lang="en-US" sz="2000" dirty="0"/>
+              <a:t>It is a </a:t>
+            </a:r>
+            <a:r>
+              <a:rPr lang="en-US" sz="2000" b="1" dirty="0"/>
+              <a:t>Co-authorship/Collaboration Network</a:t>
+            </a:r>
+            <a:r>
+              <a:rPr lang="en-US" sz="2000" dirty="0"/>
+              <a:t>. </a:t>
+            </a:r>
+          </a:p>
+          <a:p>
+            <a:pPr marL="0" indent="0">
+              <a:buNone/>
             </a:pPr>
             <a:r>
               <a:rPr lang="en-US" sz="2000" dirty="0"/>
-              <a:t>Nodes (authors): 1461</a:t>
-            </a:r>
-          </a:p>
-          <a:p>
-            <a:pPr>
-              <a:defRPr sz="2400"/>
-            </a:pPr>
-            <a:r>
-              <a:rPr lang="en-US" sz="2000" dirty="0"/>
-              <a:t>Edges (co-authorship links): 2742</a:t>
-            </a:r>
-          </a:p>
-          <a:p>
-            <a:pPr>
-              <a:defRPr sz="2400"/>
-            </a:pPr>
-            <a:r>
-              <a:rPr lang="en-US" sz="2000" dirty="0"/>
-              <a:t>Graph type: undirected, unweighted, no self-loops</a:t>
-            </a:r>
-          </a:p>
-          <a:p>
-            <a:pPr>
-              <a:defRPr sz="2400"/>
+              <a:t>Reflects human collaboration and distinct research communities.</a:t>
+            </a:r>
+          </a:p>
+          <a:p>
+            <a:pPr marL="0" indent="0">
+              <a:buNone/>
             </a:pPr>
             <a:endParaRPr lang="en-US" sz="2000" dirty="0"/>
           </a:p>
           <a:p>
             <a:pPr marL="0" indent="0">
               <a:buNone/>
-              <a:defRPr sz="2400"/>
             </a:pPr>
             <a:r>
-              <a:rPr lang="en-US" sz="2400" b="1" dirty="0"/>
-              <a:t>Random Network: Erdos-</a:t>
-            </a:r>
-            <a:r>
-              <a:rPr lang="en-US" sz="2400" b="1" dirty="0" err="1"/>
-              <a:t>Renyi</a:t>
-            </a:r>
-            <a:r>
-              <a:rPr lang="en-US" sz="2400" b="1" dirty="0"/>
-              <a:t> model</a:t>
-            </a:r>
-          </a:p>
-          <a:p>
-            <a:pPr>
-              <a:defRPr sz="2400"/>
-            </a:pPr>
+              <a:rPr lang="en-US" sz="2000" b="1" dirty="0"/>
+              <a:t>Small-World properties: </a:t>
+            </a:r>
             <a:r>
               <a:rPr lang="en-US" sz="2000" dirty="0"/>
-              <a:t>Nodes: 1461</a:t>
-            </a:r>
-          </a:p>
-          <a:p>
-            <a:pPr>
-              <a:defRPr sz="2400"/>
-            </a:pPr>
-            <a:r>
-              <a:rPr lang="en-US" sz="2000" dirty="0"/>
-              <a:t>Edges: 2728</a:t>
-            </a:r>
-          </a:p>
-          <a:p>
-            <a:pPr>
-              <a:defRPr sz="2400"/>
+              <a:t>a high clustering coefficient, as co-authors of a researcher are very likely to co-author with each other.</a:t>
+            </a:r>
+          </a:p>
+          <a:p>
+            <a:pPr marL="0" indent="0">
+              <a:buNone/>
             </a:pPr>
             <a:endParaRPr lang="en-US" sz="2000" dirty="0"/>
           </a:p>
           <a:p>
             <a:pPr marL="0" indent="0">
               <a:buNone/>
-              <a:defRPr sz="2400"/>
             </a:pPr>
             <a:r>
-              <a:rPr lang="en-US" sz="2400" b="1" dirty="0"/>
-              <a:t>Scale-free Network: </a:t>
-            </a:r>
-            <a:r>
-              <a:rPr lang="en-US" sz="2400" b="1" dirty="0" err="1"/>
-              <a:t>Barabasi</a:t>
-            </a:r>
-            <a:r>
-              <a:rPr lang="en-US" sz="2400" b="1" dirty="0"/>
-              <a:t>-Albert model</a:t>
-            </a:r>
-          </a:p>
-          <a:p>
-            <a:pPr>
-              <a:defRPr sz="2400"/>
+              <a:rPr lang="en-US" sz="2000" b="1" dirty="0"/>
+              <a:t>Scale-Free characteristics: </a:t>
+            </a:r>
+            <a:r>
+              <a:rPr lang="en-US" sz="2000" dirty="0"/>
+              <a:t>a heavy-tailed degree distribution where a few highly published researchers act as massive hubs.</a:t>
+            </a:r>
+          </a:p>
+          <a:p>
+            <a:pPr marL="0" indent="0">
+              <a:buNone/>
             </a:pPr>
+            <a:endParaRPr lang="en-US" sz="2000" dirty="0"/>
+          </a:p>
+          <a:p>
+            <a:pPr marL="0" indent="0">
+              <a:buNone/>
+            </a:pPr>
             <a:r>
               <a:rPr lang="en-US" sz="2000" dirty="0"/>
-              <a:t>Nodes: 1461</a:t>
-            </a:r>
-          </a:p>
-          <a:p>
-            <a:pPr>
-              <a:defRPr sz="2400"/>
-            </a:pPr>
+              <a:t>These observations are made relative to the metrics of the Erdős-Rényi and </a:t>
+            </a:r>
+            <a:r>
+              <a:rPr lang="en-US" sz="2000" dirty="0" err="1"/>
+              <a:t>Barabási</a:t>
+            </a:r>
             <a:r>
               <a:rPr lang="en-US" sz="2000" dirty="0"/>
-              <a:t>Edges: 2918</a:t>
+              <a:t>-Albert models.</a:t>
             </a:r>
           </a:p>
         </p:txBody>
@@ -5460,7 +5710,7 @@
     </p:spTree>
     <p:extLst>
       <p:ext uri="{BB962C8B-B14F-4D97-AF65-F5344CB8AC3E}">
-        <p14:creationId xmlns:p14="http://schemas.microsoft.com/office/powerpoint/2010/main" val="2281326393"/>
+        <p14:creationId xmlns:p14="http://schemas.microsoft.com/office/powerpoint/2010/main" val="978290815"/>
       </p:ext>
     </p:extLst>
   </p:cSld>
@@ -5475,7 +5725,13 @@
   <p:cSld>
     <p:spTree>
       <p:nvGrpSpPr>
-        <p:cNvPr id="1" name=""/>
+        <p:cNvPr id="1" name="">
+          <a:extLst>
+            <a:ext uri="{FF2B5EF4-FFF2-40B4-BE49-F238E27FC236}">
+              <a16:creationId xmlns:a16="http://schemas.microsoft.com/office/drawing/2014/main" id="{F6688009-40F2-7E3A-2475-0FE2EF3BD0DD}"/>
+            </a:ext>
+          </a:extLst>
+        </p:cNvPr>
         <p:cNvGrpSpPr/>
         <p:nvPr/>
       </p:nvGrpSpPr>
@@ -5492,7 +5748,7 @@
           <p:cNvPr id="2" name="Title 1">
             <a:extLst>
               <a:ext uri="{FF2B5EF4-FFF2-40B4-BE49-F238E27FC236}">
-                <a16:creationId xmlns:a16="http://schemas.microsoft.com/office/drawing/2014/main" id="{A3CA0CB8-73ED-02B6-1533-4A33527E686C}"/>
+                <a16:creationId xmlns:a16="http://schemas.microsoft.com/office/drawing/2014/main" id="{BBC849A9-A580-2283-28E0-CC259F2FB55A}"/>
               </a:ext>
             </a:extLst>
           </p:cNvPr>
@@ -5503,7 +5759,12 @@
             <p:ph type="title"/>
           </p:nvPr>
         </p:nvSpPr>
-        <p:spPr/>
+        <p:spPr>
+          <a:xfrm>
+            <a:off x="609600" y="2857500"/>
+            <a:ext cx="10972800" cy="1143000"/>
+          </a:xfrm>
+        </p:spPr>
         <p:txBody>
           <a:bodyPr>
             <a:normAutofit/>
@@ -5511,544 +5772,16 @@
           <a:lstStyle/>
           <a:p>
             <a:r>
-              <a:rPr lang="en-US" sz="3600" b="1" dirty="0"/>
-              <a:t>Network Properties</a:t>
-            </a:r>
-          </a:p>
-        </p:txBody>
-      </p:sp>
-      <p:graphicFrame>
-        <p:nvGraphicFramePr>
-          <p:cNvPr id="5" name="Table 4">
-            <a:extLst>
-              <a:ext uri="{FF2B5EF4-FFF2-40B4-BE49-F238E27FC236}">
-                <a16:creationId xmlns:a16="http://schemas.microsoft.com/office/drawing/2014/main" id="{8902F6E5-D50D-156C-6973-88B90B218EE6}"/>
-              </a:ext>
-            </a:extLst>
-          </p:cNvPr>
-          <p:cNvGraphicFramePr>
-            <a:graphicFrameLocks noGrp="1"/>
-          </p:cNvGraphicFramePr>
-          <p:nvPr>
-            <p:extLst>
-              <p:ext uri="{D42A27DB-BD31-4B8C-83A1-F6EECF244321}">
-                <p14:modId xmlns:p14="http://schemas.microsoft.com/office/powerpoint/2010/main" val="2179173524"/>
-              </p:ext>
-            </p:extLst>
-          </p:nvPr>
-        </p:nvGraphicFramePr>
-        <p:xfrm>
-          <a:off x="1595025" y="2048958"/>
-          <a:ext cx="9001949" cy="2765637"/>
-        </p:xfrm>
-        <a:graphic>
-          <a:graphicData uri="http://schemas.openxmlformats.org/drawingml/2006/table">
-            <a:tbl>
-              <a:tblPr firstRow="1" bandRow="1">
-                <a:tableStyleId>{5C22544A-7EE6-4342-B048-85BDC9FD1C3A}</a:tableStyleId>
-              </a:tblPr>
-              <a:tblGrid>
-                <a:gridCol w="3281297">
-                  <a:extLst>
-                    <a:ext uri="{9D8B030D-6E8A-4147-A177-3AD203B41FA5}">
-                      <a16:colId xmlns:a16="http://schemas.microsoft.com/office/drawing/2014/main" val="3737601808"/>
-                    </a:ext>
-                  </a:extLst>
-                </a:gridCol>
-                <a:gridCol w="1827213">
-                  <a:extLst>
-                    <a:ext uri="{9D8B030D-6E8A-4147-A177-3AD203B41FA5}">
-                      <a16:colId xmlns:a16="http://schemas.microsoft.com/office/drawing/2014/main" val="2060914983"/>
-                    </a:ext>
-                  </a:extLst>
-                </a:gridCol>
-                <a:gridCol w="1876425">
-                  <a:extLst>
-                    <a:ext uri="{9D8B030D-6E8A-4147-A177-3AD203B41FA5}">
-                      <a16:colId xmlns:a16="http://schemas.microsoft.com/office/drawing/2014/main" val="1384432102"/>
-                    </a:ext>
-                  </a:extLst>
-                </a:gridCol>
-                <a:gridCol w="2017014">
-                  <a:extLst>
-                    <a:ext uri="{9D8B030D-6E8A-4147-A177-3AD203B41FA5}">
-                      <a16:colId xmlns:a16="http://schemas.microsoft.com/office/drawing/2014/main" val="1731971228"/>
-                    </a:ext>
-                  </a:extLst>
-                </a:gridCol>
-              </a:tblGrid>
-              <a:tr h="388197">
-                <a:tc>
-                  <a:txBody>
-                    <a:bodyPr/>
-                    <a:lstStyle/>
-                    <a:p>
-                      <a:endParaRPr lang="en-US"/>
-                    </a:p>
-                  </a:txBody>
-                  <a:tcPr/>
-                </a:tc>
-                <a:tc>
-                  <a:txBody>
-                    <a:bodyPr/>
-                    <a:lstStyle/>
-                    <a:p>
-                      <a:r>
-                        <a:rPr lang="en-US" dirty="0"/>
-                        <a:t>Real network</a:t>
-                      </a:r>
-                    </a:p>
-                  </a:txBody>
-                  <a:tcPr/>
-                </a:tc>
-                <a:tc>
-                  <a:txBody>
-                    <a:bodyPr/>
-                    <a:lstStyle/>
-                    <a:p>
-                      <a:r>
-                        <a:rPr lang="en-US" dirty="0"/>
-                        <a:t>Random network</a:t>
-                      </a:r>
-                    </a:p>
-                  </a:txBody>
-                  <a:tcPr/>
-                </a:tc>
-                <a:tc>
-                  <a:txBody>
-                    <a:bodyPr/>
-                    <a:lstStyle/>
-                    <a:p>
-                      <a:r>
-                        <a:rPr lang="en-US" dirty="0"/>
-                        <a:t>Scale-free network</a:t>
-                      </a:r>
-                    </a:p>
-                  </a:txBody>
-                  <a:tcPr/>
-                </a:tc>
-                <a:extLst>
-                  <a:ext uri="{0D108BD9-81ED-4DB2-BD59-A6C34878D82A}">
-                    <a16:rowId xmlns:a16="http://schemas.microsoft.com/office/drawing/2014/main" val="2364562667"/>
-                  </a:ext>
-                </a:extLst>
-              </a:tr>
-              <a:tr h="388197">
-                <a:tc>
-                  <a:txBody>
-                    <a:bodyPr/>
-                    <a:lstStyle/>
-                    <a:p>
-                      <a:r>
-                        <a:rPr lang="en-US" sz="2000" dirty="0"/>
-                        <a:t>Min/Max/Average Degree</a:t>
-                      </a:r>
-                    </a:p>
-                  </a:txBody>
-                  <a:tcPr/>
-                </a:tc>
-                <a:tc>
-                  <a:txBody>
-                    <a:bodyPr/>
-                    <a:lstStyle/>
-                    <a:p>
-                      <a:r>
-                        <a:rPr lang="en-US" sz="2000" dirty="0"/>
-                        <a:t>1 / 34 / 3.75</a:t>
-                      </a:r>
-                    </a:p>
-                  </a:txBody>
-                  <a:tcPr/>
-                </a:tc>
-                <a:tc>
-                  <a:txBody>
-                    <a:bodyPr/>
-                    <a:lstStyle/>
-                    <a:p>
-                      <a:r>
-                        <a:rPr lang="en-US" sz="2000" dirty="0"/>
-                        <a:t>0 / 12 / 3.73</a:t>
-                      </a:r>
-                    </a:p>
-                  </a:txBody>
-                  <a:tcPr/>
-                </a:tc>
-                <a:tc>
-                  <a:txBody>
-                    <a:bodyPr/>
-                    <a:lstStyle/>
-                    <a:p>
-                      <a:r>
-                        <a:rPr lang="en-US" sz="2000" dirty="0"/>
-                        <a:t>2 / 103 / 3.99</a:t>
-                      </a:r>
-                    </a:p>
-                  </a:txBody>
-                  <a:tcPr/>
-                </a:tc>
-                <a:extLst>
-                  <a:ext uri="{0D108BD9-81ED-4DB2-BD59-A6C34878D82A}">
-                    <a16:rowId xmlns:a16="http://schemas.microsoft.com/office/drawing/2014/main" val="2366982699"/>
-                  </a:ext>
-                </a:extLst>
-              </a:tr>
-              <a:tr h="388197">
-                <a:tc>
-                  <a:txBody>
-                    <a:bodyPr/>
-                    <a:lstStyle/>
-                    <a:p>
-                      <a:r>
-                        <a:rPr lang="en-US" sz="2000" dirty="0"/>
-                        <a:t>Diameter</a:t>
-                      </a:r>
-                    </a:p>
-                  </a:txBody>
-                  <a:tcPr/>
-                </a:tc>
-                <a:tc>
-                  <a:txBody>
-                    <a:bodyPr/>
-                    <a:lstStyle/>
-                    <a:p>
-                      <a:r>
-                        <a:rPr lang="en-US" sz="2000" dirty="0"/>
-                        <a:t>17</a:t>
-                      </a:r>
-                    </a:p>
-                  </a:txBody>
-                  <a:tcPr/>
-                </a:tc>
-                <a:tc>
-                  <a:txBody>
-                    <a:bodyPr/>
-                    <a:lstStyle/>
-                    <a:p>
-                      <a:r>
-                        <a:rPr lang="en-US" sz="2000" dirty="0"/>
-                        <a:t>12</a:t>
-                      </a:r>
-                    </a:p>
-                  </a:txBody>
-                  <a:tcPr/>
-                </a:tc>
-                <a:tc>
-                  <a:txBody>
-                    <a:bodyPr/>
-                    <a:lstStyle/>
-                    <a:p>
-                      <a:r>
-                        <a:rPr lang="en-US" sz="2000" dirty="0"/>
-                        <a:t>8</a:t>
-                      </a:r>
-                    </a:p>
-                  </a:txBody>
-                  <a:tcPr/>
-                </a:tc>
-                <a:extLst>
-                  <a:ext uri="{0D108BD9-81ED-4DB2-BD59-A6C34878D82A}">
-                    <a16:rowId xmlns:a16="http://schemas.microsoft.com/office/drawing/2014/main" val="533775939"/>
-                  </a:ext>
-                </a:extLst>
-              </a:tr>
-              <a:tr h="388197">
-                <a:tc>
-                  <a:txBody>
-                    <a:bodyPr/>
-                    <a:lstStyle/>
-                    <a:p>
-                      <a:r>
-                        <a:rPr lang="en-US" sz="2000" dirty="0"/>
-                        <a:t>Connected Components</a:t>
-                      </a:r>
-                    </a:p>
-                  </a:txBody>
-                  <a:tcPr/>
-                </a:tc>
-                <a:tc>
-                  <a:txBody>
-                    <a:bodyPr/>
-                    <a:lstStyle/>
-                    <a:p>
-                      <a:r>
-                        <a:rPr lang="en-US" sz="2000" dirty="0"/>
-                        <a:t>268</a:t>
-                      </a:r>
-                    </a:p>
-                  </a:txBody>
-                  <a:tcPr/>
-                </a:tc>
-                <a:tc>
-                  <a:txBody>
-                    <a:bodyPr/>
-                    <a:lstStyle/>
-                    <a:p>
-                      <a:r>
-                        <a:rPr lang="en-US" sz="2000" dirty="0"/>
-                        <a:t>46</a:t>
-                      </a:r>
-                    </a:p>
-                  </a:txBody>
-                  <a:tcPr/>
-                </a:tc>
-                <a:tc>
-                  <a:txBody>
-                    <a:bodyPr/>
-                    <a:lstStyle/>
-                    <a:p>
-                      <a:r>
-                        <a:rPr lang="en-US" sz="2000" dirty="0"/>
-                        <a:t>1</a:t>
-                      </a:r>
-                    </a:p>
-                  </a:txBody>
-                  <a:tcPr/>
-                </a:tc>
-                <a:extLst>
-                  <a:ext uri="{0D108BD9-81ED-4DB2-BD59-A6C34878D82A}">
-                    <a16:rowId xmlns:a16="http://schemas.microsoft.com/office/drawing/2014/main" val="2894749781"/>
-                  </a:ext>
-                </a:extLst>
-              </a:tr>
-              <a:tr h="388197">
-                <a:tc>
-                  <a:txBody>
-                    <a:bodyPr/>
-                    <a:lstStyle/>
-                    <a:p>
-                      <a:r>
-                        <a:rPr lang="en-US" sz="2000" dirty="0"/>
-                        <a:t>Largest Component Size</a:t>
-                      </a:r>
-                    </a:p>
-                  </a:txBody>
-                  <a:tcPr/>
-                </a:tc>
-                <a:tc>
-                  <a:txBody>
-                    <a:bodyPr/>
-                    <a:lstStyle/>
-                    <a:p>
-                      <a:r>
-                        <a:rPr lang="en-US" sz="2000" dirty="0"/>
-                        <a:t>379</a:t>
-                      </a:r>
-                    </a:p>
-                  </a:txBody>
-                  <a:tcPr/>
-                </a:tc>
-                <a:tc>
-                  <a:txBody>
-                    <a:bodyPr/>
-                    <a:lstStyle/>
-                    <a:p>
-                      <a:r>
-                        <a:rPr lang="en-US" sz="2000" dirty="0"/>
-                        <a:t>1415</a:t>
-                      </a:r>
-                    </a:p>
-                  </a:txBody>
-                  <a:tcPr/>
-                </a:tc>
-                <a:tc>
-                  <a:txBody>
-                    <a:bodyPr/>
-                    <a:lstStyle/>
-                    <a:p>
-                      <a:r>
-                        <a:rPr lang="en-US" sz="2000" dirty="0"/>
-                        <a:t>1461</a:t>
-                      </a:r>
-                    </a:p>
-                  </a:txBody>
-                  <a:tcPr/>
-                </a:tc>
-                <a:extLst>
-                  <a:ext uri="{0D108BD9-81ED-4DB2-BD59-A6C34878D82A}">
-                    <a16:rowId xmlns:a16="http://schemas.microsoft.com/office/drawing/2014/main" val="951618927"/>
-                  </a:ext>
-                </a:extLst>
-              </a:tr>
-              <a:tr h="388197">
-                <a:tc>
-                  <a:txBody>
-                    <a:bodyPr/>
-                    <a:lstStyle/>
-                    <a:p>
-                      <a:r>
-                        <a:rPr lang="en-US" sz="2000" dirty="0"/>
-                        <a:t>Average shortest path</a:t>
-                      </a:r>
-                    </a:p>
-                  </a:txBody>
-                  <a:tcPr/>
-                </a:tc>
-                <a:tc>
-                  <a:txBody>
-                    <a:bodyPr/>
-                    <a:lstStyle/>
-                    <a:p>
-                      <a:r>
-                        <a:rPr lang="en-US" sz="2000" b="0" i="0" kern="1200" dirty="0">
-                          <a:solidFill>
-                            <a:schemeClr val="dk1"/>
-                          </a:solidFill>
-                          <a:effectLst/>
-                          <a:latin typeface="+mn-lt"/>
-                          <a:ea typeface="+mn-ea"/>
-                          <a:cs typeface="+mn-cs"/>
-                        </a:rPr>
-                        <a:t>6.04</a:t>
-                      </a:r>
-                      <a:endParaRPr lang="en-US" sz="2000" dirty="0"/>
-                    </a:p>
-                  </a:txBody>
-                  <a:tcPr/>
-                </a:tc>
-                <a:tc>
-                  <a:txBody>
-                    <a:bodyPr/>
-                    <a:lstStyle/>
-                    <a:p>
-                      <a:r>
-                        <a:rPr lang="en-US" sz="2000" b="0" i="0" kern="1200" dirty="0">
-                          <a:solidFill>
-                            <a:schemeClr val="dk1"/>
-                          </a:solidFill>
-                          <a:effectLst/>
-                          <a:latin typeface="+mn-lt"/>
-                          <a:ea typeface="+mn-ea"/>
-                          <a:cs typeface="+mn-cs"/>
-                        </a:rPr>
-                        <a:t>5.59</a:t>
-                      </a:r>
-                      <a:endParaRPr lang="en-US" sz="2000" dirty="0"/>
-                    </a:p>
-                  </a:txBody>
-                  <a:tcPr/>
-                </a:tc>
-                <a:tc>
-                  <a:txBody>
-                    <a:bodyPr/>
-                    <a:lstStyle/>
-                    <a:p>
-                      <a:r>
-                        <a:rPr lang="en-US" sz="2000" b="0" i="0" kern="1200" dirty="0">
-                          <a:solidFill>
-                            <a:schemeClr val="dk1"/>
-                          </a:solidFill>
-                          <a:effectLst/>
-                          <a:latin typeface="+mn-lt"/>
-                          <a:ea typeface="+mn-ea"/>
-                          <a:cs typeface="+mn-cs"/>
-                        </a:rPr>
-                        <a:t>4.24</a:t>
-                      </a:r>
-                      <a:endParaRPr lang="en-US" sz="2000" dirty="0"/>
-                    </a:p>
-                  </a:txBody>
-                  <a:tcPr/>
-                </a:tc>
-                <a:extLst>
-                  <a:ext uri="{0D108BD9-81ED-4DB2-BD59-A6C34878D82A}">
-                    <a16:rowId xmlns:a16="http://schemas.microsoft.com/office/drawing/2014/main" val="3568186649"/>
-                  </a:ext>
-                </a:extLst>
-              </a:tr>
-              <a:tr h="388197">
-                <a:tc>
-                  <a:txBody>
-                    <a:bodyPr/>
-                    <a:lstStyle/>
-                    <a:p>
-                      <a:r>
-                        <a:rPr lang="en-US" sz="2000" dirty="0"/>
-                        <a:t>Average clustering coefficient</a:t>
-                      </a:r>
-                    </a:p>
-                  </a:txBody>
-                  <a:tcPr/>
-                </a:tc>
-                <a:tc>
-                  <a:txBody>
-                    <a:bodyPr/>
-                    <a:lstStyle/>
-                    <a:p>
-                      <a:r>
-                        <a:rPr lang="en-US" sz="2000" b="0" i="0" kern="1200" dirty="0">
-                          <a:solidFill>
-                            <a:schemeClr val="dk1"/>
-                          </a:solidFill>
-                          <a:effectLst/>
-                          <a:latin typeface="+mn-lt"/>
-                          <a:ea typeface="+mn-ea"/>
-                          <a:cs typeface="+mn-cs"/>
-                        </a:rPr>
-                        <a:t>0.69</a:t>
-                      </a:r>
-                      <a:endParaRPr lang="en-US" sz="2000" dirty="0"/>
-                    </a:p>
-                  </a:txBody>
-                  <a:tcPr/>
-                </a:tc>
-                <a:tc>
-                  <a:txBody>
-                    <a:bodyPr/>
-                    <a:lstStyle/>
-                    <a:p>
-                      <a:r>
-                        <a:rPr lang="en-US" sz="2000" b="0" i="0" kern="1200" dirty="0">
-                          <a:solidFill>
-                            <a:schemeClr val="dk1"/>
-                          </a:solidFill>
-                          <a:effectLst/>
-                          <a:latin typeface="+mn-lt"/>
-                          <a:ea typeface="+mn-ea"/>
-                          <a:cs typeface="+mn-cs"/>
-                        </a:rPr>
-                        <a:t>0.004</a:t>
-                      </a:r>
-                      <a:endParaRPr lang="en-US" sz="2000" dirty="0"/>
-                    </a:p>
-                  </a:txBody>
-                  <a:tcPr/>
-                </a:tc>
-                <a:tc>
-                  <a:txBody>
-                    <a:bodyPr/>
-                    <a:lstStyle/>
-                    <a:p>
-                      <a:r>
-                        <a:rPr lang="en-US" sz="2000" b="0" i="0" kern="1200" dirty="0">
-                          <a:solidFill>
-                            <a:schemeClr val="dk1"/>
-                          </a:solidFill>
-                          <a:effectLst/>
-                          <a:latin typeface="+mn-lt"/>
-                          <a:ea typeface="+mn-ea"/>
-                          <a:cs typeface="+mn-cs"/>
-                        </a:rPr>
-                        <a:t>0.02</a:t>
-                      </a:r>
-                      <a:endParaRPr lang="en-US" sz="2000" dirty="0"/>
-                    </a:p>
-                  </a:txBody>
-                  <a:tcPr/>
-                </a:tc>
-                <a:extLst>
-                  <a:ext uri="{0D108BD9-81ED-4DB2-BD59-A6C34878D82A}">
-                    <a16:rowId xmlns:a16="http://schemas.microsoft.com/office/drawing/2014/main" val="1790762521"/>
-                  </a:ext>
-                </a:extLst>
-              </a:tr>
-            </a:tbl>
-          </a:graphicData>
-        </a:graphic>
-      </p:graphicFrame>
+              <a:rPr lang="en-US" b="1" dirty="0"/>
+              <a:t>Thank you!</a:t>
+            </a:r>
+          </a:p>
+        </p:txBody>
+      </p:sp>
     </p:spTree>
     <p:extLst>
       <p:ext uri="{BB962C8B-B14F-4D97-AF65-F5344CB8AC3E}">
-        <p14:creationId xmlns:p14="http://schemas.microsoft.com/office/powerpoint/2010/main" val="3892594497"/>
+        <p14:creationId xmlns:p14="http://schemas.microsoft.com/office/powerpoint/2010/main" val="3662256073"/>
       </p:ext>
     </p:extLst>
   </p:cSld>

</xml_diff>